<commit_message>
fix on pltl slides
</commit_message>
<xml_diff>
--- a/slides/PV_pmc.pptx
+++ b/slides/PV_pmc.pptx
@@ -16736,9 +16736,9 @@
             <a:avLst/>
           </a:prstGeom>
           <a:solidFill>
-            <a:schemeClr val="accent4">
-              <a:lumMod val="40000"/>
-              <a:lumOff val="60000"/>
+            <a:schemeClr val="accent2">
+              <a:lumMod val="20000"/>
+              <a:lumOff val="80000"/>
             </a:schemeClr>
           </a:solidFill>
           <a:ln w="34925" cmpd="dbl">
@@ -16995,18 +16995,20 @@
           <p:cNvCxnSpPr>
             <a:cxnSpLocks/>
             <a:stCxn id="10" idx="5"/>
-            <a:endCxn id="10" idx="3"/>
+            <a:endCxn id="10" idx="7"/>
           </p:cNvCxnSpPr>
           <p:nvPr/>
         </p:nvCxnSpPr>
         <p:spPr>
-          <a:xfrm rot="5400000">
-            <a:off x="7188901" y="4219228"/>
-            <a:ext cx="12700" cy="251448"/>
+          <a:xfrm rot="5400000" flipH="1">
+            <a:off x="7194888" y="4225215"/>
+            <a:ext cx="239474" cy="12700"/>
           </a:xfrm>
-          <a:prstGeom prst="curvedConnector3">
+          <a:prstGeom prst="curvedConnector5">
             <a:avLst>
-              <a:gd name="adj1" fmla="val 2190520"/>
+              <a:gd name="adj1" fmla="val -28284"/>
+              <a:gd name="adj2" fmla="val -2856622"/>
+              <a:gd name="adj3" fmla="val 153032"/>
             </a:avLst>
           </a:prstGeom>
           <a:ln w="12700">
@@ -17124,8 +17126,8 @@
         </p:nvSpPr>
         <p:spPr>
           <a:xfrm>
-            <a:off x="5306359" y="4580481"/>
-            <a:ext cx="551754" cy="307777"/>
+            <a:off x="4451750" y="4551608"/>
+            <a:ext cx="1426994" cy="307777"/>
           </a:xfrm>
           <a:prstGeom prst="rect">
             <a:avLst/>
@@ -17140,7 +17142,7 @@
           <a:p>
             <a:r>
               <a:rPr lang="en-NL" sz="1400" dirty="0"/>
-              <a:t>{try} </a:t>
+              <a:t>try∈ and succ∉ </a:t>
             </a:r>
           </a:p>
         </p:txBody>
@@ -17160,7 +17162,7 @@
         <p:spPr>
           <a:xfrm>
             <a:off x="5986054" y="3908741"/>
-            <a:ext cx="671979" cy="307777"/>
+            <a:ext cx="715260" cy="307777"/>
           </a:xfrm>
           <a:prstGeom prst="rect">
             <a:avLst/>
@@ -17175,77 +17177,7 @@
           <a:p>
             <a:r>
               <a:rPr lang="en-NL" sz="1400" dirty="0"/>
-              <a:t>{succ}</a:t>
-            </a:r>
-          </a:p>
-        </p:txBody>
-      </p:sp>
-      <p:sp>
-        <p:nvSpPr>
-          <p:cNvPr id="34" name="TextBox 33">
-            <a:extLst>
-              <a:ext uri="{FF2B5EF4-FFF2-40B4-BE49-F238E27FC236}">
-                <a16:creationId xmlns:a16="http://schemas.microsoft.com/office/drawing/2014/main" id="{D60E518E-2C4D-3AC7-79B8-9A05A0E583CF}"/>
-              </a:ext>
-            </a:extLst>
-          </p:cNvPr>
-          <p:cNvSpPr txBox="1"/>
-          <p:nvPr/>
-        </p:nvSpPr>
-        <p:spPr>
-          <a:xfrm>
-            <a:off x="5839012" y="3696774"/>
-            <a:ext cx="956800" cy="307777"/>
-          </a:xfrm>
-          <a:prstGeom prst="rect">
-            <a:avLst/>
-          </a:prstGeom>
-          <a:noFill/>
-        </p:spPr>
-        <p:txBody>
-          <a:bodyPr wrap="none" rtlCol="0">
-            <a:spAutoFit/>
-          </a:bodyPr>
-          <a:lstStyle/>
-          <a:p>
-            <a:r>
-              <a:rPr lang="en-NL" sz="1400" dirty="0"/>
-              <a:t>{try, succ}</a:t>
-            </a:r>
-          </a:p>
-        </p:txBody>
-      </p:sp>
-      <p:sp>
-        <p:nvSpPr>
-          <p:cNvPr id="35" name="TextBox 34">
-            <a:extLst>
-              <a:ext uri="{FF2B5EF4-FFF2-40B4-BE49-F238E27FC236}">
-                <a16:creationId xmlns:a16="http://schemas.microsoft.com/office/drawing/2014/main" id="{37753457-DE77-4284-D949-DDE684DD9999}"/>
-              </a:ext>
-            </a:extLst>
-          </p:cNvPr>
-          <p:cNvSpPr txBox="1"/>
-          <p:nvPr/>
-        </p:nvSpPr>
-        <p:spPr>
-          <a:xfrm>
-            <a:off x="7252347" y="4323228"/>
-            <a:ext cx="274434" cy="369332"/>
-          </a:xfrm>
-          <a:prstGeom prst="rect">
-            <a:avLst/>
-          </a:prstGeom>
-          <a:noFill/>
-        </p:spPr>
-        <p:txBody>
-          <a:bodyPr wrap="none" rtlCol="0">
-            <a:spAutoFit/>
-          </a:bodyPr>
-          <a:lstStyle/>
-          <a:p>
-            <a:r>
-              <a:rPr lang="en-NL" dirty="0"/>
-              <a:t>*</a:t>
+              <a:t>succ ∈</a:t>
             </a:r>
           </a:p>
         </p:txBody>
@@ -17265,7 +17197,7 @@
         <p:spPr>
           <a:xfrm>
             <a:off x="3992548" y="5074062"/>
-            <a:ext cx="4865732" cy="923330"/>
+            <a:ext cx="4865732" cy="646331"/>
           </a:xfrm>
           <a:prstGeom prst="rect">
             <a:avLst/>
@@ -17280,15 +17212,7 @@
           <a:p>
             <a:r>
               <a:rPr lang="en-NL" dirty="0"/>
-              <a:t>Well, this Buchi is </a:t>
-            </a:r>
-            <a:r>
-              <a:rPr lang="en-NL" b="1" dirty="0"/>
-              <a:t>deterministic</a:t>
-            </a:r>
-            <a:r>
-              <a:rPr lang="en-NL" dirty="0"/>
-              <a:t>, so it is also a Rabin with accenting condition: { (L,K) } with L=∅ and K={v,w}</a:t>
+              <a:t>with accepting condition: { (L,K) } with L={v} and K={w}</a:t>
             </a:r>
           </a:p>
         </p:txBody>
@@ -17343,7 +17267,7 @@
         <p:spPr>
           <a:xfrm>
             <a:off x="4234090" y="2524609"/>
-            <a:ext cx="4358111" cy="923330"/>
+            <a:ext cx="4527821" cy="646331"/>
           </a:xfrm>
           <a:prstGeom prst="rect">
             <a:avLst/>
@@ -17358,7 +17282,7 @@
           <a:p>
             <a:r>
               <a:rPr lang="en-NL" dirty="0"/>
-              <a:t>First, we construct a Rabin automaton that equivalently describes 𝜑. Below I give a Buchi: </a:t>
+              <a:t>First, we construct a deterministic Rabin automaton that equivalently describes 𝜑 : </a:t>
             </a:r>
           </a:p>
         </p:txBody>
@@ -17394,6 +17318,124 @@
             <a:r>
               <a:rPr lang="en-NL" dirty="0"/>
               <a:t>R:</a:t>
+            </a:r>
+          </a:p>
+        </p:txBody>
+      </p:sp>
+      <p:cxnSp>
+        <p:nvCxnSpPr>
+          <p:cNvPr id="42" name="Curved Connector 41">
+            <a:extLst>
+              <a:ext uri="{FF2B5EF4-FFF2-40B4-BE49-F238E27FC236}">
+                <a16:creationId xmlns:a16="http://schemas.microsoft.com/office/drawing/2014/main" id="{0032B207-EFC5-6EF3-46FE-119CCCD8E7A8}"/>
+              </a:ext>
+            </a:extLst>
+          </p:cNvPr>
+          <p:cNvCxnSpPr>
+            <a:cxnSpLocks/>
+            <a:stCxn id="10" idx="3"/>
+            <a:endCxn id="9" idx="5"/>
+          </p:cNvCxnSpPr>
+          <p:nvPr/>
+        </p:nvCxnSpPr>
+        <p:spPr>
+          <a:xfrm rot="5400000" flipH="1">
+            <a:off x="6377214" y="3658989"/>
+            <a:ext cx="10360" cy="1361567"/>
+          </a:xfrm>
+          <a:prstGeom prst="curvedConnector3">
+            <a:avLst>
+              <a:gd name="adj1" fmla="val -2685290"/>
+            </a:avLst>
+          </a:prstGeom>
+          <a:ln w="12700">
+            <a:solidFill>
+              <a:schemeClr val="tx1"/>
+            </a:solidFill>
+            <a:tailEnd type="triangle"/>
+          </a:ln>
+        </p:spPr>
+        <p:style>
+          <a:lnRef idx="1">
+            <a:schemeClr val="accent1"/>
+          </a:lnRef>
+          <a:fillRef idx="0">
+            <a:schemeClr val="accent1"/>
+          </a:fillRef>
+          <a:effectRef idx="0">
+            <a:schemeClr val="accent1"/>
+          </a:effectRef>
+          <a:fontRef idx="minor">
+            <a:schemeClr val="tx1"/>
+          </a:fontRef>
+        </p:style>
+      </p:cxnSp>
+      <p:sp>
+        <p:nvSpPr>
+          <p:cNvPr id="54" name="TextBox 53">
+            <a:extLst>
+              <a:ext uri="{FF2B5EF4-FFF2-40B4-BE49-F238E27FC236}">
+                <a16:creationId xmlns:a16="http://schemas.microsoft.com/office/drawing/2014/main" id="{B1DE81D2-5C3C-4643-1CE4-D47D31E0BAE5}"/>
+              </a:ext>
+            </a:extLst>
+          </p:cNvPr>
+          <p:cNvSpPr txBox="1"/>
+          <p:nvPr/>
+        </p:nvSpPr>
+        <p:spPr>
+          <a:xfrm>
+            <a:off x="5878744" y="4621870"/>
+            <a:ext cx="1426994" cy="307777"/>
+          </a:xfrm>
+          <a:prstGeom prst="rect">
+            <a:avLst/>
+          </a:prstGeom>
+          <a:noFill/>
+        </p:spPr>
+        <p:txBody>
+          <a:bodyPr wrap="none" rtlCol="0">
+            <a:spAutoFit/>
+          </a:bodyPr>
+          <a:lstStyle/>
+          <a:p>
+            <a:r>
+              <a:rPr lang="en-NL" sz="1400" dirty="0"/>
+              <a:t>try∈ and succ∉ </a:t>
+            </a:r>
+          </a:p>
+        </p:txBody>
+      </p:sp>
+      <p:sp>
+        <p:nvSpPr>
+          <p:cNvPr id="55" name="TextBox 54">
+            <a:extLst>
+              <a:ext uri="{FF2B5EF4-FFF2-40B4-BE49-F238E27FC236}">
+                <a16:creationId xmlns:a16="http://schemas.microsoft.com/office/drawing/2014/main" id="{A489A214-15F8-30EA-DD28-615E112594D8}"/>
+              </a:ext>
+            </a:extLst>
+          </p:cNvPr>
+          <p:cNvSpPr txBox="1"/>
+          <p:nvPr/>
+        </p:nvSpPr>
+        <p:spPr>
+          <a:xfrm>
+            <a:off x="7663875" y="4035368"/>
+            <a:ext cx="715260" cy="307777"/>
+          </a:xfrm>
+          <a:prstGeom prst="rect">
+            <a:avLst/>
+          </a:prstGeom>
+          <a:noFill/>
+        </p:spPr>
+        <p:txBody>
+          <a:bodyPr wrap="none" rtlCol="0">
+            <a:spAutoFit/>
+          </a:bodyPr>
+          <a:lstStyle/>
+          <a:p>
+            <a:r>
+              <a:rPr lang="en-NL" sz="1400" dirty="0"/>
+              <a:t>succ ∈</a:t>
             </a:r>
           </a:p>
         </p:txBody>
@@ -19820,642 +19862,6 @@
       </p:sp>
       <p:sp>
         <p:nvSpPr>
-          <p:cNvPr id="9" name="Oval 8">
-            <a:extLst>
-              <a:ext uri="{FF2B5EF4-FFF2-40B4-BE49-F238E27FC236}">
-                <a16:creationId xmlns:a16="http://schemas.microsoft.com/office/drawing/2014/main" id="{A9061998-D99A-A393-ACE8-E1B154878775}"/>
-              </a:ext>
-            </a:extLst>
-          </p:cNvPr>
-          <p:cNvSpPr/>
-          <p:nvPr/>
-        </p:nvSpPr>
-        <p:spPr>
-          <a:xfrm>
-            <a:off x="5683998" y="2664352"/>
-            <a:ext cx="355600" cy="338666"/>
-          </a:xfrm>
-          <a:prstGeom prst="ellipse">
-            <a:avLst/>
-          </a:prstGeom>
-          <a:solidFill>
-            <a:schemeClr val="accent3">
-              <a:lumMod val="40000"/>
-              <a:lumOff val="60000"/>
-            </a:schemeClr>
-          </a:solidFill>
-          <a:ln>
-            <a:solidFill>
-              <a:schemeClr val="accent3">
-                <a:lumMod val="50000"/>
-              </a:schemeClr>
-            </a:solidFill>
-          </a:ln>
-        </p:spPr>
-        <p:style>
-          <a:lnRef idx="2">
-            <a:schemeClr val="accent1">
-              <a:shade val="50000"/>
-            </a:schemeClr>
-          </a:lnRef>
-          <a:fillRef idx="1">
-            <a:schemeClr val="accent1"/>
-          </a:fillRef>
-          <a:effectRef idx="0">
-            <a:schemeClr val="accent1"/>
-          </a:effectRef>
-          <a:fontRef idx="minor">
-            <a:schemeClr val="lt1"/>
-          </a:fontRef>
-        </p:style>
-        <p:txBody>
-          <a:bodyPr rtlCol="0" anchor="ctr"/>
-          <a:lstStyle/>
-          <a:p>
-            <a:pPr algn="ctr"/>
-            <a:r>
-              <a:rPr lang="en-NL" dirty="0">
-                <a:solidFill>
-                  <a:schemeClr val="tx1"/>
-                </a:solidFill>
-              </a:rPr>
-              <a:t>u</a:t>
-            </a:r>
-          </a:p>
-        </p:txBody>
-      </p:sp>
-      <p:sp>
-        <p:nvSpPr>
-          <p:cNvPr id="10" name="Oval 9">
-            <a:extLst>
-              <a:ext uri="{FF2B5EF4-FFF2-40B4-BE49-F238E27FC236}">
-                <a16:creationId xmlns:a16="http://schemas.microsoft.com/office/drawing/2014/main" id="{370866BC-90AA-658C-D89C-4348CBA4FA0A}"/>
-              </a:ext>
-            </a:extLst>
-          </p:cNvPr>
-          <p:cNvSpPr/>
-          <p:nvPr/>
-        </p:nvSpPr>
-        <p:spPr>
-          <a:xfrm>
-            <a:off x="6630334" y="2664352"/>
-            <a:ext cx="355600" cy="338666"/>
-          </a:xfrm>
-          <a:prstGeom prst="ellipse">
-            <a:avLst/>
-          </a:prstGeom>
-          <a:solidFill>
-            <a:schemeClr val="accent4">
-              <a:lumMod val="40000"/>
-              <a:lumOff val="60000"/>
-            </a:schemeClr>
-          </a:solidFill>
-          <a:ln w="34925" cmpd="dbl">
-            <a:solidFill>
-              <a:schemeClr val="tx1"/>
-            </a:solidFill>
-          </a:ln>
-        </p:spPr>
-        <p:style>
-          <a:lnRef idx="2">
-            <a:schemeClr val="accent1">
-              <a:shade val="50000"/>
-            </a:schemeClr>
-          </a:lnRef>
-          <a:fillRef idx="1">
-            <a:schemeClr val="accent1"/>
-          </a:fillRef>
-          <a:effectRef idx="0">
-            <a:schemeClr val="accent1"/>
-          </a:effectRef>
-          <a:fontRef idx="minor">
-            <a:schemeClr val="lt1"/>
-          </a:fontRef>
-        </p:style>
-        <p:txBody>
-          <a:bodyPr rtlCol="0" anchor="ctr"/>
-          <a:lstStyle/>
-          <a:p>
-            <a:pPr algn="ctr"/>
-            <a:r>
-              <a:rPr lang="en-NL" dirty="0">
-                <a:solidFill>
-                  <a:schemeClr val="tx1"/>
-                </a:solidFill>
-              </a:rPr>
-              <a:t>v</a:t>
-            </a:r>
-          </a:p>
-        </p:txBody>
-      </p:sp>
-      <p:sp>
-        <p:nvSpPr>
-          <p:cNvPr id="12" name="Oval 11">
-            <a:extLst>
-              <a:ext uri="{FF2B5EF4-FFF2-40B4-BE49-F238E27FC236}">
-                <a16:creationId xmlns:a16="http://schemas.microsoft.com/office/drawing/2014/main" id="{A7F092FA-6D28-A28B-B94B-A406D47C7FCD}"/>
-              </a:ext>
-            </a:extLst>
-          </p:cNvPr>
-          <p:cNvSpPr/>
-          <p:nvPr/>
-        </p:nvSpPr>
-        <p:spPr>
-          <a:xfrm>
-            <a:off x="8243349" y="2674712"/>
-            <a:ext cx="355600" cy="338666"/>
-          </a:xfrm>
-          <a:prstGeom prst="ellipse">
-            <a:avLst/>
-          </a:prstGeom>
-          <a:solidFill>
-            <a:schemeClr val="accent4">
-              <a:lumMod val="40000"/>
-              <a:lumOff val="60000"/>
-            </a:schemeClr>
-          </a:solidFill>
-          <a:ln w="34925" cmpd="dbl">
-            <a:solidFill>
-              <a:schemeClr val="tx1"/>
-            </a:solidFill>
-          </a:ln>
-        </p:spPr>
-        <p:style>
-          <a:lnRef idx="2">
-            <a:schemeClr val="accent1">
-              <a:shade val="50000"/>
-            </a:schemeClr>
-          </a:lnRef>
-          <a:fillRef idx="1">
-            <a:schemeClr val="accent1"/>
-          </a:fillRef>
-          <a:effectRef idx="0">
-            <a:schemeClr val="accent1"/>
-          </a:effectRef>
-          <a:fontRef idx="minor">
-            <a:schemeClr val="lt1"/>
-          </a:fontRef>
-        </p:style>
-        <p:txBody>
-          <a:bodyPr rtlCol="0" anchor="ctr"/>
-          <a:lstStyle/>
-          <a:p>
-            <a:pPr algn="ctr"/>
-            <a:r>
-              <a:rPr lang="en-NL" dirty="0">
-                <a:solidFill>
-                  <a:schemeClr val="tx1"/>
-                </a:solidFill>
-              </a:rPr>
-              <a:t>w</a:t>
-            </a:r>
-          </a:p>
-        </p:txBody>
-      </p:sp>
-      <p:cxnSp>
-        <p:nvCxnSpPr>
-          <p:cNvPr id="14" name="Straight Arrow Connector 13">
-            <a:extLst>
-              <a:ext uri="{FF2B5EF4-FFF2-40B4-BE49-F238E27FC236}">
-                <a16:creationId xmlns:a16="http://schemas.microsoft.com/office/drawing/2014/main" id="{53CFA656-4155-18B1-DE50-D0AF8C947924}"/>
-              </a:ext>
-            </a:extLst>
-          </p:cNvPr>
-          <p:cNvCxnSpPr>
-            <a:cxnSpLocks/>
-            <a:stCxn id="9" idx="6"/>
-            <a:endCxn id="10" idx="2"/>
-          </p:cNvCxnSpPr>
-          <p:nvPr/>
-        </p:nvCxnSpPr>
-        <p:spPr>
-          <a:xfrm>
-            <a:off x="6039598" y="2833685"/>
-            <a:ext cx="590736" cy="0"/>
-          </a:xfrm>
-          <a:prstGeom prst="straightConnector1">
-            <a:avLst/>
-          </a:prstGeom>
-          <a:ln w="12700">
-            <a:solidFill>
-              <a:schemeClr val="tx1"/>
-            </a:solidFill>
-            <a:tailEnd type="triangle"/>
-          </a:ln>
-        </p:spPr>
-        <p:style>
-          <a:lnRef idx="1">
-            <a:schemeClr val="accent1"/>
-          </a:lnRef>
-          <a:fillRef idx="0">
-            <a:schemeClr val="accent1"/>
-          </a:fillRef>
-          <a:effectRef idx="0">
-            <a:schemeClr val="accent1"/>
-          </a:effectRef>
-          <a:fontRef idx="minor">
-            <a:schemeClr val="tx1"/>
-          </a:fontRef>
-        </p:style>
-      </p:cxnSp>
-      <p:cxnSp>
-        <p:nvCxnSpPr>
-          <p:cNvPr id="17" name="Straight Arrow Connector 16">
-            <a:extLst>
-              <a:ext uri="{FF2B5EF4-FFF2-40B4-BE49-F238E27FC236}">
-                <a16:creationId xmlns:a16="http://schemas.microsoft.com/office/drawing/2014/main" id="{A04470C2-A47B-3F8A-B21A-F6F318976C2E}"/>
-              </a:ext>
-            </a:extLst>
-          </p:cNvPr>
-          <p:cNvCxnSpPr>
-            <a:cxnSpLocks/>
-            <a:stCxn id="10" idx="6"/>
-            <a:endCxn id="12" idx="2"/>
-          </p:cNvCxnSpPr>
-          <p:nvPr/>
-        </p:nvCxnSpPr>
-        <p:spPr>
-          <a:xfrm>
-            <a:off x="6985934" y="2833685"/>
-            <a:ext cx="1257415" cy="10360"/>
-          </a:xfrm>
-          <a:prstGeom prst="straightConnector1">
-            <a:avLst/>
-          </a:prstGeom>
-          <a:ln w="12700">
-            <a:solidFill>
-              <a:schemeClr val="tx1"/>
-            </a:solidFill>
-            <a:tailEnd type="triangle"/>
-          </a:ln>
-        </p:spPr>
-        <p:style>
-          <a:lnRef idx="1">
-            <a:schemeClr val="accent1"/>
-          </a:lnRef>
-          <a:fillRef idx="0">
-            <a:schemeClr val="accent1"/>
-          </a:fillRef>
-          <a:effectRef idx="0">
-            <a:schemeClr val="accent1"/>
-          </a:effectRef>
-          <a:fontRef idx="minor">
-            <a:schemeClr val="tx1"/>
-          </a:fontRef>
-        </p:style>
-      </p:cxnSp>
-      <p:cxnSp>
-        <p:nvCxnSpPr>
-          <p:cNvPr id="18" name="Curved Connector 17">
-            <a:extLst>
-              <a:ext uri="{FF2B5EF4-FFF2-40B4-BE49-F238E27FC236}">
-                <a16:creationId xmlns:a16="http://schemas.microsoft.com/office/drawing/2014/main" id="{BF963C4F-70B1-BEED-2B5E-0EF770BC5A44}"/>
-              </a:ext>
-            </a:extLst>
-          </p:cNvPr>
-          <p:cNvCxnSpPr>
-            <a:cxnSpLocks/>
-            <a:stCxn id="10" idx="5"/>
-            <a:endCxn id="10" idx="3"/>
-          </p:cNvCxnSpPr>
-          <p:nvPr/>
-        </p:nvCxnSpPr>
-        <p:spPr>
-          <a:xfrm rot="5400000">
-            <a:off x="6808134" y="2827698"/>
-            <a:ext cx="12700" cy="251448"/>
-          </a:xfrm>
-          <a:prstGeom prst="curvedConnector3">
-            <a:avLst>
-              <a:gd name="adj1" fmla="val 2190520"/>
-            </a:avLst>
-          </a:prstGeom>
-          <a:ln w="12700">
-            <a:solidFill>
-              <a:schemeClr val="tx1"/>
-            </a:solidFill>
-            <a:tailEnd type="triangle"/>
-          </a:ln>
-        </p:spPr>
-        <p:style>
-          <a:lnRef idx="1">
-            <a:schemeClr val="accent1"/>
-          </a:lnRef>
-          <a:fillRef idx="0">
-            <a:schemeClr val="accent1"/>
-          </a:fillRef>
-          <a:effectRef idx="0">
-            <a:schemeClr val="accent1"/>
-          </a:effectRef>
-          <a:fontRef idx="minor">
-            <a:schemeClr val="tx1"/>
-          </a:fontRef>
-        </p:style>
-      </p:cxnSp>
-      <p:cxnSp>
-        <p:nvCxnSpPr>
-          <p:cNvPr id="19" name="Curved Connector 18">
-            <a:extLst>
-              <a:ext uri="{FF2B5EF4-FFF2-40B4-BE49-F238E27FC236}">
-                <a16:creationId xmlns:a16="http://schemas.microsoft.com/office/drawing/2014/main" id="{F66D88FE-766F-D716-BBE8-4E004ADADF0D}"/>
-              </a:ext>
-            </a:extLst>
-          </p:cNvPr>
-          <p:cNvCxnSpPr>
-            <a:cxnSpLocks/>
-            <a:stCxn id="12" idx="5"/>
-            <a:endCxn id="12" idx="3"/>
-          </p:cNvCxnSpPr>
-          <p:nvPr/>
-        </p:nvCxnSpPr>
-        <p:spPr>
-          <a:xfrm rot="5400000">
-            <a:off x="8421149" y="2838058"/>
-            <a:ext cx="12700" cy="251448"/>
-          </a:xfrm>
-          <a:prstGeom prst="curvedConnector3">
-            <a:avLst>
-              <a:gd name="adj1" fmla="val 2190520"/>
-            </a:avLst>
-          </a:prstGeom>
-          <a:ln w="12700">
-            <a:solidFill>
-              <a:schemeClr val="tx1"/>
-            </a:solidFill>
-            <a:tailEnd type="triangle"/>
-          </a:ln>
-        </p:spPr>
-        <p:style>
-          <a:lnRef idx="1">
-            <a:schemeClr val="accent1"/>
-          </a:lnRef>
-          <a:fillRef idx="0">
-            <a:schemeClr val="accent1"/>
-          </a:fillRef>
-          <a:effectRef idx="0">
-            <a:schemeClr val="accent1"/>
-          </a:effectRef>
-          <a:fontRef idx="minor">
-            <a:schemeClr val="tx1"/>
-          </a:fontRef>
-        </p:style>
-      </p:cxnSp>
-      <p:cxnSp>
-        <p:nvCxnSpPr>
-          <p:cNvPr id="21" name="Straight Arrow Connector 20">
-            <a:extLst>
-              <a:ext uri="{FF2B5EF4-FFF2-40B4-BE49-F238E27FC236}">
-                <a16:creationId xmlns:a16="http://schemas.microsoft.com/office/drawing/2014/main" id="{88D138CF-B67E-A0A9-6723-6F792C4063E1}"/>
-              </a:ext>
-            </a:extLst>
-          </p:cNvPr>
-          <p:cNvCxnSpPr>
-            <a:cxnSpLocks/>
-          </p:cNvCxnSpPr>
-          <p:nvPr/>
-        </p:nvCxnSpPr>
-        <p:spPr>
-          <a:xfrm>
-            <a:off x="5474978" y="2844045"/>
-            <a:ext cx="187729" cy="0"/>
-          </a:xfrm>
-          <a:prstGeom prst="straightConnector1">
-            <a:avLst/>
-          </a:prstGeom>
-          <a:ln w="12700">
-            <a:solidFill>
-              <a:schemeClr val="tx1"/>
-            </a:solidFill>
-            <a:tailEnd type="triangle"/>
-          </a:ln>
-        </p:spPr>
-        <p:style>
-          <a:lnRef idx="1">
-            <a:schemeClr val="accent1"/>
-          </a:lnRef>
-          <a:fillRef idx="0">
-            <a:schemeClr val="accent1"/>
-          </a:fillRef>
-          <a:effectRef idx="0">
-            <a:schemeClr val="accent1"/>
-          </a:effectRef>
-          <a:fontRef idx="minor">
-            <a:schemeClr val="tx1"/>
-          </a:fontRef>
-        </p:style>
-      </p:cxnSp>
-      <p:sp>
-        <p:nvSpPr>
-          <p:cNvPr id="22" name="TextBox 21">
-            <a:extLst>
-              <a:ext uri="{FF2B5EF4-FFF2-40B4-BE49-F238E27FC236}">
-                <a16:creationId xmlns:a16="http://schemas.microsoft.com/office/drawing/2014/main" id="{D7AC3CA8-7067-6DED-86E8-9A9AB3EC3303}"/>
-              </a:ext>
-            </a:extLst>
-          </p:cNvPr>
-          <p:cNvSpPr txBox="1"/>
-          <p:nvPr/>
-        </p:nvSpPr>
-        <p:spPr>
-          <a:xfrm>
-            <a:off x="6120764" y="2572726"/>
-            <a:ext cx="274434" cy="369332"/>
-          </a:xfrm>
-          <a:prstGeom prst="rect">
-            <a:avLst/>
-          </a:prstGeom>
-          <a:noFill/>
-        </p:spPr>
-        <p:txBody>
-          <a:bodyPr wrap="none" rtlCol="0">
-            <a:spAutoFit/>
-          </a:bodyPr>
-          <a:lstStyle/>
-          <a:p>
-            <a:r>
-              <a:rPr lang="en-NL" dirty="0"/>
-              <a:t>*</a:t>
-            </a:r>
-          </a:p>
-        </p:txBody>
-      </p:sp>
-      <p:sp>
-        <p:nvSpPr>
-          <p:cNvPr id="23" name="TextBox 22">
-            <a:extLst>
-              <a:ext uri="{FF2B5EF4-FFF2-40B4-BE49-F238E27FC236}">
-                <a16:creationId xmlns:a16="http://schemas.microsoft.com/office/drawing/2014/main" id="{ABEE712E-9862-8761-1891-50684FBF191D}"/>
-              </a:ext>
-            </a:extLst>
-          </p:cNvPr>
-          <p:cNvSpPr txBox="1"/>
-          <p:nvPr/>
-        </p:nvSpPr>
-        <p:spPr>
-          <a:xfrm>
-            <a:off x="6538607" y="3199311"/>
-            <a:ext cx="551754" cy="307777"/>
-          </a:xfrm>
-          <a:prstGeom prst="rect">
-            <a:avLst/>
-          </a:prstGeom>
-          <a:noFill/>
-        </p:spPr>
-        <p:txBody>
-          <a:bodyPr wrap="none" rtlCol="0">
-            <a:spAutoFit/>
-          </a:bodyPr>
-          <a:lstStyle/>
-          <a:p>
-            <a:r>
-              <a:rPr lang="en-NL" sz="1400" dirty="0"/>
-              <a:t>{try} </a:t>
-            </a:r>
-          </a:p>
-        </p:txBody>
-      </p:sp>
-      <p:sp>
-        <p:nvSpPr>
-          <p:cNvPr id="24" name="TextBox 23">
-            <a:extLst>
-              <a:ext uri="{FF2B5EF4-FFF2-40B4-BE49-F238E27FC236}">
-                <a16:creationId xmlns:a16="http://schemas.microsoft.com/office/drawing/2014/main" id="{8DB6D405-9029-AC39-BFAE-B1D14CEE6206}"/>
-              </a:ext>
-            </a:extLst>
-          </p:cNvPr>
-          <p:cNvSpPr txBox="1"/>
-          <p:nvPr/>
-        </p:nvSpPr>
-        <p:spPr>
-          <a:xfrm>
-            <a:off x="7218302" y="2527571"/>
-            <a:ext cx="671979" cy="307777"/>
-          </a:xfrm>
-          <a:prstGeom prst="rect">
-            <a:avLst/>
-          </a:prstGeom>
-          <a:noFill/>
-        </p:spPr>
-        <p:txBody>
-          <a:bodyPr wrap="none" rtlCol="0">
-            <a:spAutoFit/>
-          </a:bodyPr>
-          <a:lstStyle/>
-          <a:p>
-            <a:r>
-              <a:rPr lang="en-NL" sz="1400" dirty="0"/>
-              <a:t>{succ}</a:t>
-            </a:r>
-          </a:p>
-        </p:txBody>
-      </p:sp>
-      <p:sp>
-        <p:nvSpPr>
-          <p:cNvPr id="26" name="TextBox 25">
-            <a:extLst>
-              <a:ext uri="{FF2B5EF4-FFF2-40B4-BE49-F238E27FC236}">
-                <a16:creationId xmlns:a16="http://schemas.microsoft.com/office/drawing/2014/main" id="{D18F79CD-4CAC-0583-388E-27DB8572FCBB}"/>
-              </a:ext>
-            </a:extLst>
-          </p:cNvPr>
-          <p:cNvSpPr txBox="1"/>
-          <p:nvPr/>
-        </p:nvSpPr>
-        <p:spPr>
-          <a:xfrm>
-            <a:off x="7071260" y="2315604"/>
-            <a:ext cx="956800" cy="307777"/>
-          </a:xfrm>
-          <a:prstGeom prst="rect">
-            <a:avLst/>
-          </a:prstGeom>
-          <a:noFill/>
-        </p:spPr>
-        <p:txBody>
-          <a:bodyPr wrap="none" rtlCol="0">
-            <a:spAutoFit/>
-          </a:bodyPr>
-          <a:lstStyle/>
-          <a:p>
-            <a:r>
-              <a:rPr lang="en-NL" sz="1400" dirty="0"/>
-              <a:t>{try, succ}</a:t>
-            </a:r>
-          </a:p>
-        </p:txBody>
-      </p:sp>
-      <p:sp>
-        <p:nvSpPr>
-          <p:cNvPr id="27" name="TextBox 26">
-            <a:extLst>
-              <a:ext uri="{FF2B5EF4-FFF2-40B4-BE49-F238E27FC236}">
-                <a16:creationId xmlns:a16="http://schemas.microsoft.com/office/drawing/2014/main" id="{FC4A6C0A-B616-54CA-2B8A-951F5914AA57}"/>
-              </a:ext>
-            </a:extLst>
-          </p:cNvPr>
-          <p:cNvSpPr txBox="1"/>
-          <p:nvPr/>
-        </p:nvSpPr>
-        <p:spPr>
-          <a:xfrm>
-            <a:off x="8484595" y="2942058"/>
-            <a:ext cx="274434" cy="369332"/>
-          </a:xfrm>
-          <a:prstGeom prst="rect">
-            <a:avLst/>
-          </a:prstGeom>
-          <a:noFill/>
-        </p:spPr>
-        <p:txBody>
-          <a:bodyPr wrap="none" rtlCol="0">
-            <a:spAutoFit/>
-          </a:bodyPr>
-          <a:lstStyle/>
-          <a:p>
-            <a:r>
-              <a:rPr lang="en-NL" dirty="0"/>
-              <a:t>*</a:t>
-            </a:r>
-          </a:p>
-        </p:txBody>
-      </p:sp>
-      <p:sp>
-        <p:nvSpPr>
-          <p:cNvPr id="28" name="TextBox 27">
-            <a:extLst>
-              <a:ext uri="{FF2B5EF4-FFF2-40B4-BE49-F238E27FC236}">
-                <a16:creationId xmlns:a16="http://schemas.microsoft.com/office/drawing/2014/main" id="{DD8CB629-4445-DC10-7C22-099B699BD1AB}"/>
-              </a:ext>
-            </a:extLst>
-          </p:cNvPr>
-          <p:cNvSpPr txBox="1"/>
-          <p:nvPr/>
-        </p:nvSpPr>
-        <p:spPr>
-          <a:xfrm>
-            <a:off x="5050106" y="2650682"/>
-            <a:ext cx="415498" cy="369332"/>
-          </a:xfrm>
-          <a:prstGeom prst="rect">
-            <a:avLst/>
-          </a:prstGeom>
-          <a:noFill/>
-        </p:spPr>
-        <p:txBody>
-          <a:bodyPr wrap="none" rtlCol="0">
-            <a:spAutoFit/>
-          </a:bodyPr>
-          <a:lstStyle/>
-          <a:p>
-            <a:r>
-              <a:rPr lang="en-NL" dirty="0"/>
-              <a:t>R:</a:t>
-            </a:r>
-          </a:p>
-        </p:txBody>
-      </p:sp>
-      <p:sp>
-        <p:nvSpPr>
           <p:cNvPr id="29" name="TextBox 28">
             <a:extLst>
               <a:ext uri="{FF2B5EF4-FFF2-40B4-BE49-F238E27FC236}">
@@ -20495,41 +19901,6 @@
       </p:sp>
       <p:sp>
         <p:nvSpPr>
-          <p:cNvPr id="32" name="TextBox 31">
-            <a:extLst>
-              <a:ext uri="{FF2B5EF4-FFF2-40B4-BE49-F238E27FC236}">
-                <a16:creationId xmlns:a16="http://schemas.microsoft.com/office/drawing/2014/main" id="{086C0265-BEA7-7399-C0F6-D7047C62355B}"/>
-              </a:ext>
-            </a:extLst>
-          </p:cNvPr>
-          <p:cNvSpPr txBox="1"/>
-          <p:nvPr/>
-        </p:nvSpPr>
-        <p:spPr>
-          <a:xfrm>
-            <a:off x="7102718" y="3462327"/>
-            <a:ext cx="1850683" cy="276999"/>
-          </a:xfrm>
-          <a:prstGeom prst="rect">
-            <a:avLst/>
-          </a:prstGeom>
-          <a:noFill/>
-        </p:spPr>
-        <p:txBody>
-          <a:bodyPr wrap="square" rtlCol="0">
-            <a:spAutoFit/>
-          </a:bodyPr>
-          <a:lstStyle/>
-          <a:p>
-            <a:r>
-              <a:rPr lang="en-NL" sz="1200" dirty="0"/>
-              <a:t>with L=∅ and K={v,w}</a:t>
-            </a:r>
-          </a:p>
-        </p:txBody>
-      </p:sp>
-      <p:sp>
-        <p:nvSpPr>
           <p:cNvPr id="34" name="Oval 33">
             <a:extLst>
               <a:ext uri="{FF2B5EF4-FFF2-40B4-BE49-F238E27FC236}">
@@ -20549,9 +19920,9 @@
             <a:avLst/>
           </a:prstGeom>
           <a:solidFill>
-            <a:schemeClr val="accent4">
-              <a:lumMod val="40000"/>
-              <a:lumOff val="60000"/>
+            <a:schemeClr val="accent2">
+              <a:lumMod val="20000"/>
+              <a:lumOff val="80000"/>
             </a:schemeClr>
           </a:solidFill>
           <a:ln>
@@ -20629,9 +20000,9 @@
             <a:avLst/>
           </a:prstGeom>
           <a:solidFill>
-            <a:schemeClr val="accent4">
-              <a:lumMod val="40000"/>
-              <a:lumOff val="60000"/>
+            <a:schemeClr val="accent2">
+              <a:lumMod val="20000"/>
+              <a:lumOff val="80000"/>
             </a:schemeClr>
           </a:solidFill>
           <a:ln>
@@ -21384,7 +20755,7 @@
           <a:p>
             <a:r>
               <a:rPr lang="en-NL" sz="1400" dirty="0"/>
-              <a:t>This results in a new Rabin R2. Any state (s,t) in R2 with t in R’s L is marked as L in R2.  If t was in R’s K, we mark (s,t) as K in R2. So, for above example we get L is empty, and all the blue states are K.</a:t>
+              <a:t>This results in a new Rabin R2. Any state (s,t) in R2 with t in R’s L is marked as L in R2.  If t was in R’s K, we mark (s,t) as K in R2. So, for above example we get L = { the red states } and K =  all the blue states (there is only one).</a:t>
             </a:r>
           </a:p>
         </p:txBody>
@@ -21420,6 +20791,727 @@
             <a:r>
               <a:rPr lang="en-NL" dirty="0"/>
               <a:t>R2:</a:t>
+            </a:r>
+          </a:p>
+        </p:txBody>
+      </p:sp>
+      <p:sp>
+        <p:nvSpPr>
+          <p:cNvPr id="101" name="Oval 100">
+            <a:extLst>
+              <a:ext uri="{FF2B5EF4-FFF2-40B4-BE49-F238E27FC236}">
+                <a16:creationId xmlns:a16="http://schemas.microsoft.com/office/drawing/2014/main" id="{030BE598-A711-7788-BA0F-7DACA59AA136}"/>
+              </a:ext>
+            </a:extLst>
+          </p:cNvPr>
+          <p:cNvSpPr/>
+          <p:nvPr/>
+        </p:nvSpPr>
+        <p:spPr>
+          <a:xfrm>
+            <a:off x="5659829" y="2682595"/>
+            <a:ext cx="355600" cy="338666"/>
+          </a:xfrm>
+          <a:prstGeom prst="ellipse">
+            <a:avLst/>
+          </a:prstGeom>
+          <a:solidFill>
+            <a:schemeClr val="accent3">
+              <a:lumMod val="40000"/>
+              <a:lumOff val="60000"/>
+            </a:schemeClr>
+          </a:solidFill>
+          <a:ln>
+            <a:solidFill>
+              <a:schemeClr val="accent3">
+                <a:lumMod val="50000"/>
+              </a:schemeClr>
+            </a:solidFill>
+          </a:ln>
+        </p:spPr>
+        <p:style>
+          <a:lnRef idx="2">
+            <a:schemeClr val="accent1">
+              <a:shade val="50000"/>
+            </a:schemeClr>
+          </a:lnRef>
+          <a:fillRef idx="1">
+            <a:schemeClr val="accent1"/>
+          </a:fillRef>
+          <a:effectRef idx="0">
+            <a:schemeClr val="accent1"/>
+          </a:effectRef>
+          <a:fontRef idx="minor">
+            <a:schemeClr val="lt1"/>
+          </a:fontRef>
+        </p:style>
+        <p:txBody>
+          <a:bodyPr rtlCol="0" anchor="ctr"/>
+          <a:lstStyle/>
+          <a:p>
+            <a:pPr algn="ctr"/>
+            <a:r>
+              <a:rPr lang="en-NL" dirty="0">
+                <a:solidFill>
+                  <a:schemeClr val="tx1"/>
+                </a:solidFill>
+              </a:rPr>
+              <a:t>u</a:t>
+            </a:r>
+          </a:p>
+        </p:txBody>
+      </p:sp>
+      <p:sp>
+        <p:nvSpPr>
+          <p:cNvPr id="102" name="Oval 101">
+            <a:extLst>
+              <a:ext uri="{FF2B5EF4-FFF2-40B4-BE49-F238E27FC236}">
+                <a16:creationId xmlns:a16="http://schemas.microsoft.com/office/drawing/2014/main" id="{5C7C29BA-A82F-A3F5-D4EA-0BA6A19148E2}"/>
+              </a:ext>
+            </a:extLst>
+          </p:cNvPr>
+          <p:cNvSpPr/>
+          <p:nvPr/>
+        </p:nvSpPr>
+        <p:spPr>
+          <a:xfrm>
+            <a:off x="6606165" y="2682595"/>
+            <a:ext cx="355600" cy="338666"/>
+          </a:xfrm>
+          <a:prstGeom prst="ellipse">
+            <a:avLst/>
+          </a:prstGeom>
+          <a:solidFill>
+            <a:schemeClr val="accent2">
+              <a:lumMod val="20000"/>
+              <a:lumOff val="80000"/>
+            </a:schemeClr>
+          </a:solidFill>
+          <a:ln w="34925" cmpd="dbl">
+            <a:solidFill>
+              <a:schemeClr val="tx1"/>
+            </a:solidFill>
+          </a:ln>
+        </p:spPr>
+        <p:style>
+          <a:lnRef idx="2">
+            <a:schemeClr val="accent1">
+              <a:shade val="50000"/>
+            </a:schemeClr>
+          </a:lnRef>
+          <a:fillRef idx="1">
+            <a:schemeClr val="accent1"/>
+          </a:fillRef>
+          <a:effectRef idx="0">
+            <a:schemeClr val="accent1"/>
+          </a:effectRef>
+          <a:fontRef idx="minor">
+            <a:schemeClr val="lt1"/>
+          </a:fontRef>
+        </p:style>
+        <p:txBody>
+          <a:bodyPr rtlCol="0" anchor="ctr"/>
+          <a:lstStyle/>
+          <a:p>
+            <a:pPr algn="ctr"/>
+            <a:r>
+              <a:rPr lang="en-NL" dirty="0">
+                <a:solidFill>
+                  <a:schemeClr val="tx1"/>
+                </a:solidFill>
+              </a:rPr>
+              <a:t>v</a:t>
+            </a:r>
+          </a:p>
+        </p:txBody>
+      </p:sp>
+      <p:sp>
+        <p:nvSpPr>
+          <p:cNvPr id="103" name="Oval 102">
+            <a:extLst>
+              <a:ext uri="{FF2B5EF4-FFF2-40B4-BE49-F238E27FC236}">
+                <a16:creationId xmlns:a16="http://schemas.microsoft.com/office/drawing/2014/main" id="{3FF467F4-2E79-E7A4-D47F-65338FD87566}"/>
+              </a:ext>
+            </a:extLst>
+          </p:cNvPr>
+          <p:cNvSpPr/>
+          <p:nvPr/>
+        </p:nvSpPr>
+        <p:spPr>
+          <a:xfrm>
+            <a:off x="7884811" y="2685089"/>
+            <a:ext cx="355600" cy="338666"/>
+          </a:xfrm>
+          <a:prstGeom prst="ellipse">
+            <a:avLst/>
+          </a:prstGeom>
+          <a:solidFill>
+            <a:schemeClr val="accent4">
+              <a:lumMod val="40000"/>
+              <a:lumOff val="60000"/>
+            </a:schemeClr>
+          </a:solidFill>
+          <a:ln w="34925" cmpd="dbl">
+            <a:solidFill>
+              <a:schemeClr val="tx1"/>
+            </a:solidFill>
+          </a:ln>
+        </p:spPr>
+        <p:style>
+          <a:lnRef idx="2">
+            <a:schemeClr val="accent1">
+              <a:shade val="50000"/>
+            </a:schemeClr>
+          </a:lnRef>
+          <a:fillRef idx="1">
+            <a:schemeClr val="accent1"/>
+          </a:fillRef>
+          <a:effectRef idx="0">
+            <a:schemeClr val="accent1"/>
+          </a:effectRef>
+          <a:fontRef idx="minor">
+            <a:schemeClr val="lt1"/>
+          </a:fontRef>
+        </p:style>
+        <p:txBody>
+          <a:bodyPr rtlCol="0" anchor="ctr"/>
+          <a:lstStyle/>
+          <a:p>
+            <a:pPr algn="ctr"/>
+            <a:r>
+              <a:rPr lang="en-NL" dirty="0">
+                <a:solidFill>
+                  <a:schemeClr val="tx1"/>
+                </a:solidFill>
+              </a:rPr>
+              <a:t>w</a:t>
+            </a:r>
+          </a:p>
+        </p:txBody>
+      </p:sp>
+      <p:cxnSp>
+        <p:nvCxnSpPr>
+          <p:cNvPr id="104" name="Straight Arrow Connector 103">
+            <a:extLst>
+              <a:ext uri="{FF2B5EF4-FFF2-40B4-BE49-F238E27FC236}">
+                <a16:creationId xmlns:a16="http://schemas.microsoft.com/office/drawing/2014/main" id="{62F50790-786E-96BE-2D32-002A79E1C382}"/>
+              </a:ext>
+            </a:extLst>
+          </p:cNvPr>
+          <p:cNvCxnSpPr>
+            <a:cxnSpLocks/>
+            <a:stCxn id="101" idx="6"/>
+            <a:endCxn id="102" idx="2"/>
+          </p:cNvCxnSpPr>
+          <p:nvPr/>
+        </p:nvCxnSpPr>
+        <p:spPr>
+          <a:xfrm>
+            <a:off x="6015429" y="2851928"/>
+            <a:ext cx="590736" cy="0"/>
+          </a:xfrm>
+          <a:prstGeom prst="straightConnector1">
+            <a:avLst/>
+          </a:prstGeom>
+          <a:ln w="12700">
+            <a:solidFill>
+              <a:schemeClr val="tx1"/>
+            </a:solidFill>
+            <a:tailEnd type="triangle"/>
+          </a:ln>
+        </p:spPr>
+        <p:style>
+          <a:lnRef idx="1">
+            <a:schemeClr val="accent1"/>
+          </a:lnRef>
+          <a:fillRef idx="0">
+            <a:schemeClr val="accent1"/>
+          </a:fillRef>
+          <a:effectRef idx="0">
+            <a:schemeClr val="accent1"/>
+          </a:effectRef>
+          <a:fontRef idx="minor">
+            <a:schemeClr val="tx1"/>
+          </a:fontRef>
+        </p:style>
+      </p:cxnSp>
+      <p:cxnSp>
+        <p:nvCxnSpPr>
+          <p:cNvPr id="105" name="Straight Arrow Connector 104">
+            <a:extLst>
+              <a:ext uri="{FF2B5EF4-FFF2-40B4-BE49-F238E27FC236}">
+                <a16:creationId xmlns:a16="http://schemas.microsoft.com/office/drawing/2014/main" id="{3CE849C9-2FCB-C0F4-1E62-20D60C5B2371}"/>
+              </a:ext>
+            </a:extLst>
+          </p:cNvPr>
+          <p:cNvCxnSpPr>
+            <a:cxnSpLocks/>
+            <a:stCxn id="102" idx="6"/>
+            <a:endCxn id="103" idx="2"/>
+          </p:cNvCxnSpPr>
+          <p:nvPr/>
+        </p:nvCxnSpPr>
+        <p:spPr>
+          <a:xfrm>
+            <a:off x="6961765" y="2851928"/>
+            <a:ext cx="923046" cy="2494"/>
+          </a:xfrm>
+          <a:prstGeom prst="straightConnector1">
+            <a:avLst/>
+          </a:prstGeom>
+          <a:ln w="12700">
+            <a:solidFill>
+              <a:schemeClr val="tx1"/>
+            </a:solidFill>
+            <a:tailEnd type="triangle"/>
+          </a:ln>
+        </p:spPr>
+        <p:style>
+          <a:lnRef idx="1">
+            <a:schemeClr val="accent1"/>
+          </a:lnRef>
+          <a:fillRef idx="0">
+            <a:schemeClr val="accent1"/>
+          </a:fillRef>
+          <a:effectRef idx="0">
+            <a:schemeClr val="accent1"/>
+          </a:effectRef>
+          <a:fontRef idx="minor">
+            <a:schemeClr val="tx1"/>
+          </a:fontRef>
+        </p:style>
+      </p:cxnSp>
+      <p:cxnSp>
+        <p:nvCxnSpPr>
+          <p:cNvPr id="106" name="Curved Connector 105">
+            <a:extLst>
+              <a:ext uri="{FF2B5EF4-FFF2-40B4-BE49-F238E27FC236}">
+                <a16:creationId xmlns:a16="http://schemas.microsoft.com/office/drawing/2014/main" id="{381C7812-7B3D-E583-59A9-239C4B862ED1}"/>
+              </a:ext>
+            </a:extLst>
+          </p:cNvPr>
+          <p:cNvCxnSpPr>
+            <a:cxnSpLocks/>
+            <a:stCxn id="102" idx="5"/>
+            <a:endCxn id="102" idx="3"/>
+          </p:cNvCxnSpPr>
+          <p:nvPr/>
+        </p:nvCxnSpPr>
+        <p:spPr>
+          <a:xfrm rot="5400000">
+            <a:off x="6783965" y="2845941"/>
+            <a:ext cx="12700" cy="251448"/>
+          </a:xfrm>
+          <a:prstGeom prst="curvedConnector3">
+            <a:avLst>
+              <a:gd name="adj1" fmla="val 2190520"/>
+            </a:avLst>
+          </a:prstGeom>
+          <a:ln w="12700">
+            <a:solidFill>
+              <a:schemeClr val="tx1"/>
+            </a:solidFill>
+            <a:tailEnd type="triangle"/>
+          </a:ln>
+        </p:spPr>
+        <p:style>
+          <a:lnRef idx="1">
+            <a:schemeClr val="accent1"/>
+          </a:lnRef>
+          <a:fillRef idx="0">
+            <a:schemeClr val="accent1"/>
+          </a:fillRef>
+          <a:effectRef idx="0">
+            <a:schemeClr val="accent1"/>
+          </a:effectRef>
+          <a:fontRef idx="minor">
+            <a:schemeClr val="tx1"/>
+          </a:fontRef>
+        </p:style>
+      </p:cxnSp>
+      <p:cxnSp>
+        <p:nvCxnSpPr>
+          <p:cNvPr id="107" name="Curved Connector 106">
+            <a:extLst>
+              <a:ext uri="{FF2B5EF4-FFF2-40B4-BE49-F238E27FC236}">
+                <a16:creationId xmlns:a16="http://schemas.microsoft.com/office/drawing/2014/main" id="{76695BA0-7202-AE09-AD97-3882BADDB95B}"/>
+              </a:ext>
+            </a:extLst>
+          </p:cNvPr>
+          <p:cNvCxnSpPr>
+            <a:cxnSpLocks/>
+            <a:stCxn id="103" idx="5"/>
+            <a:endCxn id="103" idx="7"/>
+          </p:cNvCxnSpPr>
+          <p:nvPr/>
+        </p:nvCxnSpPr>
+        <p:spPr>
+          <a:xfrm rot="5400000" flipH="1">
+            <a:off x="8068598" y="2854422"/>
+            <a:ext cx="239474" cy="12700"/>
+          </a:xfrm>
+          <a:prstGeom prst="curvedConnector5">
+            <a:avLst>
+              <a:gd name="adj1" fmla="val -28284"/>
+              <a:gd name="adj2" fmla="val -2723283"/>
+              <a:gd name="adj3" fmla="val 153032"/>
+            </a:avLst>
+          </a:prstGeom>
+          <a:ln w="12700">
+            <a:solidFill>
+              <a:schemeClr val="tx1"/>
+            </a:solidFill>
+            <a:tailEnd type="triangle"/>
+          </a:ln>
+        </p:spPr>
+        <p:style>
+          <a:lnRef idx="1">
+            <a:schemeClr val="accent1"/>
+          </a:lnRef>
+          <a:fillRef idx="0">
+            <a:schemeClr val="accent1"/>
+          </a:fillRef>
+          <a:effectRef idx="0">
+            <a:schemeClr val="accent1"/>
+          </a:effectRef>
+          <a:fontRef idx="minor">
+            <a:schemeClr val="tx1"/>
+          </a:fontRef>
+        </p:style>
+      </p:cxnSp>
+      <p:cxnSp>
+        <p:nvCxnSpPr>
+          <p:cNvPr id="108" name="Straight Arrow Connector 107">
+            <a:extLst>
+              <a:ext uri="{FF2B5EF4-FFF2-40B4-BE49-F238E27FC236}">
+                <a16:creationId xmlns:a16="http://schemas.microsoft.com/office/drawing/2014/main" id="{BD50A127-3AF7-F9EB-9DC0-F1976A3FFB12}"/>
+              </a:ext>
+            </a:extLst>
+          </p:cNvPr>
+          <p:cNvCxnSpPr>
+            <a:cxnSpLocks/>
+          </p:cNvCxnSpPr>
+          <p:nvPr/>
+        </p:nvCxnSpPr>
+        <p:spPr>
+          <a:xfrm>
+            <a:off x="5450809" y="2862288"/>
+            <a:ext cx="187729" cy="0"/>
+          </a:xfrm>
+          <a:prstGeom prst="straightConnector1">
+            <a:avLst/>
+          </a:prstGeom>
+          <a:ln w="12700">
+            <a:solidFill>
+              <a:schemeClr val="tx1"/>
+            </a:solidFill>
+            <a:tailEnd type="triangle"/>
+          </a:ln>
+        </p:spPr>
+        <p:style>
+          <a:lnRef idx="1">
+            <a:schemeClr val="accent1"/>
+          </a:lnRef>
+          <a:fillRef idx="0">
+            <a:schemeClr val="accent1"/>
+          </a:fillRef>
+          <a:effectRef idx="0">
+            <a:schemeClr val="accent1"/>
+          </a:effectRef>
+          <a:fontRef idx="minor">
+            <a:schemeClr val="tx1"/>
+          </a:fontRef>
+        </p:style>
+      </p:cxnSp>
+      <p:sp>
+        <p:nvSpPr>
+          <p:cNvPr id="109" name="TextBox 108">
+            <a:extLst>
+              <a:ext uri="{FF2B5EF4-FFF2-40B4-BE49-F238E27FC236}">
+                <a16:creationId xmlns:a16="http://schemas.microsoft.com/office/drawing/2014/main" id="{48473050-A614-A7AE-6840-0339BEE630C1}"/>
+              </a:ext>
+            </a:extLst>
+          </p:cNvPr>
+          <p:cNvSpPr txBox="1"/>
+          <p:nvPr/>
+        </p:nvSpPr>
+        <p:spPr>
+          <a:xfrm>
+            <a:off x="6096595" y="2590969"/>
+            <a:ext cx="274434" cy="369332"/>
+          </a:xfrm>
+          <a:prstGeom prst="rect">
+            <a:avLst/>
+          </a:prstGeom>
+          <a:noFill/>
+        </p:spPr>
+        <p:txBody>
+          <a:bodyPr wrap="none" rtlCol="0">
+            <a:spAutoFit/>
+          </a:bodyPr>
+          <a:lstStyle/>
+          <a:p>
+            <a:r>
+              <a:rPr lang="en-NL" dirty="0"/>
+              <a:t>*</a:t>
+            </a:r>
+          </a:p>
+        </p:txBody>
+      </p:sp>
+      <p:sp>
+        <p:nvSpPr>
+          <p:cNvPr id="110" name="TextBox 109">
+            <a:extLst>
+              <a:ext uri="{FF2B5EF4-FFF2-40B4-BE49-F238E27FC236}">
+                <a16:creationId xmlns:a16="http://schemas.microsoft.com/office/drawing/2014/main" id="{4D2C331E-968D-3A3A-3998-BED7365D18FB}"/>
+              </a:ext>
+            </a:extLst>
+          </p:cNvPr>
+          <p:cNvSpPr txBox="1"/>
+          <p:nvPr/>
+        </p:nvSpPr>
+        <p:spPr>
+          <a:xfrm>
+            <a:off x="5659829" y="3188681"/>
+            <a:ext cx="1426994" cy="307777"/>
+          </a:xfrm>
+          <a:prstGeom prst="rect">
+            <a:avLst/>
+          </a:prstGeom>
+          <a:noFill/>
+        </p:spPr>
+        <p:txBody>
+          <a:bodyPr wrap="none" rtlCol="0">
+            <a:spAutoFit/>
+          </a:bodyPr>
+          <a:lstStyle/>
+          <a:p>
+            <a:r>
+              <a:rPr lang="en-NL" sz="1400" dirty="0"/>
+              <a:t>try∈ and succ∉ </a:t>
+            </a:r>
+          </a:p>
+        </p:txBody>
+      </p:sp>
+      <p:sp>
+        <p:nvSpPr>
+          <p:cNvPr id="111" name="TextBox 110">
+            <a:extLst>
+              <a:ext uri="{FF2B5EF4-FFF2-40B4-BE49-F238E27FC236}">
+                <a16:creationId xmlns:a16="http://schemas.microsoft.com/office/drawing/2014/main" id="{88268E41-00DE-5CC6-E25B-CB75E781F8E5}"/>
+              </a:ext>
+            </a:extLst>
+          </p:cNvPr>
+          <p:cNvSpPr txBox="1"/>
+          <p:nvPr/>
+        </p:nvSpPr>
+        <p:spPr>
+          <a:xfrm>
+            <a:off x="7026189" y="2576751"/>
+            <a:ext cx="715260" cy="307777"/>
+          </a:xfrm>
+          <a:prstGeom prst="rect">
+            <a:avLst/>
+          </a:prstGeom>
+          <a:noFill/>
+        </p:spPr>
+        <p:txBody>
+          <a:bodyPr wrap="none" rtlCol="0">
+            <a:spAutoFit/>
+          </a:bodyPr>
+          <a:lstStyle/>
+          <a:p>
+            <a:r>
+              <a:rPr lang="en-NL" sz="1400" dirty="0"/>
+              <a:t>succ ∈</a:t>
+            </a:r>
+          </a:p>
+        </p:txBody>
+      </p:sp>
+      <p:sp>
+        <p:nvSpPr>
+          <p:cNvPr id="112" name="TextBox 111">
+            <a:extLst>
+              <a:ext uri="{FF2B5EF4-FFF2-40B4-BE49-F238E27FC236}">
+                <a16:creationId xmlns:a16="http://schemas.microsoft.com/office/drawing/2014/main" id="{EF1872DE-8FD9-C8FA-0E31-965FDDC58980}"/>
+              </a:ext>
+            </a:extLst>
+          </p:cNvPr>
+          <p:cNvSpPr txBox="1"/>
+          <p:nvPr/>
+        </p:nvSpPr>
+        <p:spPr>
+          <a:xfrm>
+            <a:off x="5380316" y="3471727"/>
+            <a:ext cx="3413013" cy="261610"/>
+          </a:xfrm>
+          <a:prstGeom prst="rect">
+            <a:avLst/>
+          </a:prstGeom>
+          <a:noFill/>
+        </p:spPr>
+        <p:txBody>
+          <a:bodyPr wrap="square" rtlCol="0">
+            <a:spAutoFit/>
+          </a:bodyPr>
+          <a:lstStyle/>
+          <a:p>
+            <a:r>
+              <a:rPr lang="en-NL" sz="1100" dirty="0"/>
+              <a:t>accepting condition: { (L,K) } with L={v} and K={w}</a:t>
+            </a:r>
+          </a:p>
+        </p:txBody>
+      </p:sp>
+      <p:sp>
+        <p:nvSpPr>
+          <p:cNvPr id="113" name="TextBox 112">
+            <a:extLst>
+              <a:ext uri="{FF2B5EF4-FFF2-40B4-BE49-F238E27FC236}">
+                <a16:creationId xmlns:a16="http://schemas.microsoft.com/office/drawing/2014/main" id="{0F185175-2CCB-3400-E610-A602D8296A77}"/>
+              </a:ext>
+            </a:extLst>
+          </p:cNvPr>
+          <p:cNvSpPr txBox="1"/>
+          <p:nvPr/>
+        </p:nvSpPr>
+        <p:spPr>
+          <a:xfrm>
+            <a:off x="5025937" y="2668925"/>
+            <a:ext cx="415498" cy="369332"/>
+          </a:xfrm>
+          <a:prstGeom prst="rect">
+            <a:avLst/>
+          </a:prstGeom>
+          <a:noFill/>
+        </p:spPr>
+        <p:txBody>
+          <a:bodyPr wrap="none" rtlCol="0">
+            <a:spAutoFit/>
+          </a:bodyPr>
+          <a:lstStyle/>
+          <a:p>
+            <a:r>
+              <a:rPr lang="en-NL" dirty="0"/>
+              <a:t>R:</a:t>
+            </a:r>
+          </a:p>
+        </p:txBody>
+      </p:sp>
+      <p:cxnSp>
+        <p:nvCxnSpPr>
+          <p:cNvPr id="114" name="Curved Connector 113">
+            <a:extLst>
+              <a:ext uri="{FF2B5EF4-FFF2-40B4-BE49-F238E27FC236}">
+                <a16:creationId xmlns:a16="http://schemas.microsoft.com/office/drawing/2014/main" id="{70C7F0BF-CF1E-B007-1C29-3742D743F9AC}"/>
+              </a:ext>
+            </a:extLst>
+          </p:cNvPr>
+          <p:cNvCxnSpPr>
+            <a:cxnSpLocks/>
+            <a:stCxn id="103" idx="3"/>
+            <a:endCxn id="102" idx="5"/>
+          </p:cNvCxnSpPr>
+          <p:nvPr/>
+        </p:nvCxnSpPr>
+        <p:spPr>
+          <a:xfrm rot="5400000" flipH="1">
+            <a:off x="7422041" y="2459313"/>
+            <a:ext cx="2494" cy="1027198"/>
+          </a:xfrm>
+          <a:prstGeom prst="curvedConnector3">
+            <a:avLst>
+              <a:gd name="adj1" fmla="val -11154611"/>
+            </a:avLst>
+          </a:prstGeom>
+          <a:ln w="12700">
+            <a:solidFill>
+              <a:schemeClr val="tx1"/>
+            </a:solidFill>
+            <a:tailEnd type="triangle"/>
+          </a:ln>
+        </p:spPr>
+        <p:style>
+          <a:lnRef idx="1">
+            <a:schemeClr val="accent1"/>
+          </a:lnRef>
+          <a:fillRef idx="0">
+            <a:schemeClr val="accent1"/>
+          </a:fillRef>
+          <a:effectRef idx="0">
+            <a:schemeClr val="accent1"/>
+          </a:effectRef>
+          <a:fontRef idx="minor">
+            <a:schemeClr val="tx1"/>
+          </a:fontRef>
+        </p:style>
+      </p:cxnSp>
+      <p:sp>
+        <p:nvSpPr>
+          <p:cNvPr id="115" name="TextBox 114">
+            <a:extLst>
+              <a:ext uri="{FF2B5EF4-FFF2-40B4-BE49-F238E27FC236}">
+                <a16:creationId xmlns:a16="http://schemas.microsoft.com/office/drawing/2014/main" id="{3DDBAF63-4E0D-77EC-EEFA-A306D2D0E262}"/>
+              </a:ext>
+            </a:extLst>
+          </p:cNvPr>
+          <p:cNvSpPr txBox="1"/>
+          <p:nvPr/>
+        </p:nvSpPr>
+        <p:spPr>
+          <a:xfrm>
+            <a:off x="7180762" y="3207283"/>
+            <a:ext cx="1426994" cy="307777"/>
+          </a:xfrm>
+          <a:prstGeom prst="rect">
+            <a:avLst/>
+          </a:prstGeom>
+          <a:noFill/>
+        </p:spPr>
+        <p:txBody>
+          <a:bodyPr wrap="none" rtlCol="0">
+            <a:spAutoFit/>
+          </a:bodyPr>
+          <a:lstStyle/>
+          <a:p>
+            <a:r>
+              <a:rPr lang="en-NL" sz="1400" dirty="0"/>
+              <a:t>try∈ and succ∉ </a:t>
+            </a:r>
+          </a:p>
+        </p:txBody>
+      </p:sp>
+      <p:sp>
+        <p:nvSpPr>
+          <p:cNvPr id="116" name="TextBox 115">
+            <a:extLst>
+              <a:ext uri="{FF2B5EF4-FFF2-40B4-BE49-F238E27FC236}">
+                <a16:creationId xmlns:a16="http://schemas.microsoft.com/office/drawing/2014/main" id="{860A6590-CE94-4DCF-15C9-CBB98A76E3F9}"/>
+              </a:ext>
+            </a:extLst>
+          </p:cNvPr>
+          <p:cNvSpPr txBox="1"/>
+          <p:nvPr/>
+        </p:nvSpPr>
+        <p:spPr>
+          <a:xfrm>
+            <a:off x="8143020" y="2334066"/>
+            <a:ext cx="715260" cy="307777"/>
+          </a:xfrm>
+          <a:prstGeom prst="rect">
+            <a:avLst/>
+          </a:prstGeom>
+          <a:noFill/>
+        </p:spPr>
+        <p:txBody>
+          <a:bodyPr wrap="none" rtlCol="0">
+            <a:spAutoFit/>
+          </a:bodyPr>
+          <a:lstStyle/>
+          <a:p>
+            <a:r>
+              <a:rPr lang="en-NL" sz="1400" dirty="0"/>
+              <a:t>succ ∈</a:t>
             </a:r>
           </a:p>
         </p:txBody>
@@ -21918,9 +22010,9 @@
             <a:avLst/>
           </a:prstGeom>
           <a:solidFill>
-            <a:schemeClr val="accent4">
-              <a:lumMod val="40000"/>
-              <a:lumOff val="60000"/>
+            <a:schemeClr val="accent2">
+              <a:lumMod val="20000"/>
+              <a:lumOff val="80000"/>
             </a:schemeClr>
           </a:solidFill>
           <a:ln>
@@ -21998,9 +22090,9 @@
             <a:avLst/>
           </a:prstGeom>
           <a:solidFill>
-            <a:schemeClr val="accent4">
-              <a:lumMod val="40000"/>
-              <a:lumOff val="60000"/>
+            <a:schemeClr val="accent2">
+              <a:lumMod val="20000"/>
+              <a:lumOff val="80000"/>
             </a:schemeClr>
           </a:solidFill>
           <a:ln>

</xml_diff>

<commit_message>
pff reverting to prev pltl solution
</commit_message>
<xml_diff>
--- a/slides/PV_pmc.pptx
+++ b/slides/PV_pmc.pptx
@@ -16736,9 +16736,9 @@
             <a:avLst/>
           </a:prstGeom>
           <a:solidFill>
-            <a:schemeClr val="accent2">
-              <a:lumMod val="20000"/>
-              <a:lumOff val="80000"/>
+            <a:schemeClr val="accent4">
+              <a:lumMod val="40000"/>
+              <a:lumOff val="60000"/>
             </a:schemeClr>
           </a:solidFill>
           <a:ln w="34925" cmpd="dbl">
@@ -17149,41 +17149,6 @@
       </p:sp>
       <p:sp>
         <p:nvSpPr>
-          <p:cNvPr id="33" name="TextBox 32">
-            <a:extLst>
-              <a:ext uri="{FF2B5EF4-FFF2-40B4-BE49-F238E27FC236}">
-                <a16:creationId xmlns:a16="http://schemas.microsoft.com/office/drawing/2014/main" id="{D23BB20C-DD83-F0E7-E40E-99CB8B6F9E82}"/>
-              </a:ext>
-            </a:extLst>
-          </p:cNvPr>
-          <p:cNvSpPr txBox="1"/>
-          <p:nvPr/>
-        </p:nvSpPr>
-        <p:spPr>
-          <a:xfrm>
-            <a:off x="5986054" y="3908741"/>
-            <a:ext cx="715260" cy="307777"/>
-          </a:xfrm>
-          <a:prstGeom prst="rect">
-            <a:avLst/>
-          </a:prstGeom>
-          <a:noFill/>
-        </p:spPr>
-        <p:txBody>
-          <a:bodyPr wrap="none" rtlCol="0">
-            <a:spAutoFit/>
-          </a:bodyPr>
-          <a:lstStyle/>
-          <a:p>
-            <a:r>
-              <a:rPr lang="en-NL" sz="1400" dirty="0"/>
-              <a:t>succ ∈</a:t>
-            </a:r>
-          </a:p>
-        </p:txBody>
-      </p:sp>
-      <p:sp>
-        <p:nvSpPr>
           <p:cNvPr id="36" name="TextBox 35">
             <a:extLst>
               <a:ext uri="{FF2B5EF4-FFF2-40B4-BE49-F238E27FC236}">
@@ -17212,7 +17177,7 @@
           <a:p>
             <a:r>
               <a:rPr lang="en-NL" dirty="0"/>
-              <a:t>with accepting condition: { (L,K) } with L={v} and K={w}</a:t>
+              <a:t>As a Buchi, it is also a Rabib, with accepting condition: { (L,K) } with L=∅ and K={v,w}</a:t>
             </a:r>
           </a:p>
         </p:txBody>
@@ -17267,7 +17232,7 @@
         <p:spPr>
           <a:xfrm>
             <a:off x="4234090" y="2524609"/>
-            <a:ext cx="4527821" cy="646331"/>
+            <a:ext cx="4527821" cy="923330"/>
           </a:xfrm>
           <a:prstGeom prst="rect">
             <a:avLst/>
@@ -17282,7 +17247,7 @@
           <a:p>
             <a:r>
               <a:rPr lang="en-NL" dirty="0"/>
-              <a:t>First, we construct a deterministic Rabin automaton that equivalently describes 𝜑 : </a:t>
+              <a:t>First, we construct a deterministic Rabin automaton that equivalently describes 𝜑. I give a deterministic Buchi: </a:t>
             </a:r>
           </a:p>
         </p:txBody>
@@ -17322,54 +17287,6 @@
           </a:p>
         </p:txBody>
       </p:sp>
-      <p:cxnSp>
-        <p:nvCxnSpPr>
-          <p:cNvPr id="42" name="Curved Connector 41">
-            <a:extLst>
-              <a:ext uri="{FF2B5EF4-FFF2-40B4-BE49-F238E27FC236}">
-                <a16:creationId xmlns:a16="http://schemas.microsoft.com/office/drawing/2014/main" id="{0032B207-EFC5-6EF3-46FE-119CCCD8E7A8}"/>
-              </a:ext>
-            </a:extLst>
-          </p:cNvPr>
-          <p:cNvCxnSpPr>
-            <a:cxnSpLocks/>
-            <a:stCxn id="10" idx="3"/>
-            <a:endCxn id="9" idx="5"/>
-          </p:cNvCxnSpPr>
-          <p:nvPr/>
-        </p:nvCxnSpPr>
-        <p:spPr>
-          <a:xfrm rot="5400000" flipH="1">
-            <a:off x="6377214" y="3658989"/>
-            <a:ext cx="10360" cy="1361567"/>
-          </a:xfrm>
-          <a:prstGeom prst="curvedConnector3">
-            <a:avLst>
-              <a:gd name="adj1" fmla="val -2685290"/>
-            </a:avLst>
-          </a:prstGeom>
-          <a:ln w="12700">
-            <a:solidFill>
-              <a:schemeClr val="tx1"/>
-            </a:solidFill>
-            <a:tailEnd type="triangle"/>
-          </a:ln>
-        </p:spPr>
-        <p:style>
-          <a:lnRef idx="1">
-            <a:schemeClr val="accent1"/>
-          </a:lnRef>
-          <a:fillRef idx="0">
-            <a:schemeClr val="accent1"/>
-          </a:fillRef>
-          <a:effectRef idx="0">
-            <a:schemeClr val="accent1"/>
-          </a:effectRef>
-          <a:fontRef idx="minor">
-            <a:schemeClr val="tx1"/>
-          </a:fontRef>
-        </p:style>
-      </p:cxnSp>
       <p:sp>
         <p:nvSpPr>
           <p:cNvPr id="54" name="TextBox 53">
@@ -17384,8 +17301,8 @@
         </p:nvSpPr>
         <p:spPr>
           <a:xfrm>
-            <a:off x="5878744" y="4621870"/>
-            <a:ext cx="1426994" cy="307777"/>
+            <a:off x="5707961" y="3891633"/>
+            <a:ext cx="1613014" cy="307777"/>
           </a:xfrm>
           <a:prstGeom prst="rect">
             <a:avLst/>
@@ -17393,14 +17310,14 @@
           <a:noFill/>
         </p:spPr>
         <p:txBody>
-          <a:bodyPr wrap="none" rtlCol="0">
+          <a:bodyPr wrap="square" rtlCol="0">
             <a:spAutoFit/>
           </a:bodyPr>
           <a:lstStyle/>
           <a:p>
             <a:r>
               <a:rPr lang="en-NL" sz="1400" dirty="0"/>
-              <a:t>try∈ and succ∉ </a:t>
+              <a:t>try∉ and succ∈</a:t>
             </a:r>
           </a:p>
         </p:txBody>
@@ -17420,7 +17337,7 @@
         <p:spPr>
           <a:xfrm>
             <a:off x="7663875" y="4035368"/>
-            <a:ext cx="715260" cy="307777"/>
+            <a:ext cx="255198" cy="307777"/>
           </a:xfrm>
           <a:prstGeom prst="rect">
             <a:avLst/>
@@ -17435,7 +17352,7 @@
           <a:p>
             <a:r>
               <a:rPr lang="en-NL" sz="1400" dirty="0"/>
-              <a:t>succ ∈</a:t>
+              <a:t>*</a:t>
             </a:r>
           </a:p>
         </p:txBody>
@@ -19920,9 +19837,9 @@
             <a:avLst/>
           </a:prstGeom>
           <a:solidFill>
-            <a:schemeClr val="accent2">
-              <a:lumMod val="20000"/>
-              <a:lumOff val="80000"/>
+            <a:schemeClr val="accent4">
+              <a:lumMod val="40000"/>
+              <a:lumOff val="60000"/>
             </a:schemeClr>
           </a:solidFill>
           <a:ln>
@@ -20000,9 +19917,9 @@
             <a:avLst/>
           </a:prstGeom>
           <a:solidFill>
-            <a:schemeClr val="accent2">
-              <a:lumMod val="20000"/>
-              <a:lumOff val="80000"/>
+            <a:schemeClr val="accent4">
+              <a:lumMod val="40000"/>
+              <a:lumOff val="60000"/>
             </a:schemeClr>
           </a:solidFill>
           <a:ln>
@@ -20755,7 +20672,7 @@
           <a:p>
             <a:r>
               <a:rPr lang="en-NL" sz="1400" dirty="0"/>
-              <a:t>This results in a new Rabin R2. Any state (s,t) in R2 with t in R’s L is marked as L in R2.  If t was in R’s K, we mark (s,t) as K in R2. So, for above example we get L = { the red states } and K =  all the blue states (there is only one).</a:t>
+              <a:t>This results in a new Rabin R2. Any state (s,t) in R2 with t in R’s L is marked as L in R2.  If t was in R’s K, we mark (s,t) as K in R2. So, for above example we get L is empty, and all the blue states are K.</a:t>
             </a:r>
           </a:p>
         </p:txBody>
@@ -20882,9 +20799,9 @@
             <a:avLst/>
           </a:prstGeom>
           <a:solidFill>
-            <a:schemeClr val="accent2">
-              <a:lumMod val="20000"/>
-              <a:lumOff val="80000"/>
+            <a:schemeClr val="accent4">
+              <a:lumMod val="40000"/>
+              <a:lumOff val="60000"/>
             </a:schemeClr>
           </a:solidFill>
           <a:ln w="34925" cmpd="dbl">
@@ -21295,41 +21212,6 @@
       </p:sp>
       <p:sp>
         <p:nvSpPr>
-          <p:cNvPr id="111" name="TextBox 110">
-            <a:extLst>
-              <a:ext uri="{FF2B5EF4-FFF2-40B4-BE49-F238E27FC236}">
-                <a16:creationId xmlns:a16="http://schemas.microsoft.com/office/drawing/2014/main" id="{88268E41-00DE-5CC6-E25B-CB75E781F8E5}"/>
-              </a:ext>
-            </a:extLst>
-          </p:cNvPr>
-          <p:cNvSpPr txBox="1"/>
-          <p:nvPr/>
-        </p:nvSpPr>
-        <p:spPr>
-          <a:xfrm>
-            <a:off x="7026189" y="2576751"/>
-            <a:ext cx="715260" cy="307777"/>
-          </a:xfrm>
-          <a:prstGeom prst="rect">
-            <a:avLst/>
-          </a:prstGeom>
-          <a:noFill/>
-        </p:spPr>
-        <p:txBody>
-          <a:bodyPr wrap="none" rtlCol="0">
-            <a:spAutoFit/>
-          </a:bodyPr>
-          <a:lstStyle/>
-          <a:p>
-            <a:r>
-              <a:rPr lang="en-NL" sz="1400" dirty="0"/>
-              <a:t>succ ∈</a:t>
-            </a:r>
-          </a:p>
-        </p:txBody>
-      </p:sp>
-      <p:sp>
-        <p:nvSpPr>
           <p:cNvPr id="112" name="TextBox 111">
             <a:extLst>
               <a:ext uri="{FF2B5EF4-FFF2-40B4-BE49-F238E27FC236}">
@@ -21358,7 +21240,7 @@
           <a:p>
             <a:r>
               <a:rPr lang="en-NL" sz="1100" dirty="0"/>
-              <a:t>accepting condition: { (L,K) } with L={v} and K={w}</a:t>
+              <a:t>accepting condition: { (L,K) } with L=∅ and K={v,w}</a:t>
             </a:r>
           </a:p>
         </p:txBody>
@@ -21398,54 +21280,6 @@
           </a:p>
         </p:txBody>
       </p:sp>
-      <p:cxnSp>
-        <p:nvCxnSpPr>
-          <p:cNvPr id="114" name="Curved Connector 113">
-            <a:extLst>
-              <a:ext uri="{FF2B5EF4-FFF2-40B4-BE49-F238E27FC236}">
-                <a16:creationId xmlns:a16="http://schemas.microsoft.com/office/drawing/2014/main" id="{70C7F0BF-CF1E-B007-1C29-3742D743F9AC}"/>
-              </a:ext>
-            </a:extLst>
-          </p:cNvPr>
-          <p:cNvCxnSpPr>
-            <a:cxnSpLocks/>
-            <a:stCxn id="103" idx="3"/>
-            <a:endCxn id="102" idx="5"/>
-          </p:cNvCxnSpPr>
-          <p:nvPr/>
-        </p:nvCxnSpPr>
-        <p:spPr>
-          <a:xfrm rot="5400000" flipH="1">
-            <a:off x="7422041" y="2459313"/>
-            <a:ext cx="2494" cy="1027198"/>
-          </a:xfrm>
-          <a:prstGeom prst="curvedConnector3">
-            <a:avLst>
-              <a:gd name="adj1" fmla="val -11154611"/>
-            </a:avLst>
-          </a:prstGeom>
-          <a:ln w="12700">
-            <a:solidFill>
-              <a:schemeClr val="tx1"/>
-            </a:solidFill>
-            <a:tailEnd type="triangle"/>
-          </a:ln>
-        </p:spPr>
-        <p:style>
-          <a:lnRef idx="1">
-            <a:schemeClr val="accent1"/>
-          </a:lnRef>
-          <a:fillRef idx="0">
-            <a:schemeClr val="accent1"/>
-          </a:fillRef>
-          <a:effectRef idx="0">
-            <a:schemeClr val="accent1"/>
-          </a:effectRef>
-          <a:fontRef idx="minor">
-            <a:schemeClr val="tx1"/>
-          </a:fontRef>
-        </p:style>
-      </p:cxnSp>
       <p:sp>
         <p:nvSpPr>
           <p:cNvPr id="115" name="TextBox 114">
@@ -21460,8 +21294,8 @@
         </p:nvSpPr>
         <p:spPr>
           <a:xfrm>
-            <a:off x="7180762" y="3207283"/>
-            <a:ext cx="1426994" cy="307777"/>
+            <a:off x="6973289" y="2362428"/>
+            <a:ext cx="896399" cy="523220"/>
           </a:xfrm>
           <a:prstGeom prst="rect">
             <a:avLst/>
@@ -21476,7 +21310,13 @@
           <a:p>
             <a:r>
               <a:rPr lang="en-NL" sz="1400" dirty="0"/>
-              <a:t>try∈ and succ∉ </a:t>
+              <a:t>try∉ and </a:t>
+            </a:r>
+          </a:p>
+          <a:p>
+            <a:r>
+              <a:rPr lang="en-NL" sz="1400" dirty="0"/>
+              <a:t>succ∈</a:t>
             </a:r>
           </a:p>
         </p:txBody>
@@ -21496,7 +21336,7 @@
         <p:spPr>
           <a:xfrm>
             <a:off x="8143020" y="2334066"/>
-            <a:ext cx="715260" cy="307777"/>
+            <a:ext cx="255198" cy="307777"/>
           </a:xfrm>
           <a:prstGeom prst="rect">
             <a:avLst/>
@@ -21511,7 +21351,7 @@
           <a:p>
             <a:r>
               <a:rPr lang="en-NL" sz="1400" dirty="0"/>
-              <a:t>succ ∈</a:t>
+              <a:t>*</a:t>
             </a:r>
           </a:p>
         </p:txBody>
@@ -22010,9 +21850,9 @@
             <a:avLst/>
           </a:prstGeom>
           <a:solidFill>
-            <a:schemeClr val="accent2">
-              <a:lumMod val="20000"/>
-              <a:lumOff val="80000"/>
+            <a:schemeClr val="accent4">
+              <a:lumMod val="40000"/>
+              <a:lumOff val="60000"/>
             </a:schemeClr>
           </a:solidFill>
           <a:ln>
@@ -22090,9 +21930,9 @@
             <a:avLst/>
           </a:prstGeom>
           <a:solidFill>
-            <a:schemeClr val="accent2">
-              <a:lumMod val="20000"/>
-              <a:lumOff val="80000"/>
+            <a:schemeClr val="accent4">
+              <a:lumMod val="40000"/>
+              <a:lumOff val="60000"/>
             </a:schemeClr>
           </a:solidFill>
           <a:ln>

</xml_diff>

<commit_message>
fixing Rabin for example-1
</commit_message>
<xml_diff>
--- a/slides/PV_pmc.pptx
+++ b/slides/PV_pmc.pptx
@@ -303,7 +303,7 @@
               <a:pPr>
                 <a:defRPr/>
               </a:pPr>
-              <a:t>10/24/25</a:t>
+              <a:t>10/27/25</a:t>
             </a:fld>
             <a:endParaRPr lang="en-US"/>
           </a:p>
@@ -16663,8 +16663,8 @@
         </p:nvSpPr>
         <p:spPr>
           <a:xfrm>
-            <a:off x="4234090" y="4839855"/>
-            <a:ext cx="4624190" cy="923330"/>
+            <a:off x="2936866" y="5475804"/>
+            <a:ext cx="5866242" cy="1323439"/>
           </a:xfrm>
           <a:prstGeom prst="rect">
             <a:avLst/>
@@ -16678,8 +16678,8 @@
           <a:lstStyle/>
           <a:p>
             <a:r>
-              <a:rPr lang="en-NL" dirty="0"/>
-              <a:t>As a Buchi, it is also a Rabin, with accepting condition: { (L,K) } with L=∅ and K={v,w}</a:t>
+              <a:rPr lang="en-NL" sz="1600" dirty="0"/>
+              <a:t>As a Buchi, it is also a Rabin, with accepting condition: { (L,K) } with L=∅ and K={v,w}. The state x is a ”sink” state; ending up there will deny establishing 𝜑. The state x is added to make outgoing arrows from v complete (defined for all possible combination of p and q).</a:t>
             </a:r>
           </a:p>
         </p:txBody>
@@ -16734,7 +16734,7 @@
         <p:spPr>
           <a:xfrm>
             <a:off x="4234090" y="2524609"/>
-            <a:ext cx="4527821" cy="923330"/>
+            <a:ext cx="4527821" cy="1477328"/>
           </a:xfrm>
           <a:prstGeom prst="rect">
             <a:avLst/>
@@ -16755,7 +16755,15 @@
           <a:p>
             <a:r>
               <a:rPr lang="en-NL" dirty="0"/>
-              <a:t>I give a deterministic Buchi: </a:t>
+              <a:t>I give a deterministic Buchi. For each state, you also need to cover </a:t>
+            </a:r>
+            <a:r>
+              <a:rPr lang="en-NL" b="1" dirty="0"/>
+              <a:t>all possible </a:t>
+            </a:r>
+            <a:r>
+              <a:rPr lang="en-NL" dirty="0"/>
+              <a:t>outgoing arrows. </a:t>
             </a:r>
           </a:p>
         </p:txBody>
@@ -16774,7 +16782,7 @@
         </p:nvSpPr>
         <p:spPr>
           <a:xfrm>
-            <a:off x="4990962" y="3838371"/>
+            <a:off x="5007895" y="4297736"/>
             <a:ext cx="355600" cy="338666"/>
           </a:xfrm>
           <a:prstGeom prst="ellipse">
@@ -16840,7 +16848,7 @@
         </p:nvSpPr>
         <p:spPr>
           <a:xfrm>
-            <a:off x="5937298" y="3838371"/>
+            <a:off x="5954231" y="4297736"/>
             <a:ext cx="355600" cy="338666"/>
           </a:xfrm>
           <a:prstGeom prst="ellipse">
@@ -16904,7 +16912,7 @@
         </p:nvSpPr>
         <p:spPr>
           <a:xfrm>
-            <a:off x="7215944" y="3840865"/>
+            <a:off x="7232877" y="4300230"/>
             <a:ext cx="355600" cy="338666"/>
           </a:xfrm>
           <a:prstGeom prst="ellipse">
@@ -16972,7 +16980,7 @@
         </p:nvCxnSpPr>
         <p:spPr>
           <a:xfrm>
-            <a:off x="5346562" y="4007704"/>
+            <a:off x="5363495" y="4467069"/>
             <a:ext cx="590736" cy="0"/>
           </a:xfrm>
           <a:prstGeom prst="straightConnector1">
@@ -17018,7 +17026,7 @@
         </p:nvCxnSpPr>
         <p:spPr>
           <a:xfrm>
-            <a:off x="6292898" y="4007704"/>
+            <a:off x="6309831" y="4467069"/>
             <a:ext cx="923046" cy="2494"/>
           </a:xfrm>
           <a:prstGeom prst="straightConnector1">
@@ -17064,7 +17072,7 @@
         </p:nvCxnSpPr>
         <p:spPr>
           <a:xfrm rot="5400000">
-            <a:off x="6115098" y="4001717"/>
+            <a:off x="6132031" y="4461082"/>
             <a:ext cx="12700" cy="251448"/>
           </a:xfrm>
           <a:prstGeom prst="curvedConnector3">
@@ -17112,7 +17120,7 @@
         </p:nvCxnSpPr>
         <p:spPr>
           <a:xfrm rot="5400000" flipH="1">
-            <a:off x="7399731" y="4010198"/>
+            <a:off x="7416664" y="4469563"/>
             <a:ext cx="239474" cy="12700"/>
           </a:xfrm>
           <a:prstGeom prst="curvedConnector5">
@@ -17160,7 +17168,7 @@
         </p:nvCxnSpPr>
         <p:spPr>
           <a:xfrm>
-            <a:off x="4781942" y="4018064"/>
+            <a:off x="4798875" y="4477429"/>
             <a:ext cx="187729" cy="0"/>
           </a:xfrm>
           <a:prstGeom prst="straightConnector1">
@@ -17202,7 +17210,7 @@
         </p:nvSpPr>
         <p:spPr>
           <a:xfrm>
-            <a:off x="5427728" y="3746745"/>
+            <a:off x="5444661" y="4206110"/>
             <a:ext cx="274434" cy="369332"/>
           </a:xfrm>
           <a:prstGeom prst="rect">
@@ -17237,7 +17245,7 @@
         </p:nvSpPr>
         <p:spPr>
           <a:xfrm>
-            <a:off x="5427728" y="4403653"/>
+            <a:off x="4971015" y="4828727"/>
             <a:ext cx="1426994" cy="307777"/>
           </a:xfrm>
           <a:prstGeom prst="rect">
@@ -17272,7 +17280,7 @@
         </p:nvSpPr>
         <p:spPr>
           <a:xfrm>
-            <a:off x="4357070" y="3824701"/>
+            <a:off x="4374003" y="4284066"/>
             <a:ext cx="415498" cy="369332"/>
           </a:xfrm>
           <a:prstGeom prst="rect">
@@ -17307,7 +17315,7 @@
         </p:nvSpPr>
         <p:spPr>
           <a:xfrm>
-            <a:off x="6417956" y="3740835"/>
+            <a:off x="6434889" y="4200200"/>
             <a:ext cx="665567" cy="307777"/>
           </a:xfrm>
           <a:prstGeom prst="rect">
@@ -17342,7 +17350,7 @@
         </p:nvSpPr>
         <p:spPr>
           <a:xfrm>
-            <a:off x="7861356" y="3876558"/>
+            <a:off x="7878289" y="4335923"/>
             <a:ext cx="255198" cy="307777"/>
           </a:xfrm>
           <a:prstGeom prst="rect">
@@ -17359,6 +17367,238 @@
             <a:r>
               <a:rPr lang="en-NL" sz="1400" dirty="0"/>
               <a:t>*</a:t>
+            </a:r>
+          </a:p>
+        </p:txBody>
+      </p:sp>
+      <p:sp>
+        <p:nvSpPr>
+          <p:cNvPr id="6" name="Oval 5">
+            <a:extLst>
+              <a:ext uri="{FF2B5EF4-FFF2-40B4-BE49-F238E27FC236}">
+                <a16:creationId xmlns:a16="http://schemas.microsoft.com/office/drawing/2014/main" id="{EFD50653-7E56-CFB3-FE61-10E6F7EE9F2E}"/>
+              </a:ext>
+            </a:extLst>
+          </p:cNvPr>
+          <p:cNvSpPr/>
+          <p:nvPr/>
+        </p:nvSpPr>
+        <p:spPr>
+          <a:xfrm>
+            <a:off x="7232877" y="4765362"/>
+            <a:ext cx="355600" cy="338666"/>
+          </a:xfrm>
+          <a:prstGeom prst="ellipse">
+            <a:avLst/>
+          </a:prstGeom>
+          <a:solidFill>
+            <a:schemeClr val="accent2">
+              <a:lumMod val="20000"/>
+              <a:lumOff val="80000"/>
+            </a:schemeClr>
+          </a:solidFill>
+          <a:ln>
+            <a:solidFill>
+              <a:schemeClr val="accent3">
+                <a:lumMod val="50000"/>
+              </a:schemeClr>
+            </a:solidFill>
+          </a:ln>
+        </p:spPr>
+        <p:style>
+          <a:lnRef idx="2">
+            <a:schemeClr val="accent1">
+              <a:shade val="50000"/>
+            </a:schemeClr>
+          </a:lnRef>
+          <a:fillRef idx="1">
+            <a:schemeClr val="accent1"/>
+          </a:fillRef>
+          <a:effectRef idx="0">
+            <a:schemeClr val="accent1"/>
+          </a:effectRef>
+          <a:fontRef idx="minor">
+            <a:schemeClr val="lt1"/>
+          </a:fontRef>
+        </p:style>
+        <p:txBody>
+          <a:bodyPr rtlCol="0" anchor="ctr"/>
+          <a:lstStyle/>
+          <a:p>
+            <a:pPr algn="ctr"/>
+            <a:r>
+              <a:rPr lang="en-NL" dirty="0">
+                <a:solidFill>
+                  <a:schemeClr val="tx1"/>
+                </a:solidFill>
+              </a:rPr>
+              <a:t>x</a:t>
+            </a:r>
+          </a:p>
+        </p:txBody>
+      </p:sp>
+      <p:cxnSp>
+        <p:nvCxnSpPr>
+          <p:cNvPr id="8" name="Straight Arrow Connector 7">
+            <a:extLst>
+              <a:ext uri="{FF2B5EF4-FFF2-40B4-BE49-F238E27FC236}">
+                <a16:creationId xmlns:a16="http://schemas.microsoft.com/office/drawing/2014/main" id="{1AAA8635-E33D-AED9-487F-D4B2DE6DE9D2}"/>
+              </a:ext>
+            </a:extLst>
+          </p:cNvPr>
+          <p:cNvCxnSpPr>
+            <a:cxnSpLocks/>
+            <a:stCxn id="73" idx="6"/>
+            <a:endCxn id="6" idx="1"/>
+          </p:cNvCxnSpPr>
+          <p:nvPr/>
+        </p:nvCxnSpPr>
+        <p:spPr>
+          <a:xfrm>
+            <a:off x="6309831" y="4467069"/>
+            <a:ext cx="975122" cy="347889"/>
+          </a:xfrm>
+          <a:prstGeom prst="straightConnector1">
+            <a:avLst/>
+          </a:prstGeom>
+          <a:ln w="12700">
+            <a:solidFill>
+              <a:schemeClr val="tx1"/>
+            </a:solidFill>
+            <a:tailEnd type="triangle"/>
+          </a:ln>
+        </p:spPr>
+        <p:style>
+          <a:lnRef idx="1">
+            <a:schemeClr val="accent1"/>
+          </a:lnRef>
+          <a:fillRef idx="0">
+            <a:schemeClr val="accent1"/>
+          </a:fillRef>
+          <a:effectRef idx="0">
+            <a:schemeClr val="accent1"/>
+          </a:effectRef>
+          <a:fontRef idx="minor">
+            <a:schemeClr val="tx1"/>
+          </a:fontRef>
+        </p:style>
+      </p:cxnSp>
+      <p:cxnSp>
+        <p:nvCxnSpPr>
+          <p:cNvPr id="12" name="Curved Connector 11">
+            <a:extLst>
+              <a:ext uri="{FF2B5EF4-FFF2-40B4-BE49-F238E27FC236}">
+                <a16:creationId xmlns:a16="http://schemas.microsoft.com/office/drawing/2014/main" id="{D9005422-AE60-A6E0-CB61-4BB73DE53C18}"/>
+              </a:ext>
+            </a:extLst>
+          </p:cNvPr>
+          <p:cNvCxnSpPr>
+            <a:cxnSpLocks/>
+            <a:stCxn id="6" idx="5"/>
+            <a:endCxn id="6" idx="7"/>
+          </p:cNvCxnSpPr>
+          <p:nvPr/>
+        </p:nvCxnSpPr>
+        <p:spPr>
+          <a:xfrm rot="5400000" flipH="1">
+            <a:off x="7416664" y="4934695"/>
+            <a:ext cx="239474" cy="12700"/>
+          </a:xfrm>
+          <a:prstGeom prst="curvedConnector5">
+            <a:avLst>
+              <a:gd name="adj1" fmla="val 3536"/>
+              <a:gd name="adj2" fmla="val -2123283"/>
+              <a:gd name="adj3" fmla="val 107070"/>
+            </a:avLst>
+          </a:prstGeom>
+          <a:ln w="12700">
+            <a:solidFill>
+              <a:schemeClr val="tx1"/>
+            </a:solidFill>
+            <a:tailEnd type="triangle"/>
+          </a:ln>
+        </p:spPr>
+        <p:style>
+          <a:lnRef idx="1">
+            <a:schemeClr val="accent1"/>
+          </a:lnRef>
+          <a:fillRef idx="0">
+            <a:schemeClr val="accent1"/>
+          </a:fillRef>
+          <a:effectRef idx="0">
+            <a:schemeClr val="accent1"/>
+          </a:effectRef>
+          <a:fontRef idx="minor">
+            <a:schemeClr val="tx1"/>
+          </a:fontRef>
+        </p:style>
+      </p:cxnSp>
+      <p:sp>
+        <p:nvSpPr>
+          <p:cNvPr id="24" name="TextBox 23">
+            <a:extLst>
+              <a:ext uri="{FF2B5EF4-FFF2-40B4-BE49-F238E27FC236}">
+                <a16:creationId xmlns:a16="http://schemas.microsoft.com/office/drawing/2014/main" id="{8A810C04-A25E-7864-7154-A3DB942A2DBF}"/>
+              </a:ext>
+            </a:extLst>
+          </p:cNvPr>
+          <p:cNvSpPr txBox="1"/>
+          <p:nvPr/>
+        </p:nvSpPr>
+        <p:spPr>
+          <a:xfrm>
+            <a:off x="7758052" y="4814958"/>
+            <a:ext cx="255198" cy="307777"/>
+          </a:xfrm>
+          <a:prstGeom prst="rect">
+            <a:avLst/>
+          </a:prstGeom>
+          <a:noFill/>
+        </p:spPr>
+        <p:txBody>
+          <a:bodyPr wrap="none" rtlCol="0">
+            <a:spAutoFit/>
+          </a:bodyPr>
+          <a:lstStyle/>
+          <a:p>
+            <a:r>
+              <a:rPr lang="en-NL" sz="1400" dirty="0"/>
+              <a:t>*</a:t>
+            </a:r>
+          </a:p>
+        </p:txBody>
+      </p:sp>
+      <p:sp>
+        <p:nvSpPr>
+          <p:cNvPr id="39" name="TextBox 38">
+            <a:extLst>
+              <a:ext uri="{FF2B5EF4-FFF2-40B4-BE49-F238E27FC236}">
+                <a16:creationId xmlns:a16="http://schemas.microsoft.com/office/drawing/2014/main" id="{46BB3C1E-B802-C919-19E1-7D08954E6E43}"/>
+              </a:ext>
+            </a:extLst>
+          </p:cNvPr>
+          <p:cNvSpPr txBox="1"/>
+          <p:nvPr/>
+        </p:nvSpPr>
+        <p:spPr>
+          <a:xfrm>
+            <a:off x="6367977" y="4650762"/>
+            <a:ext cx="1039525" cy="523220"/>
+          </a:xfrm>
+          <a:prstGeom prst="rect">
+            <a:avLst/>
+          </a:prstGeom>
+          <a:noFill/>
+        </p:spPr>
+        <p:txBody>
+          <a:bodyPr wrap="square" rtlCol="0">
+            <a:spAutoFit/>
+          </a:bodyPr>
+          <a:lstStyle/>
+          <a:p>
+            <a:r>
+              <a:rPr lang="en-NL" sz="1400" dirty="0"/>
+              <a:t>try∉ and succ∉ </a:t>
             </a:r>
           </a:p>
         </p:txBody>
@@ -20662,8 +20902,8 @@
         </p:nvSpPr>
         <p:spPr>
           <a:xfrm flipH="1">
-            <a:off x="937215" y="5804672"/>
-            <a:ext cx="7547380" cy="738664"/>
+            <a:off x="841140" y="5472733"/>
+            <a:ext cx="3553816" cy="1169551"/>
           </a:xfrm>
           <a:prstGeom prst="rect">
             <a:avLst/>
@@ -20676,6 +20916,7 @@
           </a:bodyPr>
           <a:lstStyle/>
           <a:p>
+            <a:pPr algn="just"/>
             <a:r>
               <a:rPr lang="en-NL" sz="1400" dirty="0"/>
               <a:t>This results in a new Rabin R2. Any state (s,t) in R2 with t in R’s L is marked as L in R2.  If t was in R’s K, we mark (s,t) as K in R2. So, for above example we get L is empty, and all the blue states are K.</a:t>
@@ -20720,10 +20961,45 @@
       </p:sp>
       <p:sp>
         <p:nvSpPr>
-          <p:cNvPr id="101" name="Oval 100">
+          <p:cNvPr id="112" name="TextBox 111">
             <a:extLst>
               <a:ext uri="{FF2B5EF4-FFF2-40B4-BE49-F238E27FC236}">
-                <a16:creationId xmlns:a16="http://schemas.microsoft.com/office/drawing/2014/main" id="{030BE598-A711-7788-BA0F-7DACA59AA136}"/>
+                <a16:creationId xmlns:a16="http://schemas.microsoft.com/office/drawing/2014/main" id="{EF1872DE-8FD9-C8FA-0E31-965FDDC58980}"/>
+              </a:ext>
+            </a:extLst>
+          </p:cNvPr>
+          <p:cNvSpPr txBox="1"/>
+          <p:nvPr/>
+        </p:nvSpPr>
+        <p:spPr>
+          <a:xfrm>
+            <a:off x="5380316" y="3471727"/>
+            <a:ext cx="3413013" cy="261610"/>
+          </a:xfrm>
+          <a:prstGeom prst="rect">
+            <a:avLst/>
+          </a:prstGeom>
+          <a:noFill/>
+        </p:spPr>
+        <p:txBody>
+          <a:bodyPr wrap="square" rtlCol="0">
+            <a:spAutoFit/>
+          </a:bodyPr>
+          <a:lstStyle/>
+          <a:p>
+            <a:r>
+              <a:rPr lang="en-NL" sz="1100" dirty="0"/>
+              <a:t>accepting condition: { (L,K) } with L=∅ and K={v,w}</a:t>
+            </a:r>
+          </a:p>
+        </p:txBody>
+      </p:sp>
+      <p:sp>
+        <p:nvSpPr>
+          <p:cNvPr id="5" name="Oval 4">
+            <a:extLst>
+              <a:ext uri="{FF2B5EF4-FFF2-40B4-BE49-F238E27FC236}">
+                <a16:creationId xmlns:a16="http://schemas.microsoft.com/office/drawing/2014/main" id="{8A07220D-23D6-FB73-EF0C-4DD33A169825}"/>
               </a:ext>
             </a:extLst>
           </p:cNvPr>
@@ -20732,7 +21008,7 @@
         </p:nvSpPr>
         <p:spPr>
           <a:xfrm>
-            <a:off x="5659829" y="2682595"/>
+            <a:off x="5631921" y="2663240"/>
             <a:ext cx="355600" cy="338666"/>
           </a:xfrm>
           <a:prstGeom prst="ellipse">
@@ -20786,10 +21062,10 @@
       </p:sp>
       <p:sp>
         <p:nvSpPr>
-          <p:cNvPr id="102" name="Oval 101">
+          <p:cNvPr id="8" name="Oval 7">
             <a:extLst>
               <a:ext uri="{FF2B5EF4-FFF2-40B4-BE49-F238E27FC236}">
-                <a16:creationId xmlns:a16="http://schemas.microsoft.com/office/drawing/2014/main" id="{5C7C29BA-A82F-A3F5-D4EA-0BA6A19148E2}"/>
+                <a16:creationId xmlns:a16="http://schemas.microsoft.com/office/drawing/2014/main" id="{443508B1-38C8-1692-1A74-462AEEFDF166}"/>
               </a:ext>
             </a:extLst>
           </p:cNvPr>
@@ -20798,7 +21074,7 @@
         </p:nvSpPr>
         <p:spPr>
           <a:xfrm>
-            <a:off x="6606165" y="2682595"/>
+            <a:off x="6578257" y="2663240"/>
             <a:ext cx="355600" cy="338666"/>
           </a:xfrm>
           <a:prstGeom prst="ellipse">
@@ -20850,10 +21126,10 @@
       </p:sp>
       <p:sp>
         <p:nvSpPr>
-          <p:cNvPr id="103" name="Oval 102">
+          <p:cNvPr id="9" name="Oval 8">
             <a:extLst>
               <a:ext uri="{FF2B5EF4-FFF2-40B4-BE49-F238E27FC236}">
-                <a16:creationId xmlns:a16="http://schemas.microsoft.com/office/drawing/2014/main" id="{3FF467F4-2E79-E7A4-D47F-65338FD87566}"/>
+                <a16:creationId xmlns:a16="http://schemas.microsoft.com/office/drawing/2014/main" id="{DBFD344C-D526-A150-CCAF-E51A3815A173}"/>
               </a:ext>
             </a:extLst>
           </p:cNvPr>
@@ -20862,7 +21138,7 @@
         </p:nvSpPr>
         <p:spPr>
           <a:xfrm>
-            <a:off x="7884811" y="2685089"/>
+            <a:off x="7856903" y="2665734"/>
             <a:ext cx="355600" cy="338666"/>
           </a:xfrm>
           <a:prstGeom prst="ellipse">
@@ -20914,23 +21190,23 @@
       </p:sp>
       <p:cxnSp>
         <p:nvCxnSpPr>
-          <p:cNvPr id="104" name="Straight Arrow Connector 103">
+          <p:cNvPr id="10" name="Straight Arrow Connector 9">
             <a:extLst>
               <a:ext uri="{FF2B5EF4-FFF2-40B4-BE49-F238E27FC236}">
-                <a16:creationId xmlns:a16="http://schemas.microsoft.com/office/drawing/2014/main" id="{62F50790-786E-96BE-2D32-002A79E1C382}"/>
+                <a16:creationId xmlns:a16="http://schemas.microsoft.com/office/drawing/2014/main" id="{B651531C-4AB5-4EDA-AE66-9339D2AA30C0}"/>
               </a:ext>
             </a:extLst>
           </p:cNvPr>
           <p:cNvCxnSpPr>
             <a:cxnSpLocks/>
-            <a:stCxn id="101" idx="6"/>
-            <a:endCxn id="102" idx="2"/>
+            <a:stCxn id="5" idx="6"/>
+            <a:endCxn id="8" idx="2"/>
           </p:cNvCxnSpPr>
           <p:nvPr/>
         </p:nvCxnSpPr>
         <p:spPr>
           <a:xfrm>
-            <a:off x="6015429" y="2851928"/>
+            <a:off x="5987521" y="2832573"/>
             <a:ext cx="590736" cy="0"/>
           </a:xfrm>
           <a:prstGeom prst="straightConnector1">
@@ -20960,23 +21236,23 @@
       </p:cxnSp>
       <p:cxnSp>
         <p:nvCxnSpPr>
-          <p:cNvPr id="105" name="Straight Arrow Connector 104">
+          <p:cNvPr id="12" name="Straight Arrow Connector 11">
             <a:extLst>
               <a:ext uri="{FF2B5EF4-FFF2-40B4-BE49-F238E27FC236}">
-                <a16:creationId xmlns:a16="http://schemas.microsoft.com/office/drawing/2014/main" id="{3CE849C9-2FCB-C0F4-1E62-20D60C5B2371}"/>
+                <a16:creationId xmlns:a16="http://schemas.microsoft.com/office/drawing/2014/main" id="{2AFA1007-51A2-9869-3AA3-DFC8890F0A58}"/>
               </a:ext>
             </a:extLst>
           </p:cNvPr>
           <p:cNvCxnSpPr>
             <a:cxnSpLocks/>
-            <a:stCxn id="102" idx="6"/>
-            <a:endCxn id="103" idx="2"/>
+            <a:stCxn id="8" idx="6"/>
+            <a:endCxn id="9" idx="2"/>
           </p:cNvCxnSpPr>
           <p:nvPr/>
         </p:nvCxnSpPr>
         <p:spPr>
           <a:xfrm>
-            <a:off x="6961765" y="2851928"/>
+            <a:off x="6933857" y="2832573"/>
             <a:ext cx="923046" cy="2494"/>
           </a:xfrm>
           <a:prstGeom prst="straightConnector1">
@@ -21006,23 +21282,23 @@
       </p:cxnSp>
       <p:cxnSp>
         <p:nvCxnSpPr>
-          <p:cNvPr id="106" name="Curved Connector 105">
+          <p:cNvPr id="14" name="Curved Connector 13">
             <a:extLst>
               <a:ext uri="{FF2B5EF4-FFF2-40B4-BE49-F238E27FC236}">
-                <a16:creationId xmlns:a16="http://schemas.microsoft.com/office/drawing/2014/main" id="{381C7812-7B3D-E583-59A9-239C4B862ED1}"/>
+                <a16:creationId xmlns:a16="http://schemas.microsoft.com/office/drawing/2014/main" id="{7B0B91FF-4817-01B9-8FEB-CBE14F4DFCD7}"/>
               </a:ext>
             </a:extLst>
           </p:cNvPr>
           <p:cNvCxnSpPr>
             <a:cxnSpLocks/>
-            <a:stCxn id="102" idx="5"/>
-            <a:endCxn id="102" idx="3"/>
+            <a:stCxn id="8" idx="5"/>
+            <a:endCxn id="8" idx="3"/>
           </p:cNvCxnSpPr>
           <p:nvPr/>
         </p:nvCxnSpPr>
         <p:spPr>
           <a:xfrm rot="5400000">
-            <a:off x="6783965" y="2845941"/>
+            <a:off x="6756057" y="2826586"/>
             <a:ext cx="12700" cy="251448"/>
           </a:xfrm>
           <a:prstGeom prst="curvedConnector3">
@@ -21054,23 +21330,23 @@
       </p:cxnSp>
       <p:cxnSp>
         <p:nvCxnSpPr>
-          <p:cNvPr id="107" name="Curved Connector 106">
+          <p:cNvPr id="17" name="Curved Connector 16">
             <a:extLst>
               <a:ext uri="{FF2B5EF4-FFF2-40B4-BE49-F238E27FC236}">
-                <a16:creationId xmlns:a16="http://schemas.microsoft.com/office/drawing/2014/main" id="{76695BA0-7202-AE09-AD97-3882BADDB95B}"/>
+                <a16:creationId xmlns:a16="http://schemas.microsoft.com/office/drawing/2014/main" id="{A525ABA5-D332-B8C6-CE4A-97108C014E4C}"/>
               </a:ext>
             </a:extLst>
           </p:cNvPr>
           <p:cNvCxnSpPr>
             <a:cxnSpLocks/>
-            <a:stCxn id="103" idx="5"/>
-            <a:endCxn id="103" idx="7"/>
+            <a:stCxn id="9" idx="5"/>
+            <a:endCxn id="9" idx="7"/>
           </p:cNvCxnSpPr>
           <p:nvPr/>
         </p:nvCxnSpPr>
         <p:spPr>
           <a:xfrm rot="5400000" flipH="1">
-            <a:off x="8068598" y="2854422"/>
+            <a:off x="8040690" y="2835067"/>
             <a:ext cx="239474" cy="12700"/>
           </a:xfrm>
           <a:prstGeom prst="curvedConnector5">
@@ -21104,10 +21380,10 @@
       </p:cxnSp>
       <p:cxnSp>
         <p:nvCxnSpPr>
-          <p:cNvPr id="108" name="Straight Arrow Connector 107">
+          <p:cNvPr id="18" name="Straight Arrow Connector 17">
             <a:extLst>
               <a:ext uri="{FF2B5EF4-FFF2-40B4-BE49-F238E27FC236}">
-                <a16:creationId xmlns:a16="http://schemas.microsoft.com/office/drawing/2014/main" id="{BD50A127-3AF7-F9EB-9DC0-F1976A3FFB12}"/>
+                <a16:creationId xmlns:a16="http://schemas.microsoft.com/office/drawing/2014/main" id="{E3554F60-8094-3240-8878-1B2BD9EE9AD6}"/>
               </a:ext>
             </a:extLst>
           </p:cNvPr>
@@ -21118,7 +21394,7 @@
         </p:nvCxnSpPr>
         <p:spPr>
           <a:xfrm>
-            <a:off x="5450809" y="2862288"/>
+            <a:off x="5422901" y="2842933"/>
             <a:ext cx="187729" cy="0"/>
           </a:xfrm>
           <a:prstGeom prst="straightConnector1">
@@ -21148,10 +21424,10 @@
       </p:cxnSp>
       <p:sp>
         <p:nvSpPr>
-          <p:cNvPr id="109" name="TextBox 108">
+          <p:cNvPr id="19" name="TextBox 18">
             <a:extLst>
               <a:ext uri="{FF2B5EF4-FFF2-40B4-BE49-F238E27FC236}">
-                <a16:creationId xmlns:a16="http://schemas.microsoft.com/office/drawing/2014/main" id="{48473050-A614-A7AE-6840-0339BEE630C1}"/>
+                <a16:creationId xmlns:a16="http://schemas.microsoft.com/office/drawing/2014/main" id="{159948F0-1D7B-3C72-3C81-513BB02AA6FE}"/>
               </a:ext>
             </a:extLst>
           </p:cNvPr>
@@ -21160,7 +21436,7 @@
         </p:nvSpPr>
         <p:spPr>
           <a:xfrm>
-            <a:off x="6096595" y="2590969"/>
+            <a:off x="6068687" y="2571614"/>
             <a:ext cx="274434" cy="369332"/>
           </a:xfrm>
           <a:prstGeom prst="rect">
@@ -21183,10 +21459,10 @@
       </p:sp>
       <p:sp>
         <p:nvSpPr>
-          <p:cNvPr id="110" name="TextBox 109">
+          <p:cNvPr id="21" name="TextBox 20">
             <a:extLst>
               <a:ext uri="{FF2B5EF4-FFF2-40B4-BE49-F238E27FC236}">
-                <a16:creationId xmlns:a16="http://schemas.microsoft.com/office/drawing/2014/main" id="{4D2C331E-968D-3A3A-3998-BED7365D18FB}"/>
+                <a16:creationId xmlns:a16="http://schemas.microsoft.com/office/drawing/2014/main" id="{75D9D75A-8F44-2E3C-5C10-1EA4DA9C9F37}"/>
               </a:ext>
             </a:extLst>
           </p:cNvPr>
@@ -21195,7 +21471,7 @@
         </p:nvSpPr>
         <p:spPr>
           <a:xfrm>
-            <a:off x="5659829" y="3188681"/>
+            <a:off x="5595041" y="3194231"/>
             <a:ext cx="1426994" cy="307777"/>
           </a:xfrm>
           <a:prstGeom prst="rect">
@@ -21218,10 +21494,10 @@
       </p:sp>
       <p:sp>
         <p:nvSpPr>
-          <p:cNvPr id="112" name="TextBox 111">
+          <p:cNvPr id="22" name="TextBox 21">
             <a:extLst>
               <a:ext uri="{FF2B5EF4-FFF2-40B4-BE49-F238E27FC236}">
-                <a16:creationId xmlns:a16="http://schemas.microsoft.com/office/drawing/2014/main" id="{EF1872DE-8FD9-C8FA-0E31-965FDDC58980}"/>
+                <a16:creationId xmlns:a16="http://schemas.microsoft.com/office/drawing/2014/main" id="{47B8684D-D255-0EB0-F1A0-47F96E2610EE}"/>
               </a:ext>
             </a:extLst>
           </p:cNvPr>
@@ -21230,42 +21506,7 @@
         </p:nvSpPr>
         <p:spPr>
           <a:xfrm>
-            <a:off x="5380316" y="3471727"/>
-            <a:ext cx="3413013" cy="261610"/>
-          </a:xfrm>
-          <a:prstGeom prst="rect">
-            <a:avLst/>
-          </a:prstGeom>
-          <a:noFill/>
-        </p:spPr>
-        <p:txBody>
-          <a:bodyPr wrap="square" rtlCol="0">
-            <a:spAutoFit/>
-          </a:bodyPr>
-          <a:lstStyle/>
-          <a:p>
-            <a:r>
-              <a:rPr lang="en-NL" sz="1100" dirty="0"/>
-              <a:t>accepting condition: { (L,K) } with L=∅ and K={v,w}</a:t>
-            </a:r>
-          </a:p>
-        </p:txBody>
-      </p:sp>
-      <p:sp>
-        <p:nvSpPr>
-          <p:cNvPr id="113" name="TextBox 112">
-            <a:extLst>
-              <a:ext uri="{FF2B5EF4-FFF2-40B4-BE49-F238E27FC236}">
-                <a16:creationId xmlns:a16="http://schemas.microsoft.com/office/drawing/2014/main" id="{0F185175-2CCB-3400-E610-A602D8296A77}"/>
-              </a:ext>
-            </a:extLst>
-          </p:cNvPr>
-          <p:cNvSpPr txBox="1"/>
-          <p:nvPr/>
-        </p:nvSpPr>
-        <p:spPr>
-          <a:xfrm>
-            <a:off x="5025937" y="2668925"/>
+            <a:off x="4998029" y="2649570"/>
             <a:ext cx="415498" cy="369332"/>
           </a:xfrm>
           <a:prstGeom prst="rect">
@@ -21288,10 +21529,10 @@
       </p:sp>
       <p:sp>
         <p:nvSpPr>
-          <p:cNvPr id="115" name="TextBox 114">
+          <p:cNvPr id="23" name="TextBox 22">
             <a:extLst>
               <a:ext uri="{FF2B5EF4-FFF2-40B4-BE49-F238E27FC236}">
-                <a16:creationId xmlns:a16="http://schemas.microsoft.com/office/drawing/2014/main" id="{3DDBAF63-4E0D-77EC-EEFA-A306D2D0E262}"/>
+                <a16:creationId xmlns:a16="http://schemas.microsoft.com/office/drawing/2014/main" id="{D9DE2ADF-C84C-DA72-5B7C-F4DCC26B436A}"/>
               </a:ext>
             </a:extLst>
           </p:cNvPr>
@@ -21300,7 +21541,7 @@
         </p:nvSpPr>
         <p:spPr>
           <a:xfrm>
-            <a:off x="7058139" y="2548079"/>
+            <a:off x="7058915" y="2565704"/>
             <a:ext cx="665567" cy="307777"/>
           </a:xfrm>
           <a:prstGeom prst="rect">
@@ -21323,10 +21564,10 @@
       </p:sp>
       <p:sp>
         <p:nvSpPr>
-          <p:cNvPr id="116" name="TextBox 115">
+          <p:cNvPr id="24" name="TextBox 23">
             <a:extLst>
               <a:ext uri="{FF2B5EF4-FFF2-40B4-BE49-F238E27FC236}">
-                <a16:creationId xmlns:a16="http://schemas.microsoft.com/office/drawing/2014/main" id="{860A6590-CE94-4DCF-15C9-CBB98A76E3F9}"/>
+                <a16:creationId xmlns:a16="http://schemas.microsoft.com/office/drawing/2014/main" id="{28B955E0-9567-85CA-1776-1F9A3D7D85AC}"/>
               </a:ext>
             </a:extLst>
           </p:cNvPr>
@@ -21335,7 +21576,7 @@
         </p:nvSpPr>
         <p:spPr>
           <a:xfrm>
-            <a:off x="8143020" y="2334066"/>
+            <a:off x="8502315" y="2701427"/>
             <a:ext cx="255198" cy="307777"/>
           </a:xfrm>
           <a:prstGeom prst="rect">
@@ -21352,6 +21593,929 @@
             <a:r>
               <a:rPr lang="en-NL" sz="1400" dirty="0"/>
               <a:t>*</a:t>
+            </a:r>
+          </a:p>
+        </p:txBody>
+      </p:sp>
+      <p:sp>
+        <p:nvSpPr>
+          <p:cNvPr id="26" name="Oval 25">
+            <a:extLst>
+              <a:ext uri="{FF2B5EF4-FFF2-40B4-BE49-F238E27FC236}">
+                <a16:creationId xmlns:a16="http://schemas.microsoft.com/office/drawing/2014/main" id="{C762F6C6-0F26-9BE4-EF50-85275E6787E9}"/>
+              </a:ext>
+            </a:extLst>
+          </p:cNvPr>
+          <p:cNvSpPr/>
+          <p:nvPr/>
+        </p:nvSpPr>
+        <p:spPr>
+          <a:xfrm>
+            <a:off x="7856903" y="3130866"/>
+            <a:ext cx="355600" cy="338666"/>
+          </a:xfrm>
+          <a:prstGeom prst="ellipse">
+            <a:avLst/>
+          </a:prstGeom>
+          <a:solidFill>
+            <a:schemeClr val="accent2">
+              <a:lumMod val="20000"/>
+              <a:lumOff val="80000"/>
+            </a:schemeClr>
+          </a:solidFill>
+          <a:ln>
+            <a:solidFill>
+              <a:schemeClr val="accent3">
+                <a:lumMod val="50000"/>
+              </a:schemeClr>
+            </a:solidFill>
+          </a:ln>
+        </p:spPr>
+        <p:style>
+          <a:lnRef idx="2">
+            <a:schemeClr val="accent1">
+              <a:shade val="50000"/>
+            </a:schemeClr>
+          </a:lnRef>
+          <a:fillRef idx="1">
+            <a:schemeClr val="accent1"/>
+          </a:fillRef>
+          <a:effectRef idx="0">
+            <a:schemeClr val="accent1"/>
+          </a:effectRef>
+          <a:fontRef idx="minor">
+            <a:schemeClr val="lt1"/>
+          </a:fontRef>
+        </p:style>
+        <p:txBody>
+          <a:bodyPr rtlCol="0" anchor="ctr"/>
+          <a:lstStyle/>
+          <a:p>
+            <a:pPr algn="ctr"/>
+            <a:r>
+              <a:rPr lang="en-NL" dirty="0">
+                <a:solidFill>
+                  <a:schemeClr val="tx1"/>
+                </a:solidFill>
+              </a:rPr>
+              <a:t>x</a:t>
+            </a:r>
+          </a:p>
+        </p:txBody>
+      </p:sp>
+      <p:cxnSp>
+        <p:nvCxnSpPr>
+          <p:cNvPr id="27" name="Straight Arrow Connector 26">
+            <a:extLst>
+              <a:ext uri="{FF2B5EF4-FFF2-40B4-BE49-F238E27FC236}">
+                <a16:creationId xmlns:a16="http://schemas.microsoft.com/office/drawing/2014/main" id="{001EDE7B-93A2-4281-479A-AA84FE01D775}"/>
+              </a:ext>
+            </a:extLst>
+          </p:cNvPr>
+          <p:cNvCxnSpPr>
+            <a:cxnSpLocks/>
+            <a:stCxn id="8" idx="6"/>
+            <a:endCxn id="26" idx="1"/>
+          </p:cNvCxnSpPr>
+          <p:nvPr/>
+        </p:nvCxnSpPr>
+        <p:spPr>
+          <a:xfrm>
+            <a:off x="6933857" y="2832573"/>
+            <a:ext cx="975122" cy="347889"/>
+          </a:xfrm>
+          <a:prstGeom prst="straightConnector1">
+            <a:avLst/>
+          </a:prstGeom>
+          <a:ln w="12700">
+            <a:solidFill>
+              <a:schemeClr val="tx1"/>
+            </a:solidFill>
+            <a:tailEnd type="triangle"/>
+          </a:ln>
+        </p:spPr>
+        <p:style>
+          <a:lnRef idx="1">
+            <a:schemeClr val="accent1"/>
+          </a:lnRef>
+          <a:fillRef idx="0">
+            <a:schemeClr val="accent1"/>
+          </a:fillRef>
+          <a:effectRef idx="0">
+            <a:schemeClr val="accent1"/>
+          </a:effectRef>
+          <a:fontRef idx="minor">
+            <a:schemeClr val="tx1"/>
+          </a:fontRef>
+        </p:style>
+      </p:cxnSp>
+      <p:cxnSp>
+        <p:nvCxnSpPr>
+          <p:cNvPr id="31" name="Curved Connector 30">
+            <a:extLst>
+              <a:ext uri="{FF2B5EF4-FFF2-40B4-BE49-F238E27FC236}">
+                <a16:creationId xmlns:a16="http://schemas.microsoft.com/office/drawing/2014/main" id="{7A7BC4AB-2036-F78B-43D4-96A1E824E7E9}"/>
+              </a:ext>
+            </a:extLst>
+          </p:cNvPr>
+          <p:cNvCxnSpPr>
+            <a:cxnSpLocks/>
+            <a:stCxn id="26" idx="5"/>
+            <a:endCxn id="26" idx="7"/>
+          </p:cNvCxnSpPr>
+          <p:nvPr/>
+        </p:nvCxnSpPr>
+        <p:spPr>
+          <a:xfrm rot="5400000" flipH="1">
+            <a:off x="8040690" y="3300199"/>
+            <a:ext cx="239474" cy="12700"/>
+          </a:xfrm>
+          <a:prstGeom prst="curvedConnector5">
+            <a:avLst>
+              <a:gd name="adj1" fmla="val 3536"/>
+              <a:gd name="adj2" fmla="val -2123283"/>
+              <a:gd name="adj3" fmla="val 107070"/>
+            </a:avLst>
+          </a:prstGeom>
+          <a:ln w="12700">
+            <a:solidFill>
+              <a:schemeClr val="tx1"/>
+            </a:solidFill>
+            <a:tailEnd type="triangle"/>
+          </a:ln>
+        </p:spPr>
+        <p:style>
+          <a:lnRef idx="1">
+            <a:schemeClr val="accent1"/>
+          </a:lnRef>
+          <a:fillRef idx="0">
+            <a:schemeClr val="accent1"/>
+          </a:fillRef>
+          <a:effectRef idx="0">
+            <a:schemeClr val="accent1"/>
+          </a:effectRef>
+          <a:fontRef idx="minor">
+            <a:schemeClr val="tx1"/>
+          </a:fontRef>
+        </p:style>
+      </p:cxnSp>
+      <p:sp>
+        <p:nvSpPr>
+          <p:cNvPr id="32" name="TextBox 31">
+            <a:extLst>
+              <a:ext uri="{FF2B5EF4-FFF2-40B4-BE49-F238E27FC236}">
+                <a16:creationId xmlns:a16="http://schemas.microsoft.com/office/drawing/2014/main" id="{DE289571-7E4A-E8E0-DE54-059FD5E3130F}"/>
+              </a:ext>
+            </a:extLst>
+          </p:cNvPr>
+          <p:cNvSpPr txBox="1"/>
+          <p:nvPr/>
+        </p:nvSpPr>
+        <p:spPr>
+          <a:xfrm>
+            <a:off x="8382078" y="3180462"/>
+            <a:ext cx="255198" cy="307777"/>
+          </a:xfrm>
+          <a:prstGeom prst="rect">
+            <a:avLst/>
+          </a:prstGeom>
+          <a:noFill/>
+        </p:spPr>
+        <p:txBody>
+          <a:bodyPr wrap="none" rtlCol="0">
+            <a:spAutoFit/>
+          </a:bodyPr>
+          <a:lstStyle/>
+          <a:p>
+            <a:r>
+              <a:rPr lang="en-NL" sz="1400" dirty="0"/>
+              <a:t>*</a:t>
+            </a:r>
+          </a:p>
+        </p:txBody>
+      </p:sp>
+      <p:sp>
+        <p:nvSpPr>
+          <p:cNvPr id="33" name="Oval 32">
+            <a:extLst>
+              <a:ext uri="{FF2B5EF4-FFF2-40B4-BE49-F238E27FC236}">
+                <a16:creationId xmlns:a16="http://schemas.microsoft.com/office/drawing/2014/main" id="{990EEDC5-C2A5-C616-4CD2-CB1793DA937D}"/>
+              </a:ext>
+            </a:extLst>
+          </p:cNvPr>
+          <p:cNvSpPr/>
+          <p:nvPr/>
+        </p:nvSpPr>
+        <p:spPr>
+          <a:xfrm>
+            <a:off x="5794375" y="5256936"/>
+            <a:ext cx="676570" cy="369332"/>
+          </a:xfrm>
+          <a:prstGeom prst="ellipse">
+            <a:avLst/>
+          </a:prstGeom>
+          <a:solidFill>
+            <a:schemeClr val="accent2">
+              <a:lumMod val="20000"/>
+              <a:lumOff val="80000"/>
+            </a:schemeClr>
+          </a:solidFill>
+          <a:ln>
+            <a:solidFill>
+              <a:schemeClr val="tx1"/>
+            </a:solidFill>
+          </a:ln>
+        </p:spPr>
+        <p:style>
+          <a:lnRef idx="2">
+            <a:schemeClr val="accent1">
+              <a:shade val="50000"/>
+            </a:schemeClr>
+          </a:lnRef>
+          <a:fillRef idx="1">
+            <a:schemeClr val="accent1"/>
+          </a:fillRef>
+          <a:effectRef idx="0">
+            <a:schemeClr val="accent1"/>
+          </a:effectRef>
+          <a:fontRef idx="minor">
+            <a:schemeClr val="lt1"/>
+          </a:fontRef>
+        </p:style>
+        <p:txBody>
+          <a:bodyPr rtlCol="0" anchor="ctr"/>
+          <a:lstStyle/>
+          <a:p>
+            <a:pPr algn="ctr"/>
+            <a:r>
+              <a:rPr lang="en-NL" sz="1400" dirty="0">
+                <a:solidFill>
+                  <a:schemeClr val="tx1"/>
+                </a:solidFill>
+              </a:rPr>
+              <a:t>s</a:t>
+            </a:r>
+            <a:r>
+              <a:rPr lang="en-NL" sz="1400" baseline="-25000" dirty="0">
+                <a:solidFill>
+                  <a:schemeClr val="tx1"/>
+                </a:solidFill>
+              </a:rPr>
+              <a:t>2</a:t>
+            </a:r>
+            <a:r>
+              <a:rPr lang="en-NL" sz="1400" dirty="0">
+                <a:solidFill>
+                  <a:schemeClr val="tx1"/>
+                </a:solidFill>
+              </a:rPr>
+              <a:t>,x</a:t>
+            </a:r>
+          </a:p>
+        </p:txBody>
+      </p:sp>
+      <p:cxnSp>
+        <p:nvCxnSpPr>
+          <p:cNvPr id="42" name="Straight Arrow Connector 41">
+            <a:extLst>
+              <a:ext uri="{FF2B5EF4-FFF2-40B4-BE49-F238E27FC236}">
+                <a16:creationId xmlns:a16="http://schemas.microsoft.com/office/drawing/2014/main" id="{A38B1AF0-1E79-8A7C-CD2A-1C72B91530A1}"/>
+              </a:ext>
+            </a:extLst>
+          </p:cNvPr>
+          <p:cNvCxnSpPr>
+            <a:cxnSpLocks/>
+            <a:stCxn id="35" idx="5"/>
+            <a:endCxn id="33" idx="1"/>
+          </p:cNvCxnSpPr>
+          <p:nvPr/>
+        </p:nvCxnSpPr>
+        <p:spPr>
+          <a:xfrm>
+            <a:off x="5076434" y="5089075"/>
+            <a:ext cx="817022" cy="221948"/>
+          </a:xfrm>
+          <a:prstGeom prst="straightConnector1">
+            <a:avLst/>
+          </a:prstGeom>
+          <a:ln w="12700">
+            <a:solidFill>
+              <a:schemeClr val="tx1"/>
+            </a:solidFill>
+            <a:tailEnd type="triangle"/>
+          </a:ln>
+        </p:spPr>
+        <p:style>
+          <a:lnRef idx="1">
+            <a:schemeClr val="accent1"/>
+          </a:lnRef>
+          <a:fillRef idx="0">
+            <a:schemeClr val="accent1"/>
+          </a:fillRef>
+          <a:effectRef idx="0">
+            <a:schemeClr val="accent1"/>
+          </a:effectRef>
+          <a:fontRef idx="minor">
+            <a:schemeClr val="tx1"/>
+          </a:fontRef>
+        </p:style>
+      </p:cxnSp>
+      <p:sp>
+        <p:nvSpPr>
+          <p:cNvPr id="67" name="Oval 66">
+            <a:extLst>
+              <a:ext uri="{FF2B5EF4-FFF2-40B4-BE49-F238E27FC236}">
+                <a16:creationId xmlns:a16="http://schemas.microsoft.com/office/drawing/2014/main" id="{AC8D2348-68A6-75DF-3FEF-B4CA2F9B5A09}"/>
+              </a:ext>
+            </a:extLst>
+          </p:cNvPr>
+          <p:cNvSpPr/>
+          <p:nvPr/>
+        </p:nvSpPr>
+        <p:spPr>
+          <a:xfrm>
+            <a:off x="4955351" y="5898581"/>
+            <a:ext cx="676570" cy="369332"/>
+          </a:xfrm>
+          <a:prstGeom prst="ellipse">
+            <a:avLst/>
+          </a:prstGeom>
+          <a:solidFill>
+            <a:schemeClr val="accent2">
+              <a:lumMod val="20000"/>
+              <a:lumOff val="80000"/>
+            </a:schemeClr>
+          </a:solidFill>
+          <a:ln>
+            <a:solidFill>
+              <a:schemeClr val="tx1"/>
+            </a:solidFill>
+          </a:ln>
+        </p:spPr>
+        <p:style>
+          <a:lnRef idx="2">
+            <a:schemeClr val="accent1">
+              <a:shade val="50000"/>
+            </a:schemeClr>
+          </a:lnRef>
+          <a:fillRef idx="1">
+            <a:schemeClr val="accent1"/>
+          </a:fillRef>
+          <a:effectRef idx="0">
+            <a:schemeClr val="accent1"/>
+          </a:effectRef>
+          <a:fontRef idx="minor">
+            <a:schemeClr val="lt1"/>
+          </a:fontRef>
+        </p:style>
+        <p:txBody>
+          <a:bodyPr rtlCol="0" anchor="ctr"/>
+          <a:lstStyle/>
+          <a:p>
+            <a:pPr algn="ctr"/>
+            <a:r>
+              <a:rPr lang="en-NL" sz="1400" dirty="0">
+                <a:solidFill>
+                  <a:schemeClr val="tx1"/>
+                </a:solidFill>
+              </a:rPr>
+              <a:t>s</a:t>
+            </a:r>
+            <a:r>
+              <a:rPr lang="en-NL" sz="1400" baseline="-25000" dirty="0">
+                <a:solidFill>
+                  <a:schemeClr val="tx1"/>
+                </a:solidFill>
+              </a:rPr>
+              <a:t>0</a:t>
+            </a:r>
+            <a:r>
+              <a:rPr lang="en-NL" sz="1400" dirty="0">
+                <a:solidFill>
+                  <a:schemeClr val="tx1"/>
+                </a:solidFill>
+              </a:rPr>
+              <a:t>,x</a:t>
+            </a:r>
+          </a:p>
+        </p:txBody>
+      </p:sp>
+      <p:sp>
+        <p:nvSpPr>
+          <p:cNvPr id="68" name="Oval 67">
+            <a:extLst>
+              <a:ext uri="{FF2B5EF4-FFF2-40B4-BE49-F238E27FC236}">
+                <a16:creationId xmlns:a16="http://schemas.microsoft.com/office/drawing/2014/main" id="{955DF16A-8BFB-A7C1-F6FC-350100201D25}"/>
+              </a:ext>
+            </a:extLst>
+          </p:cNvPr>
+          <p:cNvSpPr/>
+          <p:nvPr/>
+        </p:nvSpPr>
+        <p:spPr>
+          <a:xfrm>
+            <a:off x="5794375" y="5898581"/>
+            <a:ext cx="676570" cy="369332"/>
+          </a:xfrm>
+          <a:prstGeom prst="ellipse">
+            <a:avLst/>
+          </a:prstGeom>
+          <a:solidFill>
+            <a:schemeClr val="accent2">
+              <a:lumMod val="20000"/>
+              <a:lumOff val="80000"/>
+            </a:schemeClr>
+          </a:solidFill>
+          <a:ln>
+            <a:solidFill>
+              <a:schemeClr val="tx1"/>
+            </a:solidFill>
+          </a:ln>
+        </p:spPr>
+        <p:style>
+          <a:lnRef idx="2">
+            <a:schemeClr val="accent1">
+              <a:shade val="50000"/>
+            </a:schemeClr>
+          </a:lnRef>
+          <a:fillRef idx="1">
+            <a:schemeClr val="accent1"/>
+          </a:fillRef>
+          <a:effectRef idx="0">
+            <a:schemeClr val="accent1"/>
+          </a:effectRef>
+          <a:fontRef idx="minor">
+            <a:schemeClr val="lt1"/>
+          </a:fontRef>
+        </p:style>
+        <p:txBody>
+          <a:bodyPr rtlCol="0" anchor="ctr"/>
+          <a:lstStyle/>
+          <a:p>
+            <a:pPr algn="ctr"/>
+            <a:r>
+              <a:rPr lang="en-NL" sz="1400" dirty="0">
+                <a:solidFill>
+                  <a:schemeClr val="tx1"/>
+                </a:solidFill>
+              </a:rPr>
+              <a:t>s</a:t>
+            </a:r>
+            <a:r>
+              <a:rPr lang="en-NL" sz="1400" baseline="-25000" dirty="0">
+                <a:solidFill>
+                  <a:schemeClr val="tx1"/>
+                </a:solidFill>
+              </a:rPr>
+              <a:t>0</a:t>
+            </a:r>
+            <a:r>
+              <a:rPr lang="en-NL" sz="1400" dirty="0">
+                <a:solidFill>
+                  <a:schemeClr val="tx1"/>
+                </a:solidFill>
+              </a:rPr>
+              <a:t>,x</a:t>
+            </a:r>
+          </a:p>
+        </p:txBody>
+      </p:sp>
+      <p:sp>
+        <p:nvSpPr>
+          <p:cNvPr id="69" name="Oval 68">
+            <a:extLst>
+              <a:ext uri="{FF2B5EF4-FFF2-40B4-BE49-F238E27FC236}">
+                <a16:creationId xmlns:a16="http://schemas.microsoft.com/office/drawing/2014/main" id="{621DB7F3-3A13-C1F1-E99E-3CB0F0285F3A}"/>
+              </a:ext>
+            </a:extLst>
+          </p:cNvPr>
+          <p:cNvSpPr/>
+          <p:nvPr/>
+        </p:nvSpPr>
+        <p:spPr>
+          <a:xfrm>
+            <a:off x="6894357" y="5887429"/>
+            <a:ext cx="676570" cy="369332"/>
+          </a:xfrm>
+          <a:prstGeom prst="ellipse">
+            <a:avLst/>
+          </a:prstGeom>
+          <a:solidFill>
+            <a:schemeClr val="accent2">
+              <a:lumMod val="20000"/>
+              <a:lumOff val="80000"/>
+            </a:schemeClr>
+          </a:solidFill>
+          <a:ln>
+            <a:solidFill>
+              <a:schemeClr val="tx1"/>
+            </a:solidFill>
+          </a:ln>
+        </p:spPr>
+        <p:style>
+          <a:lnRef idx="2">
+            <a:schemeClr val="accent1">
+              <a:shade val="50000"/>
+            </a:schemeClr>
+          </a:lnRef>
+          <a:fillRef idx="1">
+            <a:schemeClr val="accent1"/>
+          </a:fillRef>
+          <a:effectRef idx="0">
+            <a:schemeClr val="accent1"/>
+          </a:effectRef>
+          <a:fontRef idx="minor">
+            <a:schemeClr val="lt1"/>
+          </a:fontRef>
+        </p:style>
+        <p:txBody>
+          <a:bodyPr rtlCol="0" anchor="ctr"/>
+          <a:lstStyle/>
+          <a:p>
+            <a:pPr algn="ctr"/>
+            <a:r>
+              <a:rPr lang="en-NL" sz="1400" dirty="0">
+                <a:solidFill>
+                  <a:schemeClr val="tx1"/>
+                </a:solidFill>
+              </a:rPr>
+              <a:t>s</a:t>
+            </a:r>
+            <a:r>
+              <a:rPr lang="en-NL" sz="1400" baseline="-25000" dirty="0">
+                <a:solidFill>
+                  <a:schemeClr val="tx1"/>
+                </a:solidFill>
+              </a:rPr>
+              <a:t>3</a:t>
+            </a:r>
+            <a:r>
+              <a:rPr lang="en-NL" sz="1400" dirty="0">
+                <a:solidFill>
+                  <a:schemeClr val="tx1"/>
+                </a:solidFill>
+              </a:rPr>
+              <a:t>,x</a:t>
+            </a:r>
+          </a:p>
+        </p:txBody>
+      </p:sp>
+      <p:cxnSp>
+        <p:nvCxnSpPr>
+          <p:cNvPr id="72" name="Straight Arrow Connector 71">
+            <a:extLst>
+              <a:ext uri="{FF2B5EF4-FFF2-40B4-BE49-F238E27FC236}">
+                <a16:creationId xmlns:a16="http://schemas.microsoft.com/office/drawing/2014/main" id="{FCB65D79-C2E2-51EF-A123-58E68D9B810A}"/>
+              </a:ext>
+            </a:extLst>
+          </p:cNvPr>
+          <p:cNvCxnSpPr>
+            <a:cxnSpLocks/>
+            <a:stCxn id="33" idx="3"/>
+            <a:endCxn id="67" idx="0"/>
+          </p:cNvCxnSpPr>
+          <p:nvPr/>
+        </p:nvCxnSpPr>
+        <p:spPr>
+          <a:xfrm flipH="1">
+            <a:off x="5293636" y="5572181"/>
+            <a:ext cx="599820" cy="326400"/>
+          </a:xfrm>
+          <a:prstGeom prst="straightConnector1">
+            <a:avLst/>
+          </a:prstGeom>
+          <a:ln w="12700">
+            <a:solidFill>
+              <a:schemeClr val="tx1"/>
+            </a:solidFill>
+            <a:tailEnd type="triangle"/>
+          </a:ln>
+        </p:spPr>
+        <p:style>
+          <a:lnRef idx="1">
+            <a:schemeClr val="accent1"/>
+          </a:lnRef>
+          <a:fillRef idx="0">
+            <a:schemeClr val="accent1"/>
+          </a:fillRef>
+          <a:effectRef idx="0">
+            <a:schemeClr val="accent1"/>
+          </a:effectRef>
+          <a:fontRef idx="minor">
+            <a:schemeClr val="tx1"/>
+          </a:fontRef>
+        </p:style>
+      </p:cxnSp>
+      <p:cxnSp>
+        <p:nvCxnSpPr>
+          <p:cNvPr id="75" name="Straight Arrow Connector 74">
+            <a:extLst>
+              <a:ext uri="{FF2B5EF4-FFF2-40B4-BE49-F238E27FC236}">
+                <a16:creationId xmlns:a16="http://schemas.microsoft.com/office/drawing/2014/main" id="{BAD3B32D-08D3-1554-EF5A-143309F605B2}"/>
+              </a:ext>
+            </a:extLst>
+          </p:cNvPr>
+          <p:cNvCxnSpPr>
+            <a:cxnSpLocks/>
+            <a:stCxn id="67" idx="6"/>
+            <a:endCxn id="68" idx="2"/>
+          </p:cNvCxnSpPr>
+          <p:nvPr/>
+        </p:nvCxnSpPr>
+        <p:spPr>
+          <a:xfrm>
+            <a:off x="5631921" y="6083247"/>
+            <a:ext cx="162454" cy="0"/>
+          </a:xfrm>
+          <a:prstGeom prst="straightConnector1">
+            <a:avLst/>
+          </a:prstGeom>
+          <a:ln w="12700">
+            <a:solidFill>
+              <a:schemeClr val="tx1"/>
+            </a:solidFill>
+            <a:tailEnd type="triangle"/>
+          </a:ln>
+        </p:spPr>
+        <p:style>
+          <a:lnRef idx="1">
+            <a:schemeClr val="accent1"/>
+          </a:lnRef>
+          <a:fillRef idx="0">
+            <a:schemeClr val="accent1"/>
+          </a:fillRef>
+          <a:effectRef idx="0">
+            <a:schemeClr val="accent1"/>
+          </a:effectRef>
+          <a:fontRef idx="minor">
+            <a:schemeClr val="tx1"/>
+          </a:fontRef>
+        </p:style>
+      </p:cxnSp>
+      <p:cxnSp>
+        <p:nvCxnSpPr>
+          <p:cNvPr id="82" name="Straight Arrow Connector 81">
+            <a:extLst>
+              <a:ext uri="{FF2B5EF4-FFF2-40B4-BE49-F238E27FC236}">
+                <a16:creationId xmlns:a16="http://schemas.microsoft.com/office/drawing/2014/main" id="{7FE4B486-16B8-8513-2A8A-A15340AE90A5}"/>
+              </a:ext>
+            </a:extLst>
+          </p:cNvPr>
+          <p:cNvCxnSpPr>
+            <a:cxnSpLocks/>
+            <a:stCxn id="68" idx="0"/>
+            <a:endCxn id="33" idx="4"/>
+          </p:cNvCxnSpPr>
+          <p:nvPr/>
+        </p:nvCxnSpPr>
+        <p:spPr>
+          <a:xfrm flipV="1">
+            <a:off x="6132660" y="5626268"/>
+            <a:ext cx="0" cy="272313"/>
+          </a:xfrm>
+          <a:prstGeom prst="straightConnector1">
+            <a:avLst/>
+          </a:prstGeom>
+          <a:ln w="12700">
+            <a:solidFill>
+              <a:schemeClr val="tx1"/>
+            </a:solidFill>
+            <a:tailEnd type="triangle"/>
+          </a:ln>
+        </p:spPr>
+        <p:style>
+          <a:lnRef idx="1">
+            <a:schemeClr val="accent1"/>
+          </a:lnRef>
+          <a:fillRef idx="0">
+            <a:schemeClr val="accent1"/>
+          </a:fillRef>
+          <a:effectRef idx="0">
+            <a:schemeClr val="accent1"/>
+          </a:effectRef>
+          <a:fontRef idx="minor">
+            <a:schemeClr val="tx1"/>
+          </a:fontRef>
+        </p:style>
+      </p:cxnSp>
+      <p:cxnSp>
+        <p:nvCxnSpPr>
+          <p:cNvPr id="88" name="Straight Arrow Connector 87">
+            <a:extLst>
+              <a:ext uri="{FF2B5EF4-FFF2-40B4-BE49-F238E27FC236}">
+                <a16:creationId xmlns:a16="http://schemas.microsoft.com/office/drawing/2014/main" id="{9DFC921E-299C-6C3E-D78C-F84F2C1B7141}"/>
+              </a:ext>
+            </a:extLst>
+          </p:cNvPr>
+          <p:cNvCxnSpPr>
+            <a:cxnSpLocks/>
+            <a:stCxn id="68" idx="6"/>
+            <a:endCxn id="69" idx="2"/>
+          </p:cNvCxnSpPr>
+          <p:nvPr/>
+        </p:nvCxnSpPr>
+        <p:spPr>
+          <a:xfrm flipV="1">
+            <a:off x="6470945" y="6072095"/>
+            <a:ext cx="423412" cy="11152"/>
+          </a:xfrm>
+          <a:prstGeom prst="straightConnector1">
+            <a:avLst/>
+          </a:prstGeom>
+          <a:ln w="12700">
+            <a:solidFill>
+              <a:schemeClr val="tx1"/>
+            </a:solidFill>
+            <a:tailEnd type="triangle"/>
+          </a:ln>
+        </p:spPr>
+        <p:style>
+          <a:lnRef idx="1">
+            <a:schemeClr val="accent1"/>
+          </a:lnRef>
+          <a:fillRef idx="0">
+            <a:schemeClr val="accent1"/>
+          </a:fillRef>
+          <a:effectRef idx="0">
+            <a:schemeClr val="accent1"/>
+          </a:effectRef>
+          <a:fontRef idx="minor">
+            <a:schemeClr val="tx1"/>
+          </a:fontRef>
+        </p:style>
+      </p:cxnSp>
+      <p:cxnSp>
+        <p:nvCxnSpPr>
+          <p:cNvPr id="93" name="Curved Connector 92">
+            <a:extLst>
+              <a:ext uri="{FF2B5EF4-FFF2-40B4-BE49-F238E27FC236}">
+                <a16:creationId xmlns:a16="http://schemas.microsoft.com/office/drawing/2014/main" id="{DE7096B9-4915-4357-7C36-C663A8FC3921}"/>
+              </a:ext>
+            </a:extLst>
+          </p:cNvPr>
+          <p:cNvCxnSpPr>
+            <a:cxnSpLocks/>
+            <a:stCxn id="69" idx="6"/>
+            <a:endCxn id="69" idx="0"/>
+          </p:cNvCxnSpPr>
+          <p:nvPr/>
+        </p:nvCxnSpPr>
+        <p:spPr>
+          <a:xfrm flipH="1" flipV="1">
+            <a:off x="7232642" y="5887429"/>
+            <a:ext cx="338285" cy="184666"/>
+          </a:xfrm>
+          <a:prstGeom prst="curvedConnector4">
+            <a:avLst>
+              <a:gd name="adj1" fmla="val -67576"/>
+              <a:gd name="adj2" fmla="val 223791"/>
+            </a:avLst>
+          </a:prstGeom>
+          <a:ln w="12700">
+            <a:solidFill>
+              <a:schemeClr val="tx1"/>
+            </a:solidFill>
+            <a:tailEnd type="triangle"/>
+          </a:ln>
+        </p:spPr>
+        <p:style>
+          <a:lnRef idx="1">
+            <a:schemeClr val="accent1"/>
+          </a:lnRef>
+          <a:fillRef idx="0">
+            <a:schemeClr val="accent1"/>
+          </a:fillRef>
+          <a:effectRef idx="0">
+            <a:schemeClr val="accent1"/>
+          </a:effectRef>
+          <a:fontRef idx="minor">
+            <a:schemeClr val="tx1"/>
+          </a:fontRef>
+        </p:style>
+      </p:cxnSp>
+      <p:cxnSp>
+        <p:nvCxnSpPr>
+          <p:cNvPr id="96" name="Curved Connector 95">
+            <a:extLst>
+              <a:ext uri="{FF2B5EF4-FFF2-40B4-BE49-F238E27FC236}">
+                <a16:creationId xmlns:a16="http://schemas.microsoft.com/office/drawing/2014/main" id="{AE308154-1615-ECF8-8E86-228EE3FC98B2}"/>
+              </a:ext>
+            </a:extLst>
+          </p:cNvPr>
+          <p:cNvCxnSpPr>
+            <a:cxnSpLocks/>
+            <a:stCxn id="68" idx="6"/>
+            <a:endCxn id="68" idx="0"/>
+          </p:cNvCxnSpPr>
+          <p:nvPr/>
+        </p:nvCxnSpPr>
+        <p:spPr>
+          <a:xfrm flipH="1" flipV="1">
+            <a:off x="6132660" y="5898581"/>
+            <a:ext cx="338285" cy="184666"/>
+          </a:xfrm>
+          <a:prstGeom prst="curvedConnector4">
+            <a:avLst>
+              <a:gd name="adj1" fmla="val -67576"/>
+              <a:gd name="adj2" fmla="val 223791"/>
+            </a:avLst>
+          </a:prstGeom>
+          <a:ln w="12700">
+            <a:solidFill>
+              <a:schemeClr val="tx1"/>
+            </a:solidFill>
+            <a:tailEnd type="triangle"/>
+          </a:ln>
+        </p:spPr>
+        <p:style>
+          <a:lnRef idx="1">
+            <a:schemeClr val="accent1"/>
+          </a:lnRef>
+          <a:fillRef idx="0">
+            <a:schemeClr val="accent1"/>
+          </a:fillRef>
+          <a:effectRef idx="0">
+            <a:schemeClr val="accent1"/>
+          </a:effectRef>
+          <a:fontRef idx="minor">
+            <a:schemeClr val="tx1"/>
+          </a:fontRef>
+        </p:style>
+      </p:cxnSp>
+      <p:sp>
+        <p:nvSpPr>
+          <p:cNvPr id="114" name="TextBox 113">
+            <a:extLst>
+              <a:ext uri="{FF2B5EF4-FFF2-40B4-BE49-F238E27FC236}">
+                <a16:creationId xmlns:a16="http://schemas.microsoft.com/office/drawing/2014/main" id="{390FE1C5-1768-0968-0676-1799BC4CD465}"/>
+              </a:ext>
+            </a:extLst>
+          </p:cNvPr>
+          <p:cNvSpPr txBox="1"/>
+          <p:nvPr/>
+        </p:nvSpPr>
+        <p:spPr>
+          <a:xfrm>
+            <a:off x="5488537" y="5029804"/>
+            <a:ext cx="809837" cy="261610"/>
+          </a:xfrm>
+          <a:prstGeom prst="rect">
+            <a:avLst/>
+          </a:prstGeom>
+          <a:noFill/>
+        </p:spPr>
+        <p:txBody>
+          <a:bodyPr wrap="none" rtlCol="0">
+            <a:spAutoFit/>
+          </a:bodyPr>
+          <a:lstStyle/>
+          <a:p>
+            <a:r>
+              <a:rPr lang="en-NL" sz="1050" dirty="0">
+                <a:highlight>
+                  <a:srgbClr val="00FF00"/>
+                </a:highlight>
+              </a:rPr>
+              <a:t>0.01</a:t>
+            </a:r>
+            <a:r>
+              <a:rPr lang="en-NL" sz="1050" dirty="0"/>
+              <a:t> {fail} </a:t>
+            </a:r>
+          </a:p>
+        </p:txBody>
+      </p:sp>
+      <p:sp>
+        <p:nvSpPr>
+          <p:cNvPr id="117" name="TextBox 116">
+            <a:extLst>
+              <a:ext uri="{FF2B5EF4-FFF2-40B4-BE49-F238E27FC236}">
+                <a16:creationId xmlns:a16="http://schemas.microsoft.com/office/drawing/2014/main" id="{75A607DB-7CEA-1F66-5BCF-04D78D318237}"/>
+              </a:ext>
+            </a:extLst>
+          </p:cNvPr>
+          <p:cNvSpPr txBox="1"/>
+          <p:nvPr/>
+        </p:nvSpPr>
+        <p:spPr>
+          <a:xfrm>
+            <a:off x="6919707" y="2945376"/>
+            <a:ext cx="1039525" cy="430887"/>
+          </a:xfrm>
+          <a:prstGeom prst="rect">
+            <a:avLst/>
+          </a:prstGeom>
+          <a:noFill/>
+        </p:spPr>
+        <p:txBody>
+          <a:bodyPr wrap="square" rtlCol="0">
+            <a:spAutoFit/>
+          </a:bodyPr>
+          <a:lstStyle/>
+          <a:p>
+            <a:r>
+              <a:rPr lang="en-NL" sz="1100" dirty="0"/>
+              <a:t>try∉ and succ∉ </a:t>
             </a:r>
           </a:p>
         </p:txBody>
@@ -21491,10 +22655,10 @@
       </p:grpSpPr>
       <p:sp>
         <p:nvSpPr>
-          <p:cNvPr id="31" name="Rectangle 30">
+          <p:cNvPr id="56" name="Rectangle 55">
             <a:extLst>
               <a:ext uri="{FF2B5EF4-FFF2-40B4-BE49-F238E27FC236}">
-                <a16:creationId xmlns:a16="http://schemas.microsoft.com/office/drawing/2014/main" id="{5450E8F7-83E7-2F5C-4335-C30C8056E30C}"/>
+                <a16:creationId xmlns:a16="http://schemas.microsoft.com/office/drawing/2014/main" id="{592BF48A-3506-D7D6-A924-EA84A2887DC9}"/>
               </a:ext>
             </a:extLst>
           </p:cNvPr>
@@ -21503,22 +22667,23 @@
         </p:nvSpPr>
         <p:spPr>
           <a:xfrm>
-            <a:off x="2290882" y="2748396"/>
-            <a:ext cx="986567" cy="922792"/>
+            <a:off x="6346374" y="3213983"/>
+            <a:ext cx="1203500" cy="806148"/>
           </a:xfrm>
           <a:prstGeom prst="rect">
             <a:avLst/>
           </a:prstGeom>
           <a:solidFill>
-            <a:schemeClr val="tx2">
+            <a:schemeClr val="accent3">
               <a:lumMod val="20000"/>
               <a:lumOff val="80000"/>
             </a:schemeClr>
           </a:solidFill>
           <a:ln>
             <a:solidFill>
-              <a:schemeClr val="bg1">
-                <a:lumMod val="65000"/>
+              <a:schemeClr val="accent3">
+                <a:lumMod val="60000"/>
+                <a:lumOff val="40000"/>
               </a:schemeClr>
             </a:solidFill>
           </a:ln>
@@ -21550,10 +22715,10 @@
       </p:sp>
       <p:sp>
         <p:nvSpPr>
-          <p:cNvPr id="33" name="Rectangle 32">
+          <p:cNvPr id="52" name="Rectangle 51">
             <a:extLst>
               <a:ext uri="{FF2B5EF4-FFF2-40B4-BE49-F238E27FC236}">
-                <a16:creationId xmlns:a16="http://schemas.microsoft.com/office/drawing/2014/main" id="{1DD507A2-1775-A4DA-1731-0C1BC8881CC6}"/>
+                <a16:creationId xmlns:a16="http://schemas.microsoft.com/office/drawing/2014/main" id="{FA1F0C46-52DA-4286-3669-FC9562475191}"/>
               </a:ext>
             </a:extLst>
           </p:cNvPr>
@@ -21562,135 +22727,14 @@
         </p:nvSpPr>
         <p:spPr>
           <a:xfrm>
-            <a:off x="1127605" y="2748396"/>
-            <a:ext cx="938825" cy="922792"/>
+            <a:off x="5957945" y="2318803"/>
+            <a:ext cx="1762277" cy="630493"/>
           </a:xfrm>
           <a:prstGeom prst="rect">
             <a:avLst/>
           </a:prstGeom>
           <a:solidFill>
-            <a:schemeClr val="tx2">
-              <a:lumMod val="20000"/>
-              <a:lumOff val="80000"/>
-            </a:schemeClr>
-          </a:solidFill>
-          <a:ln>
-            <a:solidFill>
-              <a:schemeClr val="bg1">
-                <a:lumMod val="65000"/>
-              </a:schemeClr>
-            </a:solidFill>
-          </a:ln>
-        </p:spPr>
-        <p:style>
-          <a:lnRef idx="2">
-            <a:schemeClr val="accent1">
-              <a:shade val="50000"/>
-            </a:schemeClr>
-          </a:lnRef>
-          <a:fillRef idx="1">
-            <a:schemeClr val="accent1"/>
-          </a:fillRef>
-          <a:effectRef idx="0">
-            <a:schemeClr val="accent1"/>
-          </a:effectRef>
-          <a:fontRef idx="minor">
-            <a:schemeClr val="lt1"/>
-          </a:fontRef>
-        </p:style>
-        <p:txBody>
-          <a:bodyPr rtlCol="0" anchor="ctr"/>
-          <a:lstStyle/>
-          <a:p>
-            <a:pPr algn="ctr"/>
-            <a:endParaRPr lang="en-NL"/>
-          </a:p>
-        </p:txBody>
-      </p:sp>
-      <p:sp>
-        <p:nvSpPr>
-          <p:cNvPr id="8" name="Rectangle 7">
-            <a:extLst>
-              <a:ext uri="{FF2B5EF4-FFF2-40B4-BE49-F238E27FC236}">
-                <a16:creationId xmlns:a16="http://schemas.microsoft.com/office/drawing/2014/main" id="{496D0E91-458C-3469-BBEB-E0CE329BFAAC}"/>
-              </a:ext>
-            </a:extLst>
-          </p:cNvPr>
-          <p:cNvSpPr/>
-          <p:nvPr/>
-        </p:nvSpPr>
-        <p:spPr>
-          <a:xfrm>
-            <a:off x="3629985" y="2739999"/>
-            <a:ext cx="1182098" cy="922792"/>
-          </a:xfrm>
-          <a:prstGeom prst="rect">
-            <a:avLst/>
-          </a:prstGeom>
-          <a:solidFill>
-            <a:schemeClr val="tx2">
-              <a:lumMod val="20000"/>
-              <a:lumOff val="80000"/>
-            </a:schemeClr>
-          </a:solidFill>
-          <a:ln>
-            <a:solidFill>
-              <a:schemeClr val="bg1">
-                <a:lumMod val="65000"/>
-              </a:schemeClr>
-            </a:solidFill>
-          </a:ln>
-        </p:spPr>
-        <p:style>
-          <a:lnRef idx="2">
-            <a:schemeClr val="accent1">
-              <a:shade val="50000"/>
-            </a:schemeClr>
-          </a:lnRef>
-          <a:fillRef idx="1">
-            <a:schemeClr val="accent1"/>
-          </a:fillRef>
-          <a:effectRef idx="0">
-            <a:schemeClr val="accent1"/>
-          </a:effectRef>
-          <a:fontRef idx="minor">
-            <a:schemeClr val="lt1"/>
-          </a:fontRef>
-        </p:style>
-        <p:txBody>
-          <a:bodyPr rtlCol="0" anchor="ctr"/>
-          <a:lstStyle/>
-          <a:p>
-            <a:pPr algn="ctr"/>
-            <a:endParaRPr lang="en-NL"/>
-          </a:p>
-        </p:txBody>
-      </p:sp>
-      <p:sp>
-        <p:nvSpPr>
-          <p:cNvPr id="5" name="Rectangle 4">
-            <a:extLst>
-              <a:ext uri="{FF2B5EF4-FFF2-40B4-BE49-F238E27FC236}">
-                <a16:creationId xmlns:a16="http://schemas.microsoft.com/office/drawing/2014/main" id="{1401ECCF-CCFD-21CF-098E-9B4E99128DD5}"/>
-              </a:ext>
-            </a:extLst>
-          </p:cNvPr>
-          <p:cNvSpPr/>
-          <p:nvPr/>
-        </p:nvSpPr>
-        <p:spPr>
-          <a:xfrm>
-            <a:off x="5881608" y="2739999"/>
-            <a:ext cx="1884956" cy="922792"/>
-          </a:xfrm>
-          <a:prstGeom prst="rect">
-            <a:avLst/>
-          </a:prstGeom>
-          <a:solidFill>
-            <a:schemeClr val="accent4">
-              <a:lumMod val="20000"/>
-              <a:lumOff val="80000"/>
-            </a:schemeClr>
+            <a:schemeClr val="bg2"/>
           </a:solidFill>
           <a:ln>
             <a:solidFill>
@@ -21807,7 +22851,7 @@
         </p:nvSpPr>
         <p:spPr>
           <a:xfrm>
-            <a:off x="374650" y="1556480"/>
+            <a:off x="311190" y="1428963"/>
             <a:ext cx="8166100" cy="923330"/>
           </a:xfrm>
           <a:prstGeom prst="rect">
@@ -21825,805 +22869,6 @@
             <a:r>
               <a:rPr lang="en-NL" dirty="0"/>
               <a:t>So we have this R2 = M∩R, with L=∅  and K = { the blue states }. Any execution satisfying 𝜑  can only pass L finitely many often and should pass one of K inifnitely many often.</a:t>
-            </a:r>
-          </a:p>
-        </p:txBody>
-      </p:sp>
-      <p:sp>
-        <p:nvSpPr>
-          <p:cNvPr id="34" name="Oval 33">
-            <a:extLst>
-              <a:ext uri="{FF2B5EF4-FFF2-40B4-BE49-F238E27FC236}">
-                <a16:creationId xmlns:a16="http://schemas.microsoft.com/office/drawing/2014/main" id="{B0B843F8-0C03-8A2B-3F3D-BC2A64E089FA}"/>
-              </a:ext>
-            </a:extLst>
-          </p:cNvPr>
-          <p:cNvSpPr/>
-          <p:nvPr/>
-        </p:nvSpPr>
-        <p:spPr>
-          <a:xfrm>
-            <a:off x="2411007" y="2961776"/>
-            <a:ext cx="788818" cy="369332"/>
-          </a:xfrm>
-          <a:prstGeom prst="ellipse">
-            <a:avLst/>
-          </a:prstGeom>
-          <a:solidFill>
-            <a:schemeClr val="accent4">
-              <a:lumMod val="40000"/>
-              <a:lumOff val="60000"/>
-            </a:schemeClr>
-          </a:solidFill>
-          <a:ln>
-            <a:solidFill>
-              <a:schemeClr val="tx1"/>
-            </a:solidFill>
-          </a:ln>
-        </p:spPr>
-        <p:style>
-          <a:lnRef idx="2">
-            <a:schemeClr val="accent1">
-              <a:shade val="50000"/>
-            </a:schemeClr>
-          </a:lnRef>
-          <a:fillRef idx="1">
-            <a:schemeClr val="accent1"/>
-          </a:fillRef>
-          <a:effectRef idx="0">
-            <a:schemeClr val="accent1"/>
-          </a:effectRef>
-          <a:fontRef idx="minor">
-            <a:schemeClr val="lt1"/>
-          </a:fontRef>
-        </p:style>
-        <p:txBody>
-          <a:bodyPr rtlCol="0" anchor="ctr"/>
-          <a:lstStyle/>
-          <a:p>
-            <a:pPr algn="ctr"/>
-            <a:r>
-              <a:rPr lang="en-NL" sz="1400" dirty="0">
-                <a:solidFill>
-                  <a:schemeClr val="tx1"/>
-                </a:solidFill>
-              </a:rPr>
-              <a:t>s</a:t>
-            </a:r>
-            <a:r>
-              <a:rPr lang="en-NL" sz="1400" baseline="-25000" dirty="0">
-                <a:solidFill>
-                  <a:schemeClr val="tx1"/>
-                </a:solidFill>
-              </a:rPr>
-              <a:t>0</a:t>
-            </a:r>
-            <a:r>
-              <a:rPr lang="en-NL" sz="1400" dirty="0">
-                <a:solidFill>
-                  <a:schemeClr val="tx1"/>
-                </a:solidFill>
-              </a:rPr>
-              <a:t>,v</a:t>
-            </a:r>
-          </a:p>
-        </p:txBody>
-      </p:sp>
-      <p:sp>
-        <p:nvSpPr>
-          <p:cNvPr id="35" name="Oval 34">
-            <a:extLst>
-              <a:ext uri="{FF2B5EF4-FFF2-40B4-BE49-F238E27FC236}">
-                <a16:creationId xmlns:a16="http://schemas.microsoft.com/office/drawing/2014/main" id="{BE9F84B9-3E45-86D7-6739-C54BA94D6D5B}"/>
-              </a:ext>
-            </a:extLst>
-          </p:cNvPr>
-          <p:cNvSpPr/>
-          <p:nvPr/>
-        </p:nvSpPr>
-        <p:spPr>
-          <a:xfrm>
-            <a:off x="3813957" y="2963371"/>
-            <a:ext cx="935843" cy="369332"/>
-          </a:xfrm>
-          <a:prstGeom prst="ellipse">
-            <a:avLst/>
-          </a:prstGeom>
-          <a:solidFill>
-            <a:schemeClr val="accent4">
-              <a:lumMod val="40000"/>
-              <a:lumOff val="60000"/>
-            </a:schemeClr>
-          </a:solidFill>
-          <a:ln>
-            <a:solidFill>
-              <a:schemeClr val="tx1"/>
-            </a:solidFill>
-          </a:ln>
-        </p:spPr>
-        <p:style>
-          <a:lnRef idx="2">
-            <a:schemeClr val="accent1">
-              <a:shade val="50000"/>
-            </a:schemeClr>
-          </a:lnRef>
-          <a:fillRef idx="1">
-            <a:schemeClr val="accent1"/>
-          </a:fillRef>
-          <a:effectRef idx="0">
-            <a:schemeClr val="accent1"/>
-          </a:effectRef>
-          <a:fontRef idx="minor">
-            <a:schemeClr val="lt1"/>
-          </a:fontRef>
-        </p:style>
-        <p:txBody>
-          <a:bodyPr rtlCol="0" anchor="ctr"/>
-          <a:lstStyle/>
-          <a:p>
-            <a:pPr algn="ctr"/>
-            <a:r>
-              <a:rPr lang="en-NL" sz="1400" dirty="0">
-                <a:solidFill>
-                  <a:schemeClr val="tx1"/>
-                </a:solidFill>
-              </a:rPr>
-              <a:t>s</a:t>
-            </a:r>
-            <a:r>
-              <a:rPr lang="en-NL" sz="1400" baseline="-25000" dirty="0">
-                <a:solidFill>
-                  <a:schemeClr val="tx1"/>
-                </a:solidFill>
-              </a:rPr>
-              <a:t>1</a:t>
-            </a:r>
-            <a:r>
-              <a:rPr lang="en-NL" sz="1400" dirty="0">
-                <a:solidFill>
-                  <a:schemeClr val="tx1"/>
-                </a:solidFill>
-              </a:rPr>
-              <a:t>,v</a:t>
-            </a:r>
-          </a:p>
-        </p:txBody>
-      </p:sp>
-      <p:sp>
-        <p:nvSpPr>
-          <p:cNvPr id="36" name="Oval 35">
-            <a:extLst>
-              <a:ext uri="{FF2B5EF4-FFF2-40B4-BE49-F238E27FC236}">
-                <a16:creationId xmlns:a16="http://schemas.microsoft.com/office/drawing/2014/main" id="{91C71BC6-2D25-AD8F-75ED-D730A3E0D4B7}"/>
-              </a:ext>
-            </a:extLst>
-          </p:cNvPr>
-          <p:cNvSpPr/>
-          <p:nvPr/>
-        </p:nvSpPr>
-        <p:spPr>
-          <a:xfrm>
-            <a:off x="6093909" y="2963910"/>
-            <a:ext cx="790868" cy="369332"/>
-          </a:xfrm>
-          <a:prstGeom prst="ellipse">
-            <a:avLst/>
-          </a:prstGeom>
-          <a:solidFill>
-            <a:schemeClr val="accent4">
-              <a:lumMod val="40000"/>
-              <a:lumOff val="60000"/>
-            </a:schemeClr>
-          </a:solidFill>
-          <a:ln>
-            <a:solidFill>
-              <a:schemeClr val="tx1"/>
-            </a:solidFill>
-          </a:ln>
-        </p:spPr>
-        <p:style>
-          <a:lnRef idx="2">
-            <a:schemeClr val="accent1">
-              <a:shade val="50000"/>
-            </a:schemeClr>
-          </a:lnRef>
-          <a:fillRef idx="1">
-            <a:schemeClr val="accent1"/>
-          </a:fillRef>
-          <a:effectRef idx="0">
-            <a:schemeClr val="accent1"/>
-          </a:effectRef>
-          <a:fontRef idx="minor">
-            <a:schemeClr val="lt1"/>
-          </a:fontRef>
-        </p:style>
-        <p:txBody>
-          <a:bodyPr rtlCol="0" anchor="ctr"/>
-          <a:lstStyle/>
-          <a:p>
-            <a:pPr algn="ctr"/>
-            <a:r>
-              <a:rPr lang="en-NL" sz="1400" dirty="0">
-                <a:solidFill>
-                  <a:schemeClr val="tx1"/>
-                </a:solidFill>
-              </a:rPr>
-              <a:t>s</a:t>
-            </a:r>
-            <a:r>
-              <a:rPr lang="en-NL" sz="1400" baseline="-25000" dirty="0">
-                <a:solidFill>
-                  <a:schemeClr val="tx1"/>
-                </a:solidFill>
-              </a:rPr>
-              <a:t>3</a:t>
-            </a:r>
-            <a:r>
-              <a:rPr lang="en-NL" sz="1400" dirty="0">
-                <a:solidFill>
-                  <a:schemeClr val="tx1"/>
-                </a:solidFill>
-              </a:rPr>
-              <a:t>,w</a:t>
-            </a:r>
-          </a:p>
-        </p:txBody>
-      </p:sp>
-      <p:sp>
-        <p:nvSpPr>
-          <p:cNvPr id="39" name="Oval 38">
-            <a:extLst>
-              <a:ext uri="{FF2B5EF4-FFF2-40B4-BE49-F238E27FC236}">
-                <a16:creationId xmlns:a16="http://schemas.microsoft.com/office/drawing/2014/main" id="{CB9AB1BA-85F6-7B3E-736C-F11F9B8F1766}"/>
-              </a:ext>
-            </a:extLst>
-          </p:cNvPr>
-          <p:cNvSpPr/>
-          <p:nvPr/>
-        </p:nvSpPr>
-        <p:spPr>
-          <a:xfrm>
-            <a:off x="1266370" y="2954702"/>
-            <a:ext cx="714477" cy="369332"/>
-          </a:xfrm>
-          <a:prstGeom prst="ellipse">
-            <a:avLst/>
-          </a:prstGeom>
-          <a:solidFill>
-            <a:schemeClr val="accent3">
-              <a:lumMod val="20000"/>
-              <a:lumOff val="80000"/>
-            </a:schemeClr>
-          </a:solidFill>
-          <a:ln>
-            <a:solidFill>
-              <a:schemeClr val="tx1"/>
-            </a:solidFill>
-          </a:ln>
-        </p:spPr>
-        <p:style>
-          <a:lnRef idx="2">
-            <a:schemeClr val="accent1">
-              <a:shade val="50000"/>
-            </a:schemeClr>
-          </a:lnRef>
-          <a:fillRef idx="1">
-            <a:schemeClr val="accent1"/>
-          </a:fillRef>
-          <a:effectRef idx="0">
-            <a:schemeClr val="accent1"/>
-          </a:effectRef>
-          <a:fontRef idx="minor">
-            <a:schemeClr val="lt1"/>
-          </a:fontRef>
-        </p:style>
-        <p:txBody>
-          <a:bodyPr rtlCol="0" anchor="ctr"/>
-          <a:lstStyle/>
-          <a:p>
-            <a:pPr algn="ctr"/>
-            <a:r>
-              <a:rPr lang="en-NL" sz="1400" dirty="0">
-                <a:solidFill>
-                  <a:schemeClr val="tx1"/>
-                </a:solidFill>
-              </a:rPr>
-              <a:t>z,u</a:t>
-            </a:r>
-            <a:endParaRPr lang="en-NL" sz="1400" baseline="-25000" dirty="0">
-              <a:solidFill>
-                <a:schemeClr val="tx1"/>
-              </a:solidFill>
-            </a:endParaRPr>
-          </a:p>
-        </p:txBody>
-      </p:sp>
-      <p:cxnSp>
-        <p:nvCxnSpPr>
-          <p:cNvPr id="40" name="Straight Arrow Connector 39">
-            <a:extLst>
-              <a:ext uri="{FF2B5EF4-FFF2-40B4-BE49-F238E27FC236}">
-                <a16:creationId xmlns:a16="http://schemas.microsoft.com/office/drawing/2014/main" id="{3B5F7377-8503-F27D-3417-15817C695EB9}"/>
-              </a:ext>
-            </a:extLst>
-          </p:cNvPr>
-          <p:cNvCxnSpPr>
-            <a:cxnSpLocks/>
-            <a:stCxn id="34" idx="6"/>
-            <a:endCxn id="35" idx="2"/>
-          </p:cNvCxnSpPr>
-          <p:nvPr/>
-        </p:nvCxnSpPr>
-        <p:spPr>
-          <a:xfrm>
-            <a:off x="3199825" y="3146442"/>
-            <a:ext cx="614132" cy="1595"/>
-          </a:xfrm>
-          <a:prstGeom prst="straightConnector1">
-            <a:avLst/>
-          </a:prstGeom>
-          <a:ln w="12700">
-            <a:solidFill>
-              <a:schemeClr val="tx1"/>
-            </a:solidFill>
-            <a:tailEnd type="triangle"/>
-          </a:ln>
-        </p:spPr>
-        <p:style>
-          <a:lnRef idx="1">
-            <a:schemeClr val="accent1"/>
-          </a:lnRef>
-          <a:fillRef idx="0">
-            <a:schemeClr val="accent1"/>
-          </a:fillRef>
-          <a:effectRef idx="0">
-            <a:schemeClr val="accent1"/>
-          </a:effectRef>
-          <a:fontRef idx="minor">
-            <a:schemeClr val="tx1"/>
-          </a:fontRef>
-        </p:style>
-      </p:cxnSp>
-      <p:cxnSp>
-        <p:nvCxnSpPr>
-          <p:cNvPr id="41" name="Straight Arrow Connector 40">
-            <a:extLst>
-              <a:ext uri="{FF2B5EF4-FFF2-40B4-BE49-F238E27FC236}">
-                <a16:creationId xmlns:a16="http://schemas.microsoft.com/office/drawing/2014/main" id="{E9257BBC-8F7D-167C-9FC6-9CAC3BDA1309}"/>
-              </a:ext>
-            </a:extLst>
-          </p:cNvPr>
-          <p:cNvCxnSpPr>
-            <a:cxnSpLocks/>
-            <a:stCxn id="35" idx="6"/>
-            <a:endCxn id="36" idx="2"/>
-          </p:cNvCxnSpPr>
-          <p:nvPr/>
-        </p:nvCxnSpPr>
-        <p:spPr>
-          <a:xfrm>
-            <a:off x="4749800" y="3148037"/>
-            <a:ext cx="1344109" cy="539"/>
-          </a:xfrm>
-          <a:prstGeom prst="straightConnector1">
-            <a:avLst/>
-          </a:prstGeom>
-          <a:ln w="12700">
-            <a:solidFill>
-              <a:schemeClr val="tx1"/>
-            </a:solidFill>
-            <a:tailEnd type="triangle"/>
-          </a:ln>
-        </p:spPr>
-        <p:style>
-          <a:lnRef idx="1">
-            <a:schemeClr val="accent1"/>
-          </a:lnRef>
-          <a:fillRef idx="0">
-            <a:schemeClr val="accent1"/>
-          </a:fillRef>
-          <a:effectRef idx="0">
-            <a:schemeClr val="accent1"/>
-          </a:effectRef>
-          <a:fontRef idx="minor">
-            <a:schemeClr val="tx1"/>
-          </a:fontRef>
-        </p:style>
-      </p:cxnSp>
-      <p:cxnSp>
-        <p:nvCxnSpPr>
-          <p:cNvPr id="43" name="Curved Connector 42">
-            <a:extLst>
-              <a:ext uri="{FF2B5EF4-FFF2-40B4-BE49-F238E27FC236}">
-                <a16:creationId xmlns:a16="http://schemas.microsoft.com/office/drawing/2014/main" id="{FB5AF0F2-E3F1-E467-D180-C7B41E7E5FCA}"/>
-              </a:ext>
-            </a:extLst>
-          </p:cNvPr>
-          <p:cNvCxnSpPr>
-            <a:cxnSpLocks/>
-            <a:stCxn id="36" idx="7"/>
-            <a:endCxn id="36" idx="5"/>
-          </p:cNvCxnSpPr>
-          <p:nvPr/>
-        </p:nvCxnSpPr>
-        <p:spPr>
-          <a:xfrm rot="16200000" flipH="1">
-            <a:off x="6638378" y="3148576"/>
-            <a:ext cx="261158" cy="12700"/>
-          </a:xfrm>
-          <a:prstGeom prst="curvedConnector5">
-            <a:avLst>
-              <a:gd name="adj1" fmla="val -29177"/>
-              <a:gd name="adj2" fmla="val 2715339"/>
-              <a:gd name="adj3" fmla="val 125936"/>
-            </a:avLst>
-          </a:prstGeom>
-          <a:ln w="12700">
-            <a:solidFill>
-              <a:schemeClr val="tx1"/>
-            </a:solidFill>
-            <a:tailEnd type="triangle"/>
-          </a:ln>
-        </p:spPr>
-        <p:style>
-          <a:lnRef idx="1">
-            <a:schemeClr val="accent1"/>
-          </a:lnRef>
-          <a:fillRef idx="0">
-            <a:schemeClr val="accent1"/>
-          </a:fillRef>
-          <a:effectRef idx="0">
-            <a:schemeClr val="accent1"/>
-          </a:effectRef>
-          <a:fontRef idx="minor">
-            <a:schemeClr val="tx1"/>
-          </a:fontRef>
-        </p:style>
-      </p:cxnSp>
-      <p:cxnSp>
-        <p:nvCxnSpPr>
-          <p:cNvPr id="44" name="Curved Connector 43">
-            <a:extLst>
-              <a:ext uri="{FF2B5EF4-FFF2-40B4-BE49-F238E27FC236}">
-                <a16:creationId xmlns:a16="http://schemas.microsoft.com/office/drawing/2014/main" id="{80653195-6699-A897-3C31-9336367D696A}"/>
-              </a:ext>
-            </a:extLst>
-          </p:cNvPr>
-          <p:cNvCxnSpPr>
-            <a:cxnSpLocks/>
-            <a:stCxn id="35" idx="5"/>
-            <a:endCxn id="35" idx="3"/>
-          </p:cNvCxnSpPr>
-          <p:nvPr/>
-        </p:nvCxnSpPr>
-        <p:spPr>
-          <a:xfrm rot="5400000">
-            <a:off x="4281879" y="2947746"/>
-            <a:ext cx="12700" cy="661741"/>
-          </a:xfrm>
-          <a:prstGeom prst="curvedConnector3">
-            <a:avLst>
-              <a:gd name="adj1" fmla="val 2225882"/>
-            </a:avLst>
-          </a:prstGeom>
-          <a:ln w="12700">
-            <a:solidFill>
-              <a:schemeClr val="tx1"/>
-            </a:solidFill>
-            <a:tailEnd type="triangle"/>
-          </a:ln>
-        </p:spPr>
-        <p:style>
-          <a:lnRef idx="1">
-            <a:schemeClr val="accent1"/>
-          </a:lnRef>
-          <a:fillRef idx="0">
-            <a:schemeClr val="accent1"/>
-          </a:fillRef>
-          <a:effectRef idx="0">
-            <a:schemeClr val="accent1"/>
-          </a:effectRef>
-          <a:fontRef idx="minor">
-            <a:schemeClr val="tx1"/>
-          </a:fontRef>
-        </p:style>
-      </p:cxnSp>
-      <p:cxnSp>
-        <p:nvCxnSpPr>
-          <p:cNvPr id="47" name="Straight Arrow Connector 46">
-            <a:extLst>
-              <a:ext uri="{FF2B5EF4-FFF2-40B4-BE49-F238E27FC236}">
-                <a16:creationId xmlns:a16="http://schemas.microsoft.com/office/drawing/2014/main" id="{89200936-42E3-14C9-5E1A-58641D5BDC66}"/>
-              </a:ext>
-            </a:extLst>
-          </p:cNvPr>
-          <p:cNvCxnSpPr>
-            <a:cxnSpLocks/>
-            <a:stCxn id="39" idx="6"/>
-            <a:endCxn id="34" idx="2"/>
-          </p:cNvCxnSpPr>
-          <p:nvPr/>
-        </p:nvCxnSpPr>
-        <p:spPr>
-          <a:xfrm>
-            <a:off x="1980847" y="3139368"/>
-            <a:ext cx="430160" cy="7074"/>
-          </a:xfrm>
-          <a:prstGeom prst="straightConnector1">
-            <a:avLst/>
-          </a:prstGeom>
-          <a:ln w="12700">
-            <a:solidFill>
-              <a:schemeClr val="tx1"/>
-            </a:solidFill>
-            <a:tailEnd type="triangle"/>
-          </a:ln>
-        </p:spPr>
-        <p:style>
-          <a:lnRef idx="1">
-            <a:schemeClr val="accent1"/>
-          </a:lnRef>
-          <a:fillRef idx="0">
-            <a:schemeClr val="accent1"/>
-          </a:fillRef>
-          <a:effectRef idx="0">
-            <a:schemeClr val="accent1"/>
-          </a:effectRef>
-          <a:fontRef idx="minor">
-            <a:schemeClr val="tx1"/>
-          </a:fontRef>
-        </p:style>
-      </p:cxnSp>
-      <p:cxnSp>
-        <p:nvCxnSpPr>
-          <p:cNvPr id="48" name="Straight Arrow Connector 47">
-            <a:extLst>
-              <a:ext uri="{FF2B5EF4-FFF2-40B4-BE49-F238E27FC236}">
-                <a16:creationId xmlns:a16="http://schemas.microsoft.com/office/drawing/2014/main" id="{F83CFE18-8305-F606-6A3B-A8C1042B0811}"/>
-              </a:ext>
-            </a:extLst>
-          </p:cNvPr>
-          <p:cNvCxnSpPr>
-            <a:cxnSpLocks/>
-          </p:cNvCxnSpPr>
-          <p:nvPr/>
-        </p:nvCxnSpPr>
-        <p:spPr>
-          <a:xfrm>
-            <a:off x="1065895" y="3150429"/>
-            <a:ext cx="212755" cy="0"/>
-          </a:xfrm>
-          <a:prstGeom prst="straightConnector1">
-            <a:avLst/>
-          </a:prstGeom>
-          <a:ln w="12700">
-            <a:solidFill>
-              <a:schemeClr val="tx1"/>
-            </a:solidFill>
-            <a:tailEnd type="triangle"/>
-          </a:ln>
-        </p:spPr>
-        <p:style>
-          <a:lnRef idx="1">
-            <a:schemeClr val="accent1"/>
-          </a:lnRef>
-          <a:fillRef idx="0">
-            <a:schemeClr val="accent1"/>
-          </a:fillRef>
-          <a:effectRef idx="0">
-            <a:schemeClr val="accent1"/>
-          </a:effectRef>
-          <a:fontRef idx="minor">
-            <a:schemeClr val="tx1"/>
-          </a:fontRef>
-        </p:style>
-      </p:cxnSp>
-      <p:sp>
-        <p:nvSpPr>
-          <p:cNvPr id="50" name="TextBox 49">
-            <a:extLst>
-              <a:ext uri="{FF2B5EF4-FFF2-40B4-BE49-F238E27FC236}">
-                <a16:creationId xmlns:a16="http://schemas.microsoft.com/office/drawing/2014/main" id="{B5B06DD6-4BA1-F27D-333C-50B83DC3B0FE}"/>
-              </a:ext>
-            </a:extLst>
-          </p:cNvPr>
-          <p:cNvSpPr txBox="1"/>
-          <p:nvPr/>
-        </p:nvSpPr>
-        <p:spPr>
-          <a:xfrm>
-            <a:off x="3231014" y="3124727"/>
-            <a:ext cx="551754" cy="307777"/>
-          </a:xfrm>
-          <a:prstGeom prst="rect">
-            <a:avLst/>
-          </a:prstGeom>
-          <a:noFill/>
-        </p:spPr>
-        <p:txBody>
-          <a:bodyPr wrap="none" rtlCol="0">
-            <a:spAutoFit/>
-          </a:bodyPr>
-          <a:lstStyle/>
-          <a:p>
-            <a:r>
-              <a:rPr lang="en-NL" sz="1400" dirty="0"/>
-              <a:t>{try} </a:t>
-            </a:r>
-          </a:p>
-        </p:txBody>
-      </p:sp>
-      <p:sp>
-        <p:nvSpPr>
-          <p:cNvPr id="51" name="TextBox 50">
-            <a:extLst>
-              <a:ext uri="{FF2B5EF4-FFF2-40B4-BE49-F238E27FC236}">
-                <a16:creationId xmlns:a16="http://schemas.microsoft.com/office/drawing/2014/main" id="{C7F0842E-5F85-707E-5728-905813706C93}"/>
-              </a:ext>
-            </a:extLst>
-          </p:cNvPr>
-          <p:cNvSpPr txBox="1"/>
-          <p:nvPr/>
-        </p:nvSpPr>
-        <p:spPr>
-          <a:xfrm>
-            <a:off x="4812084" y="2838665"/>
-            <a:ext cx="1069524" cy="307777"/>
-          </a:xfrm>
-          <a:prstGeom prst="rect">
-            <a:avLst/>
-          </a:prstGeom>
-          <a:noFill/>
-        </p:spPr>
-        <p:txBody>
-          <a:bodyPr wrap="none" rtlCol="0">
-            <a:spAutoFit/>
-          </a:bodyPr>
-          <a:lstStyle/>
-          <a:p>
-            <a:r>
-              <a:rPr lang="en-NL" sz="1400" dirty="0"/>
-              <a:t>0.98 {succ}</a:t>
-            </a:r>
-          </a:p>
-        </p:txBody>
-      </p:sp>
-      <p:sp>
-        <p:nvSpPr>
-          <p:cNvPr id="53" name="TextBox 52">
-            <a:extLst>
-              <a:ext uri="{FF2B5EF4-FFF2-40B4-BE49-F238E27FC236}">
-                <a16:creationId xmlns:a16="http://schemas.microsoft.com/office/drawing/2014/main" id="{3B99DB0F-1B25-D50C-882E-B1B1378B0D1D}"/>
-              </a:ext>
-            </a:extLst>
-          </p:cNvPr>
-          <p:cNvSpPr txBox="1"/>
-          <p:nvPr/>
-        </p:nvSpPr>
-        <p:spPr>
-          <a:xfrm>
-            <a:off x="3920077" y="3592892"/>
-            <a:ext cx="949299" cy="307777"/>
-          </a:xfrm>
-          <a:prstGeom prst="rect">
-            <a:avLst/>
-          </a:prstGeom>
-          <a:noFill/>
-        </p:spPr>
-        <p:txBody>
-          <a:bodyPr wrap="none" rtlCol="0">
-            <a:spAutoFit/>
-          </a:bodyPr>
-          <a:lstStyle/>
-          <a:p>
-            <a:r>
-              <a:rPr lang="en-NL" sz="1400" dirty="0"/>
-              <a:t>0.01 {try} </a:t>
-            </a:r>
-          </a:p>
-        </p:txBody>
-      </p:sp>
-      <p:sp>
-        <p:nvSpPr>
-          <p:cNvPr id="54" name="TextBox 53">
-            <a:extLst>
-              <a:ext uri="{FF2B5EF4-FFF2-40B4-BE49-F238E27FC236}">
-                <a16:creationId xmlns:a16="http://schemas.microsoft.com/office/drawing/2014/main" id="{736EF116-4B78-B29C-F634-970290E3C65C}"/>
-              </a:ext>
-            </a:extLst>
-          </p:cNvPr>
-          <p:cNvSpPr txBox="1"/>
-          <p:nvPr/>
-        </p:nvSpPr>
-        <p:spPr>
-          <a:xfrm>
-            <a:off x="7094585" y="2977190"/>
-            <a:ext cx="671979" cy="307777"/>
-          </a:xfrm>
-          <a:prstGeom prst="rect">
-            <a:avLst/>
-          </a:prstGeom>
-          <a:noFill/>
-        </p:spPr>
-        <p:txBody>
-          <a:bodyPr wrap="none" rtlCol="0">
-            <a:spAutoFit/>
-          </a:bodyPr>
-          <a:lstStyle/>
-          <a:p>
-            <a:r>
-              <a:rPr lang="en-NL" sz="1400" dirty="0"/>
-              <a:t>{succ}</a:t>
-            </a:r>
-          </a:p>
-        </p:txBody>
-      </p:sp>
-      <p:sp>
-        <p:nvSpPr>
-          <p:cNvPr id="66" name="TextBox 65">
-            <a:extLst>
-              <a:ext uri="{FF2B5EF4-FFF2-40B4-BE49-F238E27FC236}">
-                <a16:creationId xmlns:a16="http://schemas.microsoft.com/office/drawing/2014/main" id="{0A09CAEB-092D-E57F-5D25-218423B39560}"/>
-              </a:ext>
-            </a:extLst>
-          </p:cNvPr>
-          <p:cNvSpPr txBox="1"/>
-          <p:nvPr/>
-        </p:nvSpPr>
-        <p:spPr>
-          <a:xfrm>
-            <a:off x="2038059" y="2840460"/>
-            <a:ext cx="328936" cy="369332"/>
-          </a:xfrm>
-          <a:prstGeom prst="rect">
-            <a:avLst/>
-          </a:prstGeom>
-          <a:noFill/>
-        </p:spPr>
-        <p:txBody>
-          <a:bodyPr wrap="none" rtlCol="0">
-            <a:spAutoFit/>
-          </a:bodyPr>
-          <a:lstStyle/>
-          <a:p>
-            <a:r>
-              <a:rPr lang="en-NL" dirty="0"/>
-              <a:t>∅</a:t>
-            </a:r>
-          </a:p>
-        </p:txBody>
-      </p:sp>
-      <p:sp>
-        <p:nvSpPr>
-          <p:cNvPr id="38" name="TextBox 37">
-            <a:extLst>
-              <a:ext uri="{FF2B5EF4-FFF2-40B4-BE49-F238E27FC236}">
-                <a16:creationId xmlns:a16="http://schemas.microsoft.com/office/drawing/2014/main" id="{CD7F566E-42FD-227C-5042-D4FBB2584C70}"/>
-              </a:ext>
-            </a:extLst>
-          </p:cNvPr>
-          <p:cNvSpPr txBox="1"/>
-          <p:nvPr/>
-        </p:nvSpPr>
-        <p:spPr>
-          <a:xfrm>
-            <a:off x="265226" y="2954702"/>
-            <a:ext cx="543739" cy="369332"/>
-          </a:xfrm>
-          <a:prstGeom prst="rect">
-            <a:avLst/>
-          </a:prstGeom>
-          <a:noFill/>
-        </p:spPr>
-        <p:txBody>
-          <a:bodyPr wrap="none" rtlCol="0">
-            <a:spAutoFit/>
-          </a:bodyPr>
-          <a:lstStyle/>
-          <a:p>
-            <a:r>
-              <a:rPr lang="en-NL" dirty="0"/>
-              <a:t>R2:</a:t>
             </a:r>
           </a:p>
         </p:txBody>
@@ -22642,8 +22887,8 @@
         </p:nvSpPr>
         <p:spPr>
           <a:xfrm>
-            <a:off x="473044" y="4052628"/>
-            <a:ext cx="7966633" cy="3416320"/>
+            <a:off x="427817" y="4123972"/>
+            <a:ext cx="8288366" cy="3416320"/>
           </a:xfrm>
           <a:prstGeom prst="rect">
             <a:avLst/>
@@ -22658,7 +22903,15 @@
           <a:p>
             <a:r>
               <a:rPr lang="en-NL" dirty="0"/>
-              <a:t>The colored boxes are the SCCs of R2. Only the blue one, let’s call it Z, is a bottom SCC.  Z contains a member of K, and no member of Z is in L. So, any execution satisfying 𝜑 will end up in Z. </a:t>
+              <a:t>The colored boxes are the </a:t>
+            </a:r>
+            <a:r>
+              <a:rPr lang="en-NL" b="1" dirty="0"/>
+              <a:t>bottom</a:t>
+            </a:r>
+            <a:r>
+              <a:rPr lang="en-NL" dirty="0"/>
+              <a:t> SCCs of R2. Only the blue one, let’s call it Z, contains a member of K. And: Z∩L=∅. So, any execution satisfying 𝜑 will end up in Z. </a:t>
             </a:r>
             <a:br>
               <a:rPr lang="en-NL" dirty="0"/>
@@ -22683,7 +22936,7 @@
             </a:r>
             <a:r>
               <a:rPr lang="en-NL" dirty="0"/>
-              <a:t>,w), 𝜑) = 1</a:t>
+              <a:t>,w), 𝜑) = 1. For the red-states: Prob((...,x), 𝜑) = 0</a:t>
             </a:r>
           </a:p>
           <a:p>
@@ -22800,41 +23053,6 @@
           </a:p>
           <a:p>
             <a:endParaRPr lang="en-NL" dirty="0"/>
-          </a:p>
-        </p:txBody>
-      </p:sp>
-      <p:sp>
-        <p:nvSpPr>
-          <p:cNvPr id="45" name="TextBox 44">
-            <a:extLst>
-              <a:ext uri="{FF2B5EF4-FFF2-40B4-BE49-F238E27FC236}">
-                <a16:creationId xmlns:a16="http://schemas.microsoft.com/office/drawing/2014/main" id="{DBBCB089-E283-CCDE-F963-458ED6EE8EE8}"/>
-              </a:ext>
-            </a:extLst>
-          </p:cNvPr>
-          <p:cNvSpPr txBox="1"/>
-          <p:nvPr/>
-        </p:nvSpPr>
-        <p:spPr>
-          <a:xfrm>
-            <a:off x="6661221" y="3692577"/>
-            <a:ext cx="325730" cy="369332"/>
-          </a:xfrm>
-          <a:prstGeom prst="rect">
-            <a:avLst/>
-          </a:prstGeom>
-          <a:noFill/>
-        </p:spPr>
-        <p:txBody>
-          <a:bodyPr wrap="none" rtlCol="0">
-            <a:spAutoFit/>
-          </a:bodyPr>
-          <a:lstStyle/>
-          <a:p>
-            <a:r>
-              <a:rPr lang="en-NL" dirty="0"/>
-              <a:t>Z</a:t>
-            </a:r>
           </a:p>
         </p:txBody>
       </p:sp>
@@ -22916,6 +23134,1512 @@
           </a:fontRef>
         </p:style>
       </p:cxnSp>
+      <p:sp>
+        <p:nvSpPr>
+          <p:cNvPr id="3" name="Oval 2">
+            <a:extLst>
+              <a:ext uri="{FF2B5EF4-FFF2-40B4-BE49-F238E27FC236}">
+                <a16:creationId xmlns:a16="http://schemas.microsoft.com/office/drawing/2014/main" id="{65D51D06-DDF8-CF98-C9B1-4C02AA8532AA}"/>
+              </a:ext>
+            </a:extLst>
+          </p:cNvPr>
+          <p:cNvSpPr/>
+          <p:nvPr/>
+        </p:nvSpPr>
+        <p:spPr>
+          <a:xfrm>
+            <a:off x="2425061" y="2443628"/>
+            <a:ext cx="788818" cy="369332"/>
+          </a:xfrm>
+          <a:prstGeom prst="ellipse">
+            <a:avLst/>
+          </a:prstGeom>
+          <a:solidFill>
+            <a:schemeClr val="accent4">
+              <a:lumMod val="40000"/>
+              <a:lumOff val="60000"/>
+            </a:schemeClr>
+          </a:solidFill>
+          <a:ln>
+            <a:solidFill>
+              <a:schemeClr val="tx1"/>
+            </a:solidFill>
+          </a:ln>
+        </p:spPr>
+        <p:style>
+          <a:lnRef idx="2">
+            <a:schemeClr val="accent1">
+              <a:shade val="50000"/>
+            </a:schemeClr>
+          </a:lnRef>
+          <a:fillRef idx="1">
+            <a:schemeClr val="accent1"/>
+          </a:fillRef>
+          <a:effectRef idx="0">
+            <a:schemeClr val="accent1"/>
+          </a:effectRef>
+          <a:fontRef idx="minor">
+            <a:schemeClr val="lt1"/>
+          </a:fontRef>
+        </p:style>
+        <p:txBody>
+          <a:bodyPr rtlCol="0" anchor="ctr"/>
+          <a:lstStyle/>
+          <a:p>
+            <a:pPr algn="ctr"/>
+            <a:r>
+              <a:rPr lang="en-NL" sz="1400" dirty="0">
+                <a:solidFill>
+                  <a:schemeClr val="tx1"/>
+                </a:solidFill>
+              </a:rPr>
+              <a:t>s</a:t>
+            </a:r>
+            <a:r>
+              <a:rPr lang="en-NL" sz="1400" baseline="-25000" dirty="0">
+                <a:solidFill>
+                  <a:schemeClr val="tx1"/>
+                </a:solidFill>
+              </a:rPr>
+              <a:t>0</a:t>
+            </a:r>
+            <a:r>
+              <a:rPr lang="en-NL" sz="1400" dirty="0">
+                <a:solidFill>
+                  <a:schemeClr val="tx1"/>
+                </a:solidFill>
+              </a:rPr>
+              <a:t>,v</a:t>
+            </a:r>
+          </a:p>
+        </p:txBody>
+      </p:sp>
+      <p:sp>
+        <p:nvSpPr>
+          <p:cNvPr id="6" name="Oval 5">
+            <a:extLst>
+              <a:ext uri="{FF2B5EF4-FFF2-40B4-BE49-F238E27FC236}">
+                <a16:creationId xmlns:a16="http://schemas.microsoft.com/office/drawing/2014/main" id="{30188103-4C36-BE17-A5A2-97A1FEEEF071}"/>
+              </a:ext>
+            </a:extLst>
+          </p:cNvPr>
+          <p:cNvSpPr/>
+          <p:nvPr/>
+        </p:nvSpPr>
+        <p:spPr>
+          <a:xfrm>
+            <a:off x="3828011" y="2445223"/>
+            <a:ext cx="935843" cy="369332"/>
+          </a:xfrm>
+          <a:prstGeom prst="ellipse">
+            <a:avLst/>
+          </a:prstGeom>
+          <a:solidFill>
+            <a:schemeClr val="accent4">
+              <a:lumMod val="40000"/>
+              <a:lumOff val="60000"/>
+            </a:schemeClr>
+          </a:solidFill>
+          <a:ln>
+            <a:solidFill>
+              <a:schemeClr val="tx1"/>
+            </a:solidFill>
+          </a:ln>
+        </p:spPr>
+        <p:style>
+          <a:lnRef idx="2">
+            <a:schemeClr val="accent1">
+              <a:shade val="50000"/>
+            </a:schemeClr>
+          </a:lnRef>
+          <a:fillRef idx="1">
+            <a:schemeClr val="accent1"/>
+          </a:fillRef>
+          <a:effectRef idx="0">
+            <a:schemeClr val="accent1"/>
+          </a:effectRef>
+          <a:fontRef idx="minor">
+            <a:schemeClr val="lt1"/>
+          </a:fontRef>
+        </p:style>
+        <p:txBody>
+          <a:bodyPr rtlCol="0" anchor="ctr"/>
+          <a:lstStyle/>
+          <a:p>
+            <a:pPr algn="ctr"/>
+            <a:r>
+              <a:rPr lang="en-NL" sz="1400" dirty="0">
+                <a:solidFill>
+                  <a:schemeClr val="tx1"/>
+                </a:solidFill>
+              </a:rPr>
+              <a:t>s</a:t>
+            </a:r>
+            <a:r>
+              <a:rPr lang="en-NL" sz="1400" baseline="-25000" dirty="0">
+                <a:solidFill>
+                  <a:schemeClr val="tx1"/>
+                </a:solidFill>
+              </a:rPr>
+              <a:t>1</a:t>
+            </a:r>
+            <a:r>
+              <a:rPr lang="en-NL" sz="1400" dirty="0">
+                <a:solidFill>
+                  <a:schemeClr val="tx1"/>
+                </a:solidFill>
+              </a:rPr>
+              <a:t>,v</a:t>
+            </a:r>
+          </a:p>
+        </p:txBody>
+      </p:sp>
+      <p:sp>
+        <p:nvSpPr>
+          <p:cNvPr id="9" name="Oval 8">
+            <a:extLst>
+              <a:ext uri="{FF2B5EF4-FFF2-40B4-BE49-F238E27FC236}">
+                <a16:creationId xmlns:a16="http://schemas.microsoft.com/office/drawing/2014/main" id="{2D53A7FB-601D-5076-6715-E495312EAF91}"/>
+              </a:ext>
+            </a:extLst>
+          </p:cNvPr>
+          <p:cNvSpPr/>
+          <p:nvPr/>
+        </p:nvSpPr>
+        <p:spPr>
+          <a:xfrm>
+            <a:off x="6107963" y="2445762"/>
+            <a:ext cx="790868" cy="369332"/>
+          </a:xfrm>
+          <a:prstGeom prst="ellipse">
+            <a:avLst/>
+          </a:prstGeom>
+          <a:solidFill>
+            <a:schemeClr val="accent4">
+              <a:lumMod val="40000"/>
+              <a:lumOff val="60000"/>
+            </a:schemeClr>
+          </a:solidFill>
+          <a:ln>
+            <a:solidFill>
+              <a:schemeClr val="tx1"/>
+            </a:solidFill>
+          </a:ln>
+        </p:spPr>
+        <p:style>
+          <a:lnRef idx="2">
+            <a:schemeClr val="accent1">
+              <a:shade val="50000"/>
+            </a:schemeClr>
+          </a:lnRef>
+          <a:fillRef idx="1">
+            <a:schemeClr val="accent1"/>
+          </a:fillRef>
+          <a:effectRef idx="0">
+            <a:schemeClr val="accent1"/>
+          </a:effectRef>
+          <a:fontRef idx="minor">
+            <a:schemeClr val="lt1"/>
+          </a:fontRef>
+        </p:style>
+        <p:txBody>
+          <a:bodyPr rtlCol="0" anchor="ctr"/>
+          <a:lstStyle/>
+          <a:p>
+            <a:pPr algn="ctr"/>
+            <a:r>
+              <a:rPr lang="en-NL" sz="1400" dirty="0">
+                <a:solidFill>
+                  <a:schemeClr val="tx1"/>
+                </a:solidFill>
+              </a:rPr>
+              <a:t>s</a:t>
+            </a:r>
+            <a:r>
+              <a:rPr lang="en-NL" sz="1400" baseline="-25000" dirty="0">
+                <a:solidFill>
+                  <a:schemeClr val="tx1"/>
+                </a:solidFill>
+              </a:rPr>
+              <a:t>3</a:t>
+            </a:r>
+            <a:r>
+              <a:rPr lang="en-NL" sz="1400" dirty="0">
+                <a:solidFill>
+                  <a:schemeClr val="tx1"/>
+                </a:solidFill>
+              </a:rPr>
+              <a:t>,w</a:t>
+            </a:r>
+          </a:p>
+        </p:txBody>
+      </p:sp>
+      <p:sp>
+        <p:nvSpPr>
+          <p:cNvPr id="10" name="Oval 9">
+            <a:extLst>
+              <a:ext uri="{FF2B5EF4-FFF2-40B4-BE49-F238E27FC236}">
+                <a16:creationId xmlns:a16="http://schemas.microsoft.com/office/drawing/2014/main" id="{6E8F69A1-96FA-CEA7-316D-DF7FBCB66CBE}"/>
+              </a:ext>
+            </a:extLst>
+          </p:cNvPr>
+          <p:cNvSpPr/>
+          <p:nvPr/>
+        </p:nvSpPr>
+        <p:spPr>
+          <a:xfrm>
+            <a:off x="1280424" y="2436554"/>
+            <a:ext cx="714477" cy="369332"/>
+          </a:xfrm>
+          <a:prstGeom prst="ellipse">
+            <a:avLst/>
+          </a:prstGeom>
+          <a:solidFill>
+            <a:schemeClr val="accent3">
+              <a:lumMod val="20000"/>
+              <a:lumOff val="80000"/>
+            </a:schemeClr>
+          </a:solidFill>
+          <a:ln>
+            <a:solidFill>
+              <a:schemeClr val="tx1"/>
+            </a:solidFill>
+          </a:ln>
+        </p:spPr>
+        <p:style>
+          <a:lnRef idx="2">
+            <a:schemeClr val="accent1">
+              <a:shade val="50000"/>
+            </a:schemeClr>
+          </a:lnRef>
+          <a:fillRef idx="1">
+            <a:schemeClr val="accent1"/>
+          </a:fillRef>
+          <a:effectRef idx="0">
+            <a:schemeClr val="accent1"/>
+          </a:effectRef>
+          <a:fontRef idx="minor">
+            <a:schemeClr val="lt1"/>
+          </a:fontRef>
+        </p:style>
+        <p:txBody>
+          <a:bodyPr rtlCol="0" anchor="ctr"/>
+          <a:lstStyle/>
+          <a:p>
+            <a:pPr algn="ctr"/>
+            <a:r>
+              <a:rPr lang="en-NL" sz="1400" dirty="0">
+                <a:solidFill>
+                  <a:schemeClr val="tx1"/>
+                </a:solidFill>
+              </a:rPr>
+              <a:t>z,u</a:t>
+            </a:r>
+            <a:endParaRPr lang="en-NL" sz="1400" baseline="-25000" dirty="0">
+              <a:solidFill>
+                <a:schemeClr val="tx1"/>
+              </a:solidFill>
+            </a:endParaRPr>
+          </a:p>
+        </p:txBody>
+      </p:sp>
+      <p:cxnSp>
+        <p:nvCxnSpPr>
+          <p:cNvPr id="11" name="Straight Arrow Connector 10">
+            <a:extLst>
+              <a:ext uri="{FF2B5EF4-FFF2-40B4-BE49-F238E27FC236}">
+                <a16:creationId xmlns:a16="http://schemas.microsoft.com/office/drawing/2014/main" id="{DADF39D1-B6C3-8878-AA06-E0D4360751D6}"/>
+              </a:ext>
+            </a:extLst>
+          </p:cNvPr>
+          <p:cNvCxnSpPr>
+            <a:cxnSpLocks/>
+            <a:stCxn id="3" idx="6"/>
+            <a:endCxn id="6" idx="2"/>
+          </p:cNvCxnSpPr>
+          <p:nvPr/>
+        </p:nvCxnSpPr>
+        <p:spPr>
+          <a:xfrm>
+            <a:off x="3213879" y="2628294"/>
+            <a:ext cx="614132" cy="1595"/>
+          </a:xfrm>
+          <a:prstGeom prst="straightConnector1">
+            <a:avLst/>
+          </a:prstGeom>
+          <a:ln w="12700">
+            <a:solidFill>
+              <a:schemeClr val="tx1"/>
+            </a:solidFill>
+            <a:tailEnd type="triangle"/>
+          </a:ln>
+        </p:spPr>
+        <p:style>
+          <a:lnRef idx="1">
+            <a:schemeClr val="accent1"/>
+          </a:lnRef>
+          <a:fillRef idx="0">
+            <a:schemeClr val="accent1"/>
+          </a:fillRef>
+          <a:effectRef idx="0">
+            <a:schemeClr val="accent1"/>
+          </a:effectRef>
+          <a:fontRef idx="minor">
+            <a:schemeClr val="tx1"/>
+          </a:fontRef>
+        </p:style>
+      </p:cxnSp>
+      <p:cxnSp>
+        <p:nvCxnSpPr>
+          <p:cNvPr id="12" name="Straight Arrow Connector 11">
+            <a:extLst>
+              <a:ext uri="{FF2B5EF4-FFF2-40B4-BE49-F238E27FC236}">
+                <a16:creationId xmlns:a16="http://schemas.microsoft.com/office/drawing/2014/main" id="{77AEF33C-0F6A-5264-1F66-3D8DEFA77ACD}"/>
+              </a:ext>
+            </a:extLst>
+          </p:cNvPr>
+          <p:cNvCxnSpPr>
+            <a:cxnSpLocks/>
+            <a:stCxn id="6" idx="6"/>
+            <a:endCxn id="9" idx="2"/>
+          </p:cNvCxnSpPr>
+          <p:nvPr/>
+        </p:nvCxnSpPr>
+        <p:spPr>
+          <a:xfrm>
+            <a:off x="4763854" y="2629889"/>
+            <a:ext cx="1344109" cy="539"/>
+          </a:xfrm>
+          <a:prstGeom prst="straightConnector1">
+            <a:avLst/>
+          </a:prstGeom>
+          <a:ln w="12700">
+            <a:solidFill>
+              <a:schemeClr val="tx1"/>
+            </a:solidFill>
+            <a:tailEnd type="triangle"/>
+          </a:ln>
+        </p:spPr>
+        <p:style>
+          <a:lnRef idx="1">
+            <a:schemeClr val="accent1"/>
+          </a:lnRef>
+          <a:fillRef idx="0">
+            <a:schemeClr val="accent1"/>
+          </a:fillRef>
+          <a:effectRef idx="0">
+            <a:schemeClr val="accent1"/>
+          </a:effectRef>
+          <a:fontRef idx="minor">
+            <a:schemeClr val="tx1"/>
+          </a:fontRef>
+        </p:style>
+      </p:cxnSp>
+      <p:cxnSp>
+        <p:nvCxnSpPr>
+          <p:cNvPr id="13" name="Curved Connector 12">
+            <a:extLst>
+              <a:ext uri="{FF2B5EF4-FFF2-40B4-BE49-F238E27FC236}">
+                <a16:creationId xmlns:a16="http://schemas.microsoft.com/office/drawing/2014/main" id="{51E58A5B-09DD-4EE6-A96A-B8B7DBC70035}"/>
+              </a:ext>
+            </a:extLst>
+          </p:cNvPr>
+          <p:cNvCxnSpPr>
+            <a:cxnSpLocks/>
+            <a:stCxn id="9" idx="7"/>
+            <a:endCxn id="9" idx="5"/>
+          </p:cNvCxnSpPr>
+          <p:nvPr/>
+        </p:nvCxnSpPr>
+        <p:spPr>
+          <a:xfrm rot="16200000" flipH="1">
+            <a:off x="6652432" y="2630428"/>
+            <a:ext cx="261158" cy="12700"/>
+          </a:xfrm>
+          <a:prstGeom prst="curvedConnector5">
+            <a:avLst>
+              <a:gd name="adj1" fmla="val -29177"/>
+              <a:gd name="adj2" fmla="val 2715339"/>
+              <a:gd name="adj3" fmla="val 125936"/>
+            </a:avLst>
+          </a:prstGeom>
+          <a:ln w="12700">
+            <a:solidFill>
+              <a:schemeClr val="tx1"/>
+            </a:solidFill>
+            <a:tailEnd type="triangle"/>
+          </a:ln>
+        </p:spPr>
+        <p:style>
+          <a:lnRef idx="1">
+            <a:schemeClr val="accent1"/>
+          </a:lnRef>
+          <a:fillRef idx="0">
+            <a:schemeClr val="accent1"/>
+          </a:fillRef>
+          <a:effectRef idx="0">
+            <a:schemeClr val="accent1"/>
+          </a:effectRef>
+          <a:fontRef idx="minor">
+            <a:schemeClr val="tx1"/>
+          </a:fontRef>
+        </p:style>
+      </p:cxnSp>
+      <p:cxnSp>
+        <p:nvCxnSpPr>
+          <p:cNvPr id="14" name="Curved Connector 13">
+            <a:extLst>
+              <a:ext uri="{FF2B5EF4-FFF2-40B4-BE49-F238E27FC236}">
+                <a16:creationId xmlns:a16="http://schemas.microsoft.com/office/drawing/2014/main" id="{BEFCE647-255E-7CF6-9722-99F9F2611B96}"/>
+              </a:ext>
+            </a:extLst>
+          </p:cNvPr>
+          <p:cNvCxnSpPr>
+            <a:cxnSpLocks/>
+            <a:stCxn id="6" idx="5"/>
+            <a:endCxn id="6" idx="3"/>
+          </p:cNvCxnSpPr>
+          <p:nvPr/>
+        </p:nvCxnSpPr>
+        <p:spPr>
+          <a:xfrm rot="5400000">
+            <a:off x="4295933" y="2429598"/>
+            <a:ext cx="12700" cy="661741"/>
+          </a:xfrm>
+          <a:prstGeom prst="curvedConnector3">
+            <a:avLst>
+              <a:gd name="adj1" fmla="val 2225882"/>
+            </a:avLst>
+          </a:prstGeom>
+          <a:ln w="12700">
+            <a:solidFill>
+              <a:schemeClr val="tx1"/>
+            </a:solidFill>
+            <a:tailEnd type="triangle"/>
+          </a:ln>
+        </p:spPr>
+        <p:style>
+          <a:lnRef idx="1">
+            <a:schemeClr val="accent1"/>
+          </a:lnRef>
+          <a:fillRef idx="0">
+            <a:schemeClr val="accent1"/>
+          </a:fillRef>
+          <a:effectRef idx="0">
+            <a:schemeClr val="accent1"/>
+          </a:effectRef>
+          <a:fontRef idx="minor">
+            <a:schemeClr val="tx1"/>
+          </a:fontRef>
+        </p:style>
+      </p:cxnSp>
+      <p:cxnSp>
+        <p:nvCxnSpPr>
+          <p:cNvPr id="15" name="Straight Arrow Connector 14">
+            <a:extLst>
+              <a:ext uri="{FF2B5EF4-FFF2-40B4-BE49-F238E27FC236}">
+                <a16:creationId xmlns:a16="http://schemas.microsoft.com/office/drawing/2014/main" id="{89B08EB2-10E2-0316-E778-C4E9545E8983}"/>
+              </a:ext>
+            </a:extLst>
+          </p:cNvPr>
+          <p:cNvCxnSpPr>
+            <a:cxnSpLocks/>
+            <a:stCxn id="10" idx="6"/>
+            <a:endCxn id="3" idx="2"/>
+          </p:cNvCxnSpPr>
+          <p:nvPr/>
+        </p:nvCxnSpPr>
+        <p:spPr>
+          <a:xfrm>
+            <a:off x="1994901" y="2621220"/>
+            <a:ext cx="430160" cy="7074"/>
+          </a:xfrm>
+          <a:prstGeom prst="straightConnector1">
+            <a:avLst/>
+          </a:prstGeom>
+          <a:ln w="12700">
+            <a:solidFill>
+              <a:schemeClr val="tx1"/>
+            </a:solidFill>
+            <a:tailEnd type="triangle"/>
+          </a:ln>
+        </p:spPr>
+        <p:style>
+          <a:lnRef idx="1">
+            <a:schemeClr val="accent1"/>
+          </a:lnRef>
+          <a:fillRef idx="0">
+            <a:schemeClr val="accent1"/>
+          </a:fillRef>
+          <a:effectRef idx="0">
+            <a:schemeClr val="accent1"/>
+          </a:effectRef>
+          <a:fontRef idx="minor">
+            <a:schemeClr val="tx1"/>
+          </a:fontRef>
+        </p:style>
+      </p:cxnSp>
+      <p:cxnSp>
+        <p:nvCxnSpPr>
+          <p:cNvPr id="16" name="Straight Arrow Connector 15">
+            <a:extLst>
+              <a:ext uri="{FF2B5EF4-FFF2-40B4-BE49-F238E27FC236}">
+                <a16:creationId xmlns:a16="http://schemas.microsoft.com/office/drawing/2014/main" id="{DBD7367B-16D2-971C-31AD-5B8132AF08B0}"/>
+              </a:ext>
+            </a:extLst>
+          </p:cNvPr>
+          <p:cNvCxnSpPr>
+            <a:cxnSpLocks/>
+          </p:cNvCxnSpPr>
+          <p:nvPr/>
+        </p:nvCxnSpPr>
+        <p:spPr>
+          <a:xfrm>
+            <a:off x="1079949" y="2632281"/>
+            <a:ext cx="212755" cy="0"/>
+          </a:xfrm>
+          <a:prstGeom prst="straightConnector1">
+            <a:avLst/>
+          </a:prstGeom>
+          <a:ln w="12700">
+            <a:solidFill>
+              <a:schemeClr val="tx1"/>
+            </a:solidFill>
+            <a:tailEnd type="triangle"/>
+          </a:ln>
+        </p:spPr>
+        <p:style>
+          <a:lnRef idx="1">
+            <a:schemeClr val="accent1"/>
+          </a:lnRef>
+          <a:fillRef idx="0">
+            <a:schemeClr val="accent1"/>
+          </a:fillRef>
+          <a:effectRef idx="0">
+            <a:schemeClr val="accent1"/>
+          </a:effectRef>
+          <a:fontRef idx="minor">
+            <a:schemeClr val="tx1"/>
+          </a:fontRef>
+        </p:style>
+      </p:cxnSp>
+      <p:sp>
+        <p:nvSpPr>
+          <p:cNvPr id="17" name="TextBox 16">
+            <a:extLst>
+              <a:ext uri="{FF2B5EF4-FFF2-40B4-BE49-F238E27FC236}">
+                <a16:creationId xmlns:a16="http://schemas.microsoft.com/office/drawing/2014/main" id="{A4A21DAE-D181-C7F5-B590-FC3510B81B02}"/>
+              </a:ext>
+            </a:extLst>
+          </p:cNvPr>
+          <p:cNvSpPr txBox="1"/>
+          <p:nvPr/>
+        </p:nvSpPr>
+        <p:spPr>
+          <a:xfrm>
+            <a:off x="3245068" y="2606579"/>
+            <a:ext cx="551754" cy="307777"/>
+          </a:xfrm>
+          <a:prstGeom prst="rect">
+            <a:avLst/>
+          </a:prstGeom>
+          <a:noFill/>
+        </p:spPr>
+        <p:txBody>
+          <a:bodyPr wrap="none" rtlCol="0">
+            <a:spAutoFit/>
+          </a:bodyPr>
+          <a:lstStyle/>
+          <a:p>
+            <a:r>
+              <a:rPr lang="en-NL" sz="1400" dirty="0"/>
+              <a:t>{try} </a:t>
+            </a:r>
+          </a:p>
+        </p:txBody>
+      </p:sp>
+      <p:sp>
+        <p:nvSpPr>
+          <p:cNvPr id="18" name="TextBox 17">
+            <a:extLst>
+              <a:ext uri="{FF2B5EF4-FFF2-40B4-BE49-F238E27FC236}">
+                <a16:creationId xmlns:a16="http://schemas.microsoft.com/office/drawing/2014/main" id="{09F20607-E933-0D50-AFE8-B2C6FC8DB494}"/>
+              </a:ext>
+            </a:extLst>
+          </p:cNvPr>
+          <p:cNvSpPr txBox="1"/>
+          <p:nvPr/>
+        </p:nvSpPr>
+        <p:spPr>
+          <a:xfrm>
+            <a:off x="4826138" y="2320517"/>
+            <a:ext cx="1069524" cy="307777"/>
+          </a:xfrm>
+          <a:prstGeom prst="rect">
+            <a:avLst/>
+          </a:prstGeom>
+          <a:noFill/>
+        </p:spPr>
+        <p:txBody>
+          <a:bodyPr wrap="none" rtlCol="0">
+            <a:spAutoFit/>
+          </a:bodyPr>
+          <a:lstStyle/>
+          <a:p>
+            <a:r>
+              <a:rPr lang="en-NL" sz="1400" dirty="0">
+                <a:highlight>
+                  <a:srgbClr val="00FF00"/>
+                </a:highlight>
+              </a:rPr>
+              <a:t>0.98</a:t>
+            </a:r>
+            <a:r>
+              <a:rPr lang="en-NL" sz="1400" dirty="0"/>
+              <a:t> {succ}</a:t>
+            </a:r>
+          </a:p>
+        </p:txBody>
+      </p:sp>
+      <p:sp>
+        <p:nvSpPr>
+          <p:cNvPr id="19" name="TextBox 18">
+            <a:extLst>
+              <a:ext uri="{FF2B5EF4-FFF2-40B4-BE49-F238E27FC236}">
+                <a16:creationId xmlns:a16="http://schemas.microsoft.com/office/drawing/2014/main" id="{30CBAD70-B9AD-E2C1-3D81-08C8F0AB16AA}"/>
+              </a:ext>
+            </a:extLst>
+          </p:cNvPr>
+          <p:cNvSpPr txBox="1"/>
+          <p:nvPr/>
+        </p:nvSpPr>
+        <p:spPr>
+          <a:xfrm>
+            <a:off x="3934131" y="3074744"/>
+            <a:ext cx="949299" cy="307777"/>
+          </a:xfrm>
+          <a:prstGeom prst="rect">
+            <a:avLst/>
+          </a:prstGeom>
+          <a:noFill/>
+        </p:spPr>
+        <p:txBody>
+          <a:bodyPr wrap="none" rtlCol="0">
+            <a:spAutoFit/>
+          </a:bodyPr>
+          <a:lstStyle/>
+          <a:p>
+            <a:r>
+              <a:rPr lang="en-NL" sz="1400" dirty="0">
+                <a:highlight>
+                  <a:srgbClr val="00FF00"/>
+                </a:highlight>
+              </a:rPr>
+              <a:t>0.01</a:t>
+            </a:r>
+            <a:r>
+              <a:rPr lang="en-NL" sz="1400" dirty="0"/>
+              <a:t> {try} </a:t>
+            </a:r>
+          </a:p>
+        </p:txBody>
+      </p:sp>
+      <p:sp>
+        <p:nvSpPr>
+          <p:cNvPr id="20" name="TextBox 19">
+            <a:extLst>
+              <a:ext uri="{FF2B5EF4-FFF2-40B4-BE49-F238E27FC236}">
+                <a16:creationId xmlns:a16="http://schemas.microsoft.com/office/drawing/2014/main" id="{6BB18A42-0E8C-8782-930F-0DB234DD89CF}"/>
+              </a:ext>
+            </a:extLst>
+          </p:cNvPr>
+          <p:cNvSpPr txBox="1"/>
+          <p:nvPr/>
+        </p:nvSpPr>
+        <p:spPr>
+          <a:xfrm>
+            <a:off x="7108639" y="2459042"/>
+            <a:ext cx="671979" cy="307777"/>
+          </a:xfrm>
+          <a:prstGeom prst="rect">
+            <a:avLst/>
+          </a:prstGeom>
+          <a:noFill/>
+        </p:spPr>
+        <p:txBody>
+          <a:bodyPr wrap="none" rtlCol="0">
+            <a:spAutoFit/>
+          </a:bodyPr>
+          <a:lstStyle/>
+          <a:p>
+            <a:r>
+              <a:rPr lang="en-NL" sz="1400" dirty="0"/>
+              <a:t>{succ}</a:t>
+            </a:r>
+          </a:p>
+        </p:txBody>
+      </p:sp>
+      <p:sp>
+        <p:nvSpPr>
+          <p:cNvPr id="21" name="TextBox 20">
+            <a:extLst>
+              <a:ext uri="{FF2B5EF4-FFF2-40B4-BE49-F238E27FC236}">
+                <a16:creationId xmlns:a16="http://schemas.microsoft.com/office/drawing/2014/main" id="{73A75F3D-5924-F112-435C-F8F213C41787}"/>
+              </a:ext>
+            </a:extLst>
+          </p:cNvPr>
+          <p:cNvSpPr txBox="1"/>
+          <p:nvPr/>
+        </p:nvSpPr>
+        <p:spPr>
+          <a:xfrm>
+            <a:off x="2052113" y="2322312"/>
+            <a:ext cx="328936" cy="369332"/>
+          </a:xfrm>
+          <a:prstGeom prst="rect">
+            <a:avLst/>
+          </a:prstGeom>
+          <a:noFill/>
+        </p:spPr>
+        <p:txBody>
+          <a:bodyPr wrap="none" rtlCol="0">
+            <a:spAutoFit/>
+          </a:bodyPr>
+          <a:lstStyle/>
+          <a:p>
+            <a:r>
+              <a:rPr lang="en-NL" dirty="0"/>
+              <a:t>∅</a:t>
+            </a:r>
+          </a:p>
+        </p:txBody>
+      </p:sp>
+      <p:sp>
+        <p:nvSpPr>
+          <p:cNvPr id="22" name="TextBox 21">
+            <a:extLst>
+              <a:ext uri="{FF2B5EF4-FFF2-40B4-BE49-F238E27FC236}">
+                <a16:creationId xmlns:a16="http://schemas.microsoft.com/office/drawing/2014/main" id="{97DA442A-ED70-C90C-5F2E-233FB6F9674D}"/>
+              </a:ext>
+            </a:extLst>
+          </p:cNvPr>
+          <p:cNvSpPr txBox="1"/>
+          <p:nvPr/>
+        </p:nvSpPr>
+        <p:spPr>
+          <a:xfrm>
+            <a:off x="487584" y="2428264"/>
+            <a:ext cx="543739" cy="369332"/>
+          </a:xfrm>
+          <a:prstGeom prst="rect">
+            <a:avLst/>
+          </a:prstGeom>
+          <a:noFill/>
+        </p:spPr>
+        <p:txBody>
+          <a:bodyPr wrap="none" rtlCol="0">
+            <a:spAutoFit/>
+          </a:bodyPr>
+          <a:lstStyle/>
+          <a:p>
+            <a:r>
+              <a:rPr lang="en-NL" dirty="0"/>
+              <a:t>R2:</a:t>
+            </a:r>
+          </a:p>
+        </p:txBody>
+      </p:sp>
+      <p:sp>
+        <p:nvSpPr>
+          <p:cNvPr id="23" name="Oval 22">
+            <a:extLst>
+              <a:ext uri="{FF2B5EF4-FFF2-40B4-BE49-F238E27FC236}">
+                <a16:creationId xmlns:a16="http://schemas.microsoft.com/office/drawing/2014/main" id="{DBB2D33D-C8C8-BA43-8E4B-69D5E2176CEC}"/>
+              </a:ext>
+            </a:extLst>
+          </p:cNvPr>
+          <p:cNvSpPr/>
+          <p:nvPr/>
+        </p:nvSpPr>
+        <p:spPr>
+          <a:xfrm>
+            <a:off x="5344744" y="2928329"/>
+            <a:ext cx="676570" cy="369332"/>
+          </a:xfrm>
+          <a:prstGeom prst="ellipse">
+            <a:avLst/>
+          </a:prstGeom>
+          <a:solidFill>
+            <a:schemeClr val="accent2">
+              <a:lumMod val="20000"/>
+              <a:lumOff val="80000"/>
+            </a:schemeClr>
+          </a:solidFill>
+          <a:ln>
+            <a:solidFill>
+              <a:schemeClr val="tx1"/>
+            </a:solidFill>
+          </a:ln>
+        </p:spPr>
+        <p:style>
+          <a:lnRef idx="2">
+            <a:schemeClr val="accent1">
+              <a:shade val="50000"/>
+            </a:schemeClr>
+          </a:lnRef>
+          <a:fillRef idx="1">
+            <a:schemeClr val="accent1"/>
+          </a:fillRef>
+          <a:effectRef idx="0">
+            <a:schemeClr val="accent1"/>
+          </a:effectRef>
+          <a:fontRef idx="minor">
+            <a:schemeClr val="lt1"/>
+          </a:fontRef>
+        </p:style>
+        <p:txBody>
+          <a:bodyPr rtlCol="0" anchor="ctr"/>
+          <a:lstStyle/>
+          <a:p>
+            <a:pPr algn="ctr"/>
+            <a:r>
+              <a:rPr lang="en-NL" sz="1400" dirty="0">
+                <a:solidFill>
+                  <a:schemeClr val="tx1"/>
+                </a:solidFill>
+              </a:rPr>
+              <a:t>s</a:t>
+            </a:r>
+            <a:r>
+              <a:rPr lang="en-NL" sz="1400" baseline="-25000" dirty="0">
+                <a:solidFill>
+                  <a:schemeClr val="tx1"/>
+                </a:solidFill>
+              </a:rPr>
+              <a:t>2</a:t>
+            </a:r>
+            <a:r>
+              <a:rPr lang="en-NL" sz="1400" dirty="0">
+                <a:solidFill>
+                  <a:schemeClr val="tx1"/>
+                </a:solidFill>
+              </a:rPr>
+              <a:t>,x</a:t>
+            </a:r>
+          </a:p>
+        </p:txBody>
+      </p:sp>
+      <p:cxnSp>
+        <p:nvCxnSpPr>
+          <p:cNvPr id="24" name="Straight Arrow Connector 23">
+            <a:extLst>
+              <a:ext uri="{FF2B5EF4-FFF2-40B4-BE49-F238E27FC236}">
+                <a16:creationId xmlns:a16="http://schemas.microsoft.com/office/drawing/2014/main" id="{A09DD103-CC3B-0DD9-4CB3-2110C63E6F70}"/>
+              </a:ext>
+            </a:extLst>
+          </p:cNvPr>
+          <p:cNvCxnSpPr>
+            <a:cxnSpLocks/>
+            <a:stCxn id="6" idx="5"/>
+            <a:endCxn id="23" idx="1"/>
+          </p:cNvCxnSpPr>
+          <p:nvPr/>
+        </p:nvCxnSpPr>
+        <p:spPr>
+          <a:xfrm>
+            <a:off x="4626803" y="2760468"/>
+            <a:ext cx="817022" cy="221948"/>
+          </a:xfrm>
+          <a:prstGeom prst="straightConnector1">
+            <a:avLst/>
+          </a:prstGeom>
+          <a:ln w="12700">
+            <a:solidFill>
+              <a:schemeClr val="tx1"/>
+            </a:solidFill>
+            <a:tailEnd type="triangle"/>
+          </a:ln>
+        </p:spPr>
+        <p:style>
+          <a:lnRef idx="1">
+            <a:schemeClr val="accent1"/>
+          </a:lnRef>
+          <a:fillRef idx="0">
+            <a:schemeClr val="accent1"/>
+          </a:fillRef>
+          <a:effectRef idx="0">
+            <a:schemeClr val="accent1"/>
+          </a:effectRef>
+          <a:fontRef idx="minor">
+            <a:schemeClr val="tx1"/>
+          </a:fontRef>
+        </p:style>
+      </p:cxnSp>
+      <p:sp>
+        <p:nvSpPr>
+          <p:cNvPr id="25" name="Oval 24">
+            <a:extLst>
+              <a:ext uri="{FF2B5EF4-FFF2-40B4-BE49-F238E27FC236}">
+                <a16:creationId xmlns:a16="http://schemas.microsoft.com/office/drawing/2014/main" id="{E6B63F0A-1073-732D-2505-476E37487172}"/>
+              </a:ext>
+            </a:extLst>
+          </p:cNvPr>
+          <p:cNvSpPr/>
+          <p:nvPr/>
+        </p:nvSpPr>
+        <p:spPr>
+          <a:xfrm>
+            <a:off x="4505720" y="3569974"/>
+            <a:ext cx="676570" cy="369332"/>
+          </a:xfrm>
+          <a:prstGeom prst="ellipse">
+            <a:avLst/>
+          </a:prstGeom>
+          <a:solidFill>
+            <a:schemeClr val="accent2">
+              <a:lumMod val="20000"/>
+              <a:lumOff val="80000"/>
+            </a:schemeClr>
+          </a:solidFill>
+          <a:ln>
+            <a:solidFill>
+              <a:schemeClr val="tx1"/>
+            </a:solidFill>
+          </a:ln>
+        </p:spPr>
+        <p:style>
+          <a:lnRef idx="2">
+            <a:schemeClr val="accent1">
+              <a:shade val="50000"/>
+            </a:schemeClr>
+          </a:lnRef>
+          <a:fillRef idx="1">
+            <a:schemeClr val="accent1"/>
+          </a:fillRef>
+          <a:effectRef idx="0">
+            <a:schemeClr val="accent1"/>
+          </a:effectRef>
+          <a:fontRef idx="minor">
+            <a:schemeClr val="lt1"/>
+          </a:fontRef>
+        </p:style>
+        <p:txBody>
+          <a:bodyPr rtlCol="0" anchor="ctr"/>
+          <a:lstStyle/>
+          <a:p>
+            <a:pPr algn="ctr"/>
+            <a:r>
+              <a:rPr lang="en-NL" sz="1400" dirty="0">
+                <a:solidFill>
+                  <a:schemeClr val="tx1"/>
+                </a:solidFill>
+              </a:rPr>
+              <a:t>s</a:t>
+            </a:r>
+            <a:r>
+              <a:rPr lang="en-NL" sz="1400" baseline="-25000" dirty="0">
+                <a:solidFill>
+                  <a:schemeClr val="tx1"/>
+                </a:solidFill>
+              </a:rPr>
+              <a:t>0</a:t>
+            </a:r>
+            <a:r>
+              <a:rPr lang="en-NL" sz="1400" dirty="0">
+                <a:solidFill>
+                  <a:schemeClr val="tx1"/>
+                </a:solidFill>
+              </a:rPr>
+              <a:t>,x</a:t>
+            </a:r>
+          </a:p>
+        </p:txBody>
+      </p:sp>
+      <p:sp>
+        <p:nvSpPr>
+          <p:cNvPr id="26" name="Oval 25">
+            <a:extLst>
+              <a:ext uri="{FF2B5EF4-FFF2-40B4-BE49-F238E27FC236}">
+                <a16:creationId xmlns:a16="http://schemas.microsoft.com/office/drawing/2014/main" id="{9C4C94B8-5F23-A619-8ACB-33D732166D73}"/>
+              </a:ext>
+            </a:extLst>
+          </p:cNvPr>
+          <p:cNvSpPr/>
+          <p:nvPr/>
+        </p:nvSpPr>
+        <p:spPr>
+          <a:xfrm>
+            <a:off x="5344744" y="3569974"/>
+            <a:ext cx="676570" cy="369332"/>
+          </a:xfrm>
+          <a:prstGeom prst="ellipse">
+            <a:avLst/>
+          </a:prstGeom>
+          <a:solidFill>
+            <a:schemeClr val="accent2">
+              <a:lumMod val="20000"/>
+              <a:lumOff val="80000"/>
+            </a:schemeClr>
+          </a:solidFill>
+          <a:ln>
+            <a:solidFill>
+              <a:schemeClr val="tx1"/>
+            </a:solidFill>
+          </a:ln>
+        </p:spPr>
+        <p:style>
+          <a:lnRef idx="2">
+            <a:schemeClr val="accent1">
+              <a:shade val="50000"/>
+            </a:schemeClr>
+          </a:lnRef>
+          <a:fillRef idx="1">
+            <a:schemeClr val="accent1"/>
+          </a:fillRef>
+          <a:effectRef idx="0">
+            <a:schemeClr val="accent1"/>
+          </a:effectRef>
+          <a:fontRef idx="minor">
+            <a:schemeClr val="lt1"/>
+          </a:fontRef>
+        </p:style>
+        <p:txBody>
+          <a:bodyPr rtlCol="0" anchor="ctr"/>
+          <a:lstStyle/>
+          <a:p>
+            <a:pPr algn="ctr"/>
+            <a:r>
+              <a:rPr lang="en-NL" sz="1400" dirty="0">
+                <a:solidFill>
+                  <a:schemeClr val="tx1"/>
+                </a:solidFill>
+              </a:rPr>
+              <a:t>s</a:t>
+            </a:r>
+            <a:r>
+              <a:rPr lang="en-NL" sz="1400" baseline="-25000" dirty="0">
+                <a:solidFill>
+                  <a:schemeClr val="tx1"/>
+                </a:solidFill>
+              </a:rPr>
+              <a:t>0</a:t>
+            </a:r>
+            <a:r>
+              <a:rPr lang="en-NL" sz="1400" dirty="0">
+                <a:solidFill>
+                  <a:schemeClr val="tx1"/>
+                </a:solidFill>
+              </a:rPr>
+              <a:t>,x</a:t>
+            </a:r>
+          </a:p>
+        </p:txBody>
+      </p:sp>
+      <p:sp>
+        <p:nvSpPr>
+          <p:cNvPr id="27" name="Oval 26">
+            <a:extLst>
+              <a:ext uri="{FF2B5EF4-FFF2-40B4-BE49-F238E27FC236}">
+                <a16:creationId xmlns:a16="http://schemas.microsoft.com/office/drawing/2014/main" id="{1488BFA5-72FB-B579-5492-57D059983862}"/>
+              </a:ext>
+            </a:extLst>
+          </p:cNvPr>
+          <p:cNvSpPr/>
+          <p:nvPr/>
+        </p:nvSpPr>
+        <p:spPr>
+          <a:xfrm>
+            <a:off x="6444726" y="3558822"/>
+            <a:ext cx="676570" cy="369332"/>
+          </a:xfrm>
+          <a:prstGeom prst="ellipse">
+            <a:avLst/>
+          </a:prstGeom>
+          <a:solidFill>
+            <a:schemeClr val="accent2">
+              <a:lumMod val="20000"/>
+              <a:lumOff val="80000"/>
+            </a:schemeClr>
+          </a:solidFill>
+          <a:ln>
+            <a:solidFill>
+              <a:schemeClr val="tx1"/>
+            </a:solidFill>
+          </a:ln>
+        </p:spPr>
+        <p:style>
+          <a:lnRef idx="2">
+            <a:schemeClr val="accent1">
+              <a:shade val="50000"/>
+            </a:schemeClr>
+          </a:lnRef>
+          <a:fillRef idx="1">
+            <a:schemeClr val="accent1"/>
+          </a:fillRef>
+          <a:effectRef idx="0">
+            <a:schemeClr val="accent1"/>
+          </a:effectRef>
+          <a:fontRef idx="minor">
+            <a:schemeClr val="lt1"/>
+          </a:fontRef>
+        </p:style>
+        <p:txBody>
+          <a:bodyPr rtlCol="0" anchor="ctr"/>
+          <a:lstStyle/>
+          <a:p>
+            <a:pPr algn="ctr"/>
+            <a:r>
+              <a:rPr lang="en-NL" sz="1400" dirty="0">
+                <a:solidFill>
+                  <a:schemeClr val="tx1"/>
+                </a:solidFill>
+              </a:rPr>
+              <a:t>s</a:t>
+            </a:r>
+            <a:r>
+              <a:rPr lang="en-NL" sz="1400" baseline="-25000" dirty="0">
+                <a:solidFill>
+                  <a:schemeClr val="tx1"/>
+                </a:solidFill>
+              </a:rPr>
+              <a:t>3</a:t>
+            </a:r>
+            <a:r>
+              <a:rPr lang="en-NL" sz="1400" dirty="0">
+                <a:solidFill>
+                  <a:schemeClr val="tx1"/>
+                </a:solidFill>
+              </a:rPr>
+              <a:t>,x</a:t>
+            </a:r>
+          </a:p>
+        </p:txBody>
+      </p:sp>
+      <p:cxnSp>
+        <p:nvCxnSpPr>
+          <p:cNvPr id="28" name="Straight Arrow Connector 27">
+            <a:extLst>
+              <a:ext uri="{FF2B5EF4-FFF2-40B4-BE49-F238E27FC236}">
+                <a16:creationId xmlns:a16="http://schemas.microsoft.com/office/drawing/2014/main" id="{B40C093A-E4E0-1D40-B75E-693A526B5638}"/>
+              </a:ext>
+            </a:extLst>
+          </p:cNvPr>
+          <p:cNvCxnSpPr>
+            <a:cxnSpLocks/>
+            <a:stCxn id="23" idx="3"/>
+            <a:endCxn id="25" idx="0"/>
+          </p:cNvCxnSpPr>
+          <p:nvPr/>
+        </p:nvCxnSpPr>
+        <p:spPr>
+          <a:xfrm flipH="1">
+            <a:off x="4844005" y="3243574"/>
+            <a:ext cx="599820" cy="326400"/>
+          </a:xfrm>
+          <a:prstGeom prst="straightConnector1">
+            <a:avLst/>
+          </a:prstGeom>
+          <a:ln w="12700">
+            <a:solidFill>
+              <a:schemeClr val="tx1"/>
+            </a:solidFill>
+            <a:tailEnd type="triangle"/>
+          </a:ln>
+        </p:spPr>
+        <p:style>
+          <a:lnRef idx="1">
+            <a:schemeClr val="accent1"/>
+          </a:lnRef>
+          <a:fillRef idx="0">
+            <a:schemeClr val="accent1"/>
+          </a:fillRef>
+          <a:effectRef idx="0">
+            <a:schemeClr val="accent1"/>
+          </a:effectRef>
+          <a:fontRef idx="minor">
+            <a:schemeClr val="tx1"/>
+          </a:fontRef>
+        </p:style>
+      </p:cxnSp>
+      <p:cxnSp>
+        <p:nvCxnSpPr>
+          <p:cNvPr id="29" name="Straight Arrow Connector 28">
+            <a:extLst>
+              <a:ext uri="{FF2B5EF4-FFF2-40B4-BE49-F238E27FC236}">
+                <a16:creationId xmlns:a16="http://schemas.microsoft.com/office/drawing/2014/main" id="{FB97F2AE-7AD6-A1C1-6A8B-FC1C1A627AB4}"/>
+              </a:ext>
+            </a:extLst>
+          </p:cNvPr>
+          <p:cNvCxnSpPr>
+            <a:cxnSpLocks/>
+            <a:stCxn id="25" idx="6"/>
+            <a:endCxn id="26" idx="2"/>
+          </p:cNvCxnSpPr>
+          <p:nvPr/>
+        </p:nvCxnSpPr>
+        <p:spPr>
+          <a:xfrm>
+            <a:off x="5182290" y="3754640"/>
+            <a:ext cx="162454" cy="0"/>
+          </a:xfrm>
+          <a:prstGeom prst="straightConnector1">
+            <a:avLst/>
+          </a:prstGeom>
+          <a:ln w="12700">
+            <a:solidFill>
+              <a:schemeClr val="tx1"/>
+            </a:solidFill>
+            <a:tailEnd type="triangle"/>
+          </a:ln>
+        </p:spPr>
+        <p:style>
+          <a:lnRef idx="1">
+            <a:schemeClr val="accent1"/>
+          </a:lnRef>
+          <a:fillRef idx="0">
+            <a:schemeClr val="accent1"/>
+          </a:fillRef>
+          <a:effectRef idx="0">
+            <a:schemeClr val="accent1"/>
+          </a:effectRef>
+          <a:fontRef idx="minor">
+            <a:schemeClr val="tx1"/>
+          </a:fontRef>
+        </p:style>
+      </p:cxnSp>
+      <p:cxnSp>
+        <p:nvCxnSpPr>
+          <p:cNvPr id="30" name="Straight Arrow Connector 29">
+            <a:extLst>
+              <a:ext uri="{FF2B5EF4-FFF2-40B4-BE49-F238E27FC236}">
+                <a16:creationId xmlns:a16="http://schemas.microsoft.com/office/drawing/2014/main" id="{D2FE3D32-E918-B9E1-082D-B55E8CE521EC}"/>
+              </a:ext>
+            </a:extLst>
+          </p:cNvPr>
+          <p:cNvCxnSpPr>
+            <a:cxnSpLocks/>
+            <a:stCxn id="26" idx="0"/>
+            <a:endCxn id="23" idx="4"/>
+          </p:cNvCxnSpPr>
+          <p:nvPr/>
+        </p:nvCxnSpPr>
+        <p:spPr>
+          <a:xfrm flipV="1">
+            <a:off x="5683029" y="3297661"/>
+            <a:ext cx="0" cy="272313"/>
+          </a:xfrm>
+          <a:prstGeom prst="straightConnector1">
+            <a:avLst/>
+          </a:prstGeom>
+          <a:ln w="12700">
+            <a:solidFill>
+              <a:schemeClr val="tx1"/>
+            </a:solidFill>
+            <a:tailEnd type="triangle"/>
+          </a:ln>
+        </p:spPr>
+        <p:style>
+          <a:lnRef idx="1">
+            <a:schemeClr val="accent1"/>
+          </a:lnRef>
+          <a:fillRef idx="0">
+            <a:schemeClr val="accent1"/>
+          </a:fillRef>
+          <a:effectRef idx="0">
+            <a:schemeClr val="accent1"/>
+          </a:effectRef>
+          <a:fontRef idx="minor">
+            <a:schemeClr val="tx1"/>
+          </a:fontRef>
+        </p:style>
+      </p:cxnSp>
+      <p:cxnSp>
+        <p:nvCxnSpPr>
+          <p:cNvPr id="32" name="Straight Arrow Connector 31">
+            <a:extLst>
+              <a:ext uri="{FF2B5EF4-FFF2-40B4-BE49-F238E27FC236}">
+                <a16:creationId xmlns:a16="http://schemas.microsoft.com/office/drawing/2014/main" id="{5F6E3FFD-D022-8132-A52A-BDDB4C1B7959}"/>
+              </a:ext>
+            </a:extLst>
+          </p:cNvPr>
+          <p:cNvCxnSpPr>
+            <a:cxnSpLocks/>
+            <a:stCxn id="26" idx="6"/>
+            <a:endCxn id="27" idx="2"/>
+          </p:cNvCxnSpPr>
+          <p:nvPr/>
+        </p:nvCxnSpPr>
+        <p:spPr>
+          <a:xfrm flipV="1">
+            <a:off x="6021314" y="3743488"/>
+            <a:ext cx="423412" cy="11152"/>
+          </a:xfrm>
+          <a:prstGeom prst="straightConnector1">
+            <a:avLst/>
+          </a:prstGeom>
+          <a:ln w="12700">
+            <a:solidFill>
+              <a:schemeClr val="tx1"/>
+            </a:solidFill>
+            <a:tailEnd type="triangle"/>
+          </a:ln>
+        </p:spPr>
+        <p:style>
+          <a:lnRef idx="1">
+            <a:schemeClr val="accent1"/>
+          </a:lnRef>
+          <a:fillRef idx="0">
+            <a:schemeClr val="accent1"/>
+          </a:fillRef>
+          <a:effectRef idx="0">
+            <a:schemeClr val="accent1"/>
+          </a:effectRef>
+          <a:fontRef idx="minor">
+            <a:schemeClr val="tx1"/>
+          </a:fontRef>
+        </p:style>
+      </p:cxnSp>
+      <p:cxnSp>
+        <p:nvCxnSpPr>
+          <p:cNvPr id="37" name="Curved Connector 36">
+            <a:extLst>
+              <a:ext uri="{FF2B5EF4-FFF2-40B4-BE49-F238E27FC236}">
+                <a16:creationId xmlns:a16="http://schemas.microsoft.com/office/drawing/2014/main" id="{C50DE66A-8B41-4E06-C7DB-44A43EC40141}"/>
+              </a:ext>
+            </a:extLst>
+          </p:cNvPr>
+          <p:cNvCxnSpPr>
+            <a:cxnSpLocks/>
+            <a:stCxn id="27" idx="6"/>
+            <a:endCxn id="27" idx="0"/>
+          </p:cNvCxnSpPr>
+          <p:nvPr/>
+        </p:nvCxnSpPr>
+        <p:spPr>
+          <a:xfrm flipH="1" flipV="1">
+            <a:off x="6783011" y="3558822"/>
+            <a:ext cx="338285" cy="184666"/>
+          </a:xfrm>
+          <a:prstGeom prst="curvedConnector4">
+            <a:avLst>
+              <a:gd name="adj1" fmla="val -67576"/>
+              <a:gd name="adj2" fmla="val 223791"/>
+            </a:avLst>
+          </a:prstGeom>
+          <a:ln w="12700">
+            <a:solidFill>
+              <a:schemeClr val="tx1"/>
+            </a:solidFill>
+            <a:tailEnd type="triangle"/>
+          </a:ln>
+        </p:spPr>
+        <p:style>
+          <a:lnRef idx="1">
+            <a:schemeClr val="accent1"/>
+          </a:lnRef>
+          <a:fillRef idx="0">
+            <a:schemeClr val="accent1"/>
+          </a:fillRef>
+          <a:effectRef idx="0">
+            <a:schemeClr val="accent1"/>
+          </a:effectRef>
+          <a:fontRef idx="minor">
+            <a:schemeClr val="tx1"/>
+          </a:fontRef>
+        </p:style>
+      </p:cxnSp>
+      <p:cxnSp>
+        <p:nvCxnSpPr>
+          <p:cNvPr id="46" name="Curved Connector 45">
+            <a:extLst>
+              <a:ext uri="{FF2B5EF4-FFF2-40B4-BE49-F238E27FC236}">
+                <a16:creationId xmlns:a16="http://schemas.microsoft.com/office/drawing/2014/main" id="{F35F5270-C8FD-5737-04FE-7373DCC4CE07}"/>
+              </a:ext>
+            </a:extLst>
+          </p:cNvPr>
+          <p:cNvCxnSpPr>
+            <a:cxnSpLocks/>
+            <a:stCxn id="26" idx="6"/>
+            <a:endCxn id="26" idx="0"/>
+          </p:cNvCxnSpPr>
+          <p:nvPr/>
+        </p:nvCxnSpPr>
+        <p:spPr>
+          <a:xfrm flipH="1" flipV="1">
+            <a:off x="5683029" y="3569974"/>
+            <a:ext cx="338285" cy="184666"/>
+          </a:xfrm>
+          <a:prstGeom prst="curvedConnector4">
+            <a:avLst>
+              <a:gd name="adj1" fmla="val -67576"/>
+              <a:gd name="adj2" fmla="val 223791"/>
+            </a:avLst>
+          </a:prstGeom>
+          <a:ln w="12700">
+            <a:solidFill>
+              <a:schemeClr val="tx1"/>
+            </a:solidFill>
+            <a:tailEnd type="triangle"/>
+          </a:ln>
+        </p:spPr>
+        <p:style>
+          <a:lnRef idx="1">
+            <a:schemeClr val="accent1"/>
+          </a:lnRef>
+          <a:fillRef idx="0">
+            <a:schemeClr val="accent1"/>
+          </a:fillRef>
+          <a:effectRef idx="0">
+            <a:schemeClr val="accent1"/>
+          </a:effectRef>
+          <a:fontRef idx="minor">
+            <a:schemeClr val="tx1"/>
+          </a:fontRef>
+        </p:style>
+      </p:cxnSp>
+      <p:sp>
+        <p:nvSpPr>
+          <p:cNvPr id="49" name="TextBox 48">
+            <a:extLst>
+              <a:ext uri="{FF2B5EF4-FFF2-40B4-BE49-F238E27FC236}">
+                <a16:creationId xmlns:a16="http://schemas.microsoft.com/office/drawing/2014/main" id="{2EB44A79-1E4B-C8EE-977F-FF44E3AAF00F}"/>
+              </a:ext>
+            </a:extLst>
+          </p:cNvPr>
+          <p:cNvSpPr txBox="1"/>
+          <p:nvPr/>
+        </p:nvSpPr>
+        <p:spPr>
+          <a:xfrm>
+            <a:off x="5038906" y="2701197"/>
+            <a:ext cx="809837" cy="261610"/>
+          </a:xfrm>
+          <a:prstGeom prst="rect">
+            <a:avLst/>
+          </a:prstGeom>
+          <a:noFill/>
+        </p:spPr>
+        <p:txBody>
+          <a:bodyPr wrap="none" rtlCol="0">
+            <a:spAutoFit/>
+          </a:bodyPr>
+          <a:lstStyle/>
+          <a:p>
+            <a:r>
+              <a:rPr lang="en-NL" sz="1050" dirty="0">
+                <a:highlight>
+                  <a:srgbClr val="00FF00"/>
+                </a:highlight>
+              </a:rPr>
+              <a:t>0.01</a:t>
+            </a:r>
+            <a:r>
+              <a:rPr lang="en-NL" sz="1050" dirty="0"/>
+              <a:t> {fail} </a:t>
+            </a:r>
+          </a:p>
+        </p:txBody>
+      </p:sp>
     </p:spTree>
     <p:extLst>
       <p:ext uri="{BB962C8B-B14F-4D97-AF65-F5344CB8AC3E}">

</xml_diff>